<commit_message>
Lomba Kaltara: tanpa rencana replikasi 2027; lembar naskah dubber
Atas arahan Kabag, rencana paket replikasi Kaltara 2027 tidak dimasukkan.
Slide 10 kini memuat pelembagaan (Surat Sekda Maret 2026, pengesahan SOP,
pengelola kedua). Lembar naskah pengisi suara ikut disimpan beserta
pembuatnya; adegan 14 disesuaikan. Pembuat paparan berganti ke .cjs karena
docs/lomba/build bertipe module.

Co-Authored-By: Claude Opus 5.5 <noreply@anthropic.com>
Claude-Session: https://claude.ai/code/session_01TchDZWsQsgeuq52sKmozd1
</commit_message>
<xml_diff>
--- a/docs/lomba/kaltara/Paparan-Prokopim-Hibot-Kaltara-2026.pptx
+++ b/docs/lomba/kaltara/Paparan-Prokopim-Hibot-Kaltara-2026.pptx
@@ -118,46 +118,46 @@
   <p:extLst>
     <p:ext uri="{521415D9-36F7-43E2-AB2F-B90AF26B5E84}">
       <p14:sectionLst xmlns:p14="http://schemas.microsoft.com/office/powerpoint/2010/main">
-        <p14:section name="Pembuka" id="{790f2907-bd8f-9ec7-d73e-56ca6e968c00}">
+        <p14:section name="Pembuka" id="{22e23a01-dc3f-a500-0301-6de06877ac60}">
           <p14:sldIdLst>
             <p14:sldId id="256"/>
           </p14:sldIdLst>
         </p14:section>
-        <p14:section name="Latar belakang" id="{d0f2726b-f8db-7a0e-9fed-56b3732f7329}">
+        <p14:section name="Latar belakang" id="{d878a4cc-f8ab-70cc-a1b1-8ef9d6989753}">
           <p14:sldIdLst>
             <p14:sldId id="257"/>
             <p14:sldId id="258"/>
           </p14:sldIdLst>
         </p14:section>
-        <p14:section name="Terobosan inovasi" id="{dff3e7c8-76b9-a962-f91f-efe1dba0caaf}">
+        <p14:section name="Terobosan inovasi" id="{321f04c2-e25d-d420-71bd-438eca57ce9f}">
           <p14:sldIdLst>
             <p14:sldId id="259"/>
             <p14:sldId id="260"/>
           </p14:sldIdLst>
         </p14:section>
-        <p14:section name="Manfaat inovasi" id="{100175e6-670a-fc1e-22ba-bb8866a67550}">
+        <p14:section name="Manfaat inovasi" id="{7131e0a7-4b06-dca8-a7ed-0f4c062ddfe5}">
           <p14:sldIdLst>
             <p14:sldId id="261"/>
             <p14:sldId id="262"/>
             <p14:sldId id="263"/>
           </p14:sldIdLst>
         </p14:section>
-        <p14:section name="Pemanfaatan sumber daya" id="{53bf8d2d-4813-2aca-d1ef-9c8ceb3c29e8}">
+        <p14:section name="Pemanfaatan sumber daya" id="{09e74e3a-96f5-a734-7ced-df6965d211fb}">
           <p14:sldIdLst>
             <p14:sldId id="264"/>
           </p14:sldIdLst>
         </p14:section>
-        <p14:section name="Diseminasi inovasi" id="{739e79be-5ba9-8c76-a527-95f1abf44cca}">
+        <p14:section name="Diseminasi inovasi" id="{0498b799-bd64-9c55-98f7-182bb429fb77}">
           <p14:sldIdLst>
             <p14:sldId id="265"/>
           </p14:sldIdLst>
         </p14:section>
-        <p14:section name="Kompatibilitas" id="{8db2e6f6-0ab7-6672-b5c0-21eb1dfac5ff}">
+        <p14:section name="Kompatibilitas" id="{70cd9dc0-2cbe-67df-1eb8-8fb526521f72}">
           <p14:sldIdLst>
             <p14:sldId id="266"/>
           </p14:sldIdLst>
         </p14:section>
-        <p14:section name="Penutup" id="{a1406237-c0aa-04f9-cf59-6eaf4ccb0803}">
+        <p14:section name="Penutup" id="{898f6651-3907-506b-d395-f8b8e24fad66}">
           <p14:sldIdLst>
             <p14:sldId id="267"/>
           </p14:sldIdLst>
@@ -654,7 +654,7 @@
           <a:p>
             <a:r>
               <a:rPr lang="en-US" dirty="0"/>
-              <a:t>Penyebarluasan: 21 akun di luar Bagian, kanal publik dipakai 66 dan 53 instansi, Tim Koordinasi lintas perangkat daerah. Paket replikasi untuk daerah di Kalimantan Utara Juli–Desember 2027; yang disesuaikan hanya nama jabatan, pengguna, dan tata naskah. (±30 detik)</a:t>
+              <a:t>Penyebarluasan: 21 akun di luar Bagian, kanal publik dipakai 66 dan 53 instansi, Tim Koordinasi lintas perangkat daerah. Bila daerah lain ingin memakai, yang disesuaikan hanya nama jabatan, pengguna, dan tata naskah. (±30 detik)</a:t>
             </a:r>
             <a:endParaRPr lang="en-US" dirty="0"/>
           </a:p>
@@ -1746,7 +1746,7 @@
       </p:sp>
       <p:pic>
         <p:nvPicPr>
-          <p:cNvPr id="5" name="Image 0" descr="/tmp/claude-0/-home-user-joyful-visuals/b7e05af7-82ac-5fa7-8dd0-336e0ff929be/scratchpad/paparan/aset/kaltara.png">    </p:cNvPr>
+          <p:cNvPr id="5" name="Image 0" descr="/home/user/joyful-visuals/docs/lomba/build/paparan/aset/kaltara.png">    </p:cNvPr>
           <p:cNvPicPr>
             <a:picLocks noChangeAspect="1"/>
           </p:cNvPicPr>
@@ -1770,7 +1770,7 @@
       </p:pic>
       <p:pic>
         <p:nvPicPr>
-          <p:cNvPr id="6" name="Image 1" descr="/tmp/claude-0/-home-user-joyful-visuals/b7e05af7-82ac-5fa7-8dd0-336e0ff929be/scratchpad/paparan/aset/tarakan.png">    </p:cNvPr>
+          <p:cNvPr id="6" name="Image 1" descr="/home/user/joyful-visuals/docs/lomba/build/paparan/aset/tarakan.png">    </p:cNvPr>
           <p:cNvPicPr>
             <a:picLocks noChangeAspect="1"/>
           </p:cNvPicPr>
@@ -2406,7 +2406,7 @@
       </p:sp>
       <p:pic>
         <p:nvPicPr>
-          <p:cNvPr id="3" name="Image 0" descr="/tmp/claude-0/-home-user-joyful-visuals/b7e05af7-82ac-5fa7-8dd0-336e0ff929be/scratchpad/paparan/aset/kaltara.png">    </p:cNvPr>
+          <p:cNvPr id="3" name="Image 0" descr="/home/user/joyful-visuals/docs/lomba/build/paparan/aset/kaltara.png">    </p:cNvPr>
           <p:cNvPicPr>
             <a:picLocks noChangeAspect="1"/>
           </p:cNvPicPr>
@@ -2430,7 +2430,7 @@
       </p:pic>
       <p:pic>
         <p:nvPicPr>
-          <p:cNvPr id="4" name="Image 1" descr="/tmp/claude-0/-home-user-joyful-visuals/b7e05af7-82ac-5fa7-8dd0-336e0ff929be/scratchpad/paparan/aset/tarakan.png">    </p:cNvPr>
+          <p:cNvPr id="4" name="Image 1" descr="/home/user/joyful-visuals/docs/lomba/build/paparan/aset/tarakan.png">    </p:cNvPr>
           <p:cNvPicPr>
             <a:picLocks noChangeAspect="1"/>
           </p:cNvPicPr>
@@ -2668,7 +2668,7 @@
       </p:sp>
       <p:pic>
         <p:nvPicPr>
-          <p:cNvPr id="10" name="Image 2" descr="/tmp/claude-0/-home-user-joyful-visuals/b7e05af7-82ac-5fa7-8dd0-336e0ff929be/scratchpad/paparan/aset/hp_walikota.jpg">    </p:cNvPr>
+          <p:cNvPr id="10" name="Image 2" descr="/home/user/joyful-visuals/docs/lomba/build/paparan/aset/hp_walikota.jpg">    </p:cNvPr>
           <p:cNvPicPr>
             <a:picLocks noChangeAspect="1"/>
           </p:cNvPicPr>
@@ -3365,7 +3365,7 @@
                   <a:schemeClr val="tx2"/>
                 </a:solidFill>
               </a:rPr>
-              <a:t>Peta jalan penyebarluasan</a:t>
+              <a:t>Pelembagaan dan rencana</a:t>
             </a:r>
             <a:endParaRPr lang="en-US" sz="1800" dirty="0"/>
           </a:p>
@@ -3403,6 +3403,139 @@
         <p:spPr>
           <a:xfrm>
             <a:off x="6446520" y="2240280"/>
+            <a:ext cx="384048" cy="384048"/>
+          </a:xfrm>
+          <a:prstGeom prst="ellipse">
+            <a:avLst/>
+          </a:prstGeom>
+          <a:solidFill>
+            <a:schemeClr val="accent1"/>
+          </a:solidFill>
+          <a:ln w="12700">
+            <a:solidFill>
+              <a:schemeClr val="accent1"/>
+            </a:solidFill>
+            <a:prstDash val="solid"/>
+          </a:ln>
+        </p:spPr>
+      </p:sp>
+      <p:sp>
+        <p:nvSpPr>
+          <p:cNvPr id="20" name="Text 18"/>
+          <p:cNvSpPr txBox="1"/>
+          <p:nvPr/>
+        </p:nvSpPr>
+        <p:spPr>
+          <a:xfrm>
+            <a:off x="6446520" y="2240280"/>
+            <a:ext cx="384048" cy="384048"/>
+          </a:xfrm>
+          <a:prstGeom prst="rect">
+            <a:avLst/>
+          </a:prstGeom>
+          <a:noFill/>
+          <a:ln/>
+        </p:spPr>
+        <p:txBody>
+          <a:bodyPr wrap="square" lIns="0" tIns="0" rIns="0" bIns="0" rtlCol="0" anchor="ctr"/>
+          <a:lstStyle/>
+          <a:p>
+            <a:pPr algn="ctr" indent="0" marL="0">
+              <a:buNone/>
+            </a:pPr>
+            <a:r>
+              <a:rPr lang="en-US" sz="1400" b="1" dirty="0">
+                <a:solidFill>
+                  <a:schemeClr val="tx2"/>
+                </a:solidFill>
+              </a:rPr>
+              <a:t>1</a:t>
+            </a:r>
+            <a:endParaRPr lang="en-US" sz="1400" dirty="0"/>
+          </a:p>
+        </p:txBody>
+      </p:sp>
+      <p:sp>
+        <p:nvSpPr>
+          <p:cNvPr id="21" name="Text 19"/>
+          <p:cNvSpPr txBox="1"/>
+          <p:nvPr/>
+        </p:nvSpPr>
+        <p:spPr>
+          <a:xfrm>
+            <a:off x="7040880" y="2221992"/>
+            <a:ext cx="4602175" cy="365760"/>
+          </a:xfrm>
+          <a:prstGeom prst="rect">
+            <a:avLst/>
+          </a:prstGeom>
+          <a:noFill/>
+          <a:ln/>
+        </p:spPr>
+        <p:txBody>
+          <a:bodyPr wrap="square" lIns="0" tIns="0" rIns="0" bIns="0" rtlCol="0" anchor="t"/>
+          <a:lstStyle/>
+          <a:p>
+            <a:pPr indent="0" marL="0">
+              <a:buNone/>
+            </a:pPr>
+            <a:r>
+              <a:rPr lang="en-US" sz="1500" b="1" dirty="0">
+                <a:solidFill>
+                  <a:schemeClr val="tx2"/>
+                </a:solidFill>
+              </a:rPr>
+              <a:t>Maret 2026</a:t>
+            </a:r>
+            <a:endParaRPr lang="en-US" sz="1500" dirty="0"/>
+          </a:p>
+        </p:txBody>
+      </p:sp>
+      <p:sp>
+        <p:nvSpPr>
+          <p:cNvPr id="22" name="Text 20"/>
+          <p:cNvSpPr txBox="1"/>
+          <p:nvPr/>
+        </p:nvSpPr>
+        <p:spPr>
+          <a:xfrm>
+            <a:off x="7040880" y="2587752"/>
+            <a:ext cx="4602175" cy="777240"/>
+          </a:xfrm>
+          <a:prstGeom prst="rect">
+            <a:avLst/>
+          </a:prstGeom>
+          <a:noFill/>
+          <a:ln/>
+        </p:spPr>
+        <p:txBody>
+          <a:bodyPr wrap="square" lIns="0" tIns="0" rIns="0" bIns="0" rtlCol="0" anchor="t"/>
+          <a:lstStyle/>
+          <a:p>
+            <a:pPr indent="0" marL="0">
+              <a:buNone/>
+            </a:pPr>
+            <a:r>
+              <a:rPr lang="en-US" sz="1400" dirty="0">
+                <a:solidFill>
+                  <a:schemeClr val="tx1"/>
+                </a:solidFill>
+              </a:rPr>
+              <a:t>Mulai digunakan; Surat Sekda 12 Maret 2026 memohon subdomain resmi prokopim.tarakankota.go.id</a:t>
+            </a:r>
+            <a:endParaRPr lang="en-US" sz="1400" dirty="0"/>
+          </a:p>
+        </p:txBody>
+      </p:sp>
+      <p:sp>
+        <p:nvSpPr>
+          <p:cNvPr id="23" name="Shape 21"/>
+          <p:cNvSpPr/>
+          <p:nvPr/>
+        </p:nvSpPr>
+        <p:spPr>
+          <a:xfrm>
+            <a:off x="6446520" y="3474720"/>
             <a:ext cx="384048" cy="384048"/>
           </a:xfrm>
           <a:prstGeom prst="ellipse">
@@ -3421,13 +3554,13 @@
       </p:sp>
       <p:sp>
         <p:nvSpPr>
-          <p:cNvPr id="20" name="Text 18"/>
-          <p:cNvSpPr txBox="1"/>
-          <p:nvPr/>
-        </p:nvSpPr>
-        <p:spPr>
-          <a:xfrm>
-            <a:off x="6446520" y="2240280"/>
+          <p:cNvPr id="24" name="Text 22"/>
+          <p:cNvSpPr txBox="1"/>
+          <p:nvPr/>
+        </p:nvSpPr>
+        <p:spPr>
+          <a:xfrm>
+            <a:off x="6446520" y="3474720"/>
             <a:ext cx="384048" cy="384048"/>
           </a:xfrm>
           <a:prstGeom prst="rect">
@@ -3449,7 +3582,7 @@
                   <a:schemeClr val="bg1"/>
                 </a:solidFill>
               </a:rPr>
-              <a:t>1</a:t>
+              <a:t>2</a:t>
             </a:r>
             <a:endParaRPr lang="en-US" sz="1400" dirty="0"/>
           </a:p>
@@ -3457,13 +3590,13 @@
       </p:sp>
       <p:sp>
         <p:nvSpPr>
-          <p:cNvPr id="21" name="Text 19"/>
-          <p:cNvSpPr txBox="1"/>
-          <p:nvPr/>
-        </p:nvSpPr>
-        <p:spPr>
-          <a:xfrm>
-            <a:off x="7040880" y="2221992"/>
+          <p:cNvPr id="25" name="Text 23"/>
+          <p:cNvSpPr txBox="1"/>
+          <p:nvPr/>
+        </p:nvSpPr>
+        <p:spPr>
+          <a:xfrm>
+            <a:off x="7040880" y="3456432"/>
             <a:ext cx="4602175" cy="365760"/>
           </a:xfrm>
           <a:prstGeom prst="rect">
@@ -3493,13 +3626,13 @@
       </p:sp>
       <p:sp>
         <p:nvSpPr>
-          <p:cNvPr id="22" name="Text 20"/>
-          <p:cNvSpPr txBox="1"/>
-          <p:nvPr/>
-        </p:nvSpPr>
-        <p:spPr>
-          <a:xfrm>
-            <a:off x="7040880" y="2587752"/>
+          <p:cNvPr id="26" name="Text 24"/>
+          <p:cNvSpPr txBox="1"/>
+          <p:nvPr/>
+        </p:nvSpPr>
+        <p:spPr>
+          <a:xfrm>
+            <a:off x="7040880" y="3822192"/>
             <a:ext cx="4602175" cy="777240"/>
           </a:xfrm>
           <a:prstGeom prst="rect">
@@ -3529,13 +3662,13 @@
       </p:sp>
       <p:sp>
         <p:nvSpPr>
-          <p:cNvPr id="23" name="Shape 21"/>
+          <p:cNvPr id="27" name="Shape 25"/>
           <p:cNvSpPr/>
           <p:nvPr/>
         </p:nvSpPr>
         <p:spPr>
           <a:xfrm>
-            <a:off x="6446520" y="3474720"/>
+            <a:off x="6446520" y="4709160"/>
             <a:ext cx="384048" cy="384048"/>
           </a:xfrm>
           <a:prstGeom prst="ellipse">
@@ -3554,116 +3687,8 @@
       </p:sp>
       <p:sp>
         <p:nvSpPr>
-          <p:cNvPr id="24" name="Text 22"/>
-          <p:cNvSpPr txBox="1"/>
-          <p:nvPr/>
-        </p:nvSpPr>
-        <p:spPr>
-          <a:xfrm>
-            <a:off x="6446520" y="3474720"/>
-            <a:ext cx="384048" cy="384048"/>
-          </a:xfrm>
-          <a:prstGeom prst="rect">
-            <a:avLst/>
-          </a:prstGeom>
-          <a:noFill/>
-          <a:ln/>
-        </p:spPr>
-        <p:txBody>
-          <a:bodyPr wrap="square" lIns="0" tIns="0" rIns="0" bIns="0" rtlCol="0" anchor="ctr"/>
-          <a:lstStyle/>
-          <a:p>
-            <a:pPr algn="ctr" indent="0" marL="0">
-              <a:buNone/>
-            </a:pPr>
-            <a:r>
-              <a:rPr lang="en-US" sz="1400" b="1" dirty="0">
-                <a:solidFill>
-                  <a:schemeClr val="bg1"/>
-                </a:solidFill>
-              </a:rPr>
-              <a:t>2</a:t>
-            </a:r>
-            <a:endParaRPr lang="en-US" sz="1400" dirty="0"/>
-          </a:p>
-        </p:txBody>
-      </p:sp>
-      <p:sp>
-        <p:nvSpPr>
-          <p:cNvPr id="25" name="Text 23"/>
-          <p:cNvSpPr txBox="1"/>
-          <p:nvPr/>
-        </p:nvSpPr>
-        <p:spPr>
-          <a:xfrm>
-            <a:off x="7040880" y="3456432"/>
-            <a:ext cx="4602175" cy="365760"/>
-          </a:xfrm>
-          <a:prstGeom prst="rect">
-            <a:avLst/>
-          </a:prstGeom>
-          <a:noFill/>
-          <a:ln/>
-        </p:spPr>
-        <p:txBody>
-          <a:bodyPr wrap="square" lIns="0" tIns="0" rIns="0" bIns="0" rtlCol="0" anchor="t"/>
-          <a:lstStyle/>
-          <a:p>
-            <a:pPr indent="0" marL="0">
-              <a:buNone/>
-            </a:pPr>
-            <a:r>
-              <a:rPr lang="en-US" sz="1500" b="1" dirty="0">
-                <a:solidFill>
-                  <a:schemeClr val="tx2"/>
-                </a:solidFill>
-              </a:rPr>
-              <a:t>Jan–Jun 2027</a:t>
-            </a:r>
-            <a:endParaRPr lang="en-US" sz="1500" dirty="0"/>
-          </a:p>
-        </p:txBody>
-      </p:sp>
-      <p:sp>
-        <p:nvSpPr>
-          <p:cNvPr id="26" name="Text 24"/>
-          <p:cNvSpPr txBox="1"/>
-          <p:nvPr/>
-        </p:nvSpPr>
-        <p:spPr>
-          <a:xfrm>
-            <a:off x="7040880" y="3822192"/>
-            <a:ext cx="4602175" cy="777240"/>
-          </a:xfrm>
-          <a:prstGeom prst="rect">
-            <a:avLst/>
-          </a:prstGeom>
-          <a:noFill/>
-          <a:ln/>
-        </p:spPr>
-        <p:txBody>
-          <a:bodyPr wrap="square" lIns="0" tIns="0" rIns="0" bIns="0" rtlCol="0" anchor="t"/>
-          <a:lstStyle/>
-          <a:p>
-            <a:pPr indent="0" marL="0">
-              <a:buNone/>
-            </a:pPr>
-            <a:r>
-              <a:rPr lang="en-US" sz="1400" dirty="0">
-                <a:solidFill>
-                  <a:schemeClr val="tx1"/>
-                </a:solidFill>
-              </a:rPr>
-              <a:t>Pendampingan pengelola kedua; dokumentasi teknis</a:t>
-            </a:r>
-            <a:endParaRPr lang="en-US" sz="1400" dirty="0"/>
-          </a:p>
-        </p:txBody>
-      </p:sp>
-      <p:sp>
-        <p:nvSpPr>
-          <p:cNvPr id="27" name="Shape 25"/>
-          <p:cNvSpPr/>
+          <p:cNvPr id="28" name="Text 26"/>
+          <p:cNvSpPr txBox="1"/>
           <p:nvPr/>
         </p:nvSpPr>
         <p:spPr>
@@ -3671,31 +3696,6 @@
             <a:off x="6446520" y="4709160"/>
             <a:ext cx="384048" cy="384048"/>
           </a:xfrm>
-          <a:prstGeom prst="ellipse">
-            <a:avLst/>
-          </a:prstGeom>
-          <a:solidFill>
-            <a:schemeClr val="accent1"/>
-          </a:solidFill>
-          <a:ln w="12700">
-            <a:solidFill>
-              <a:schemeClr val="accent1"/>
-            </a:solidFill>
-            <a:prstDash val="solid"/>
-          </a:ln>
-        </p:spPr>
-      </p:sp>
-      <p:sp>
-        <p:nvSpPr>
-          <p:cNvPr id="28" name="Text 26"/>
-          <p:cNvSpPr txBox="1"/>
-          <p:nvPr/>
-        </p:nvSpPr>
-        <p:spPr>
-          <a:xfrm>
-            <a:off x="6446520" y="4709160"/>
-            <a:ext cx="384048" cy="384048"/>
-          </a:xfrm>
           <a:prstGeom prst="rect">
             <a:avLst/>
           </a:prstGeom>
@@ -3712,7 +3712,7 @@
             <a:r>
               <a:rPr lang="en-US" sz="1400" b="1" dirty="0">
                 <a:solidFill>
-                  <a:schemeClr val="tx2"/>
+                  <a:schemeClr val="bg1"/>
                 </a:solidFill>
               </a:rPr>
               <a:t>3</a:t>
@@ -3751,7 +3751,7 @@
                   <a:schemeClr val="tx2"/>
                 </a:solidFill>
               </a:rPr>
-              <a:t>Jul–Des 2027</a:t>
+              <a:t>Jan–Jun 2027</a:t>
             </a:r>
             <a:endParaRPr lang="en-US" sz="1500" dirty="0"/>
           </a:p>
@@ -3787,7 +3787,7 @@
                   <a:schemeClr val="tx1"/>
                 </a:solidFill>
               </a:rPr>
-              <a:t>Paket replikasi: Pemprov Kaltara, Bulungan, Malinau, Nunukan, Tana Tidung, Sekretariat DPRD</a:t>
+              <a:t>Pendampingan pengelola kedua; dokumentasi teknis</a:t>
             </a:r>
             <a:endParaRPr lang="en-US" sz="1400" dirty="0"/>
           </a:p>
@@ -4509,7 +4509,7 @@
       </p:sp>
       <p:pic>
         <p:nvPicPr>
-          <p:cNvPr id="3" name="Image 0" descr="/tmp/claude-0/-home-user-joyful-visuals/b7e05af7-82ac-5fa7-8dd0-336e0ff929be/scratchpad/paparan/aset/kaltara.png">    </p:cNvPr>
+          <p:cNvPr id="3" name="Image 0" descr="/home/user/joyful-visuals/docs/lomba/build/paparan/aset/kaltara.png">    </p:cNvPr>
           <p:cNvPicPr>
             <a:picLocks noChangeAspect="1"/>
           </p:cNvPicPr>
@@ -4533,7 +4533,7 @@
       </p:pic>
       <p:pic>
         <p:nvPicPr>
-          <p:cNvPr id="4" name="Image 1" descr="/tmp/claude-0/-home-user-joyful-visuals/b7e05af7-82ac-5fa7-8dd0-336e0ff929be/scratchpad/paparan/aset/tarakan.png">    </p:cNvPr>
+          <p:cNvPr id="4" name="Image 1" descr="/home/user/joyful-visuals/docs/lomba/build/paparan/aset/tarakan.png">    </p:cNvPr>
           <p:cNvPicPr>
             <a:picLocks noChangeAspect="1"/>
           </p:cNvPicPr>
@@ -4729,7 +4729,7 @@
       </p:sp>
       <p:pic>
         <p:nvPicPr>
-          <p:cNvPr id="9" name="Image 2" descr="/tmp/claude-0/-home-user-joyful-visuals/b7e05af7-82ac-5fa7-8dd0-336e0ff929be/scratchpad/paparan/aset/qr.png">    </p:cNvPr>
+          <p:cNvPr id="9" name="Image 2" descr="/home/user/joyful-visuals/docs/lomba/build/paparan/aset/qr.png">    </p:cNvPr>
           <p:cNvPicPr>
             <a:picLocks noChangeAspect="1"/>
           </p:cNvPicPr>
@@ -12318,7 +12318,7 @@
       </p:sp>
       <p:pic>
         <p:nvPicPr>
-          <p:cNvPr id="4" name="Image 0" descr="/tmp/claude-0/-home-user-joyful-visuals/b7e05af7-82ac-5fa7-8dd0-336e0ff929be/scratchpad/paparan/aset/hp_walikota.jpg">    </p:cNvPr>
+          <p:cNvPr id="4" name="Image 0" descr="/home/user/joyful-visuals/docs/lomba/build/paparan/aset/hp_walikota.jpg">    </p:cNvPr>
           <p:cNvPicPr>
             <a:picLocks noChangeAspect="1"/>
           </p:cNvPicPr>

</xml_diff>

<commit_message>
Lomba Kaltara: siap direplikasi sesuai kebutuhan; jadwal SOP baru
Slide 10 menegaskan inovasi siap direplikasi sesuai kebutuhan, dan
jadwal SOP menjadi revisi serta pengesahan November 2026–Februari 2027
mengikuti nomenklatur baru.

Co-Authored-By: Claude Opus 5.5 <noreply@anthropic.com>
Claude-Session: https://claude.ai/code/session_01TchDZWsQsgeuq52sKmozd1
</commit_message>
<xml_diff>
--- a/docs/lomba/kaltara/Paparan-Prokopim-Hibot-Kaltara-2026.pptx
+++ b/docs/lomba/kaltara/Paparan-Prokopim-Hibot-Kaltara-2026.pptx
@@ -118,46 +118,46 @@
   <p:extLst>
     <p:ext uri="{521415D9-36F7-43E2-AB2F-B90AF26B5E84}">
       <p14:sectionLst xmlns:p14="http://schemas.microsoft.com/office/powerpoint/2010/main">
-        <p14:section name="Pembuka" id="{22e23a01-dc3f-a500-0301-6de06877ac60}">
+        <p14:section name="Pembuka" id="{559a64d0-fb67-86d2-ac61-865376edba9f}">
           <p14:sldIdLst>
             <p14:sldId id="256"/>
           </p14:sldIdLst>
         </p14:section>
-        <p14:section name="Latar belakang" id="{d878a4cc-f8ab-70cc-a1b1-8ef9d6989753}">
+        <p14:section name="Latar belakang" id="{a11319f2-8b51-37fe-f57c-d6fd24bd001d}">
           <p14:sldIdLst>
             <p14:sldId id="257"/>
             <p14:sldId id="258"/>
           </p14:sldIdLst>
         </p14:section>
-        <p14:section name="Terobosan inovasi" id="{321f04c2-e25d-d420-71bd-438eca57ce9f}">
+        <p14:section name="Terobosan inovasi" id="{f05bc113-5172-0a74-4058-e5a4cd92a985}">
           <p14:sldIdLst>
             <p14:sldId id="259"/>
             <p14:sldId id="260"/>
           </p14:sldIdLst>
         </p14:section>
-        <p14:section name="Manfaat inovasi" id="{7131e0a7-4b06-dca8-a7ed-0f4c062ddfe5}">
+        <p14:section name="Manfaat inovasi" id="{efe4d48e-0036-a0cf-047f-edc74deb6047}">
           <p14:sldIdLst>
             <p14:sldId id="261"/>
             <p14:sldId id="262"/>
             <p14:sldId id="263"/>
           </p14:sldIdLst>
         </p14:section>
-        <p14:section name="Pemanfaatan sumber daya" id="{09e74e3a-96f5-a734-7ced-df6965d211fb}">
+        <p14:section name="Pemanfaatan sumber daya" id="{7af7bd23-9c7c-2d7c-d94e-1e0a2b157457}">
           <p14:sldIdLst>
             <p14:sldId id="264"/>
           </p14:sldIdLst>
         </p14:section>
-        <p14:section name="Diseminasi inovasi" id="{0498b799-bd64-9c55-98f7-182bb429fb77}">
+        <p14:section name="Diseminasi inovasi" id="{284e0802-24e1-75af-c342-6a40cc4ac2cd}">
           <p14:sldIdLst>
             <p14:sldId id="265"/>
           </p14:sldIdLst>
         </p14:section>
-        <p14:section name="Kompatibilitas" id="{70cd9dc0-2cbe-67df-1eb8-8fb526521f72}">
+        <p14:section name="Kompatibilitas" id="{ca31231f-8011-5838-89f8-79257619cbd6}">
           <p14:sldIdLst>
             <p14:sldId id="266"/>
           </p14:sldIdLst>
         </p14:section>
-        <p14:section name="Penutup" id="{898f6651-3907-506b-d395-f8b8e24fad66}">
+        <p14:section name="Penutup" id="{3d3cf0f4-3207-31c2-7373-c81f7a45f994}">
           <p14:sldIdLst>
             <p14:sldId id="267"/>
           </p14:sldIdLst>
@@ -654,7 +654,7 @@
           <a:p>
             <a:r>
               <a:rPr lang="en-US" dirty="0"/>
-              <a:t>Penyebarluasan: 21 akun di luar Bagian, kanal publik dipakai 66 dan 53 instansi, Tim Koordinasi lintas perangkat daerah. Bila daerah lain ingin memakai, yang disesuaikan hanya nama jabatan, pengguna, dan tata naskah. (±30 detik)</a:t>
+              <a:t>Penyebarluasan: 21 akun di luar Bagian, kanal publik dipakai 66 dan 53 instansi, Tim Koordinasi lintas perangkat daerah. Inovasi ini siap direplikasi sesuai kebutuhan: yang disesuaikan hanya nama jabatan, pengguna, dan tata naskah. SOP direvisi dan disahkan November 2026–Februari 2027 mengikuti nomenklatur baru. (±30 detik)</a:t>
             </a:r>
             <a:endParaRPr lang="en-US" dirty="0"/>
           </a:p>
@@ -3324,12 +3324,23 @@
               <a:buNone/>
             </a:pPr>
             <a:r>
-              <a:rPr lang="en-US" sz="1400" i="1" dirty="0">
+              <a:rPr lang="en-US" sz="1400" b="1" dirty="0">
                 <a:solidFill>
                   <a:schemeClr val="tx2"/>
                 </a:solidFill>
               </a:rPr>
-              <a:t>“Yang dibutuhkan daerah lain hanya peramban, kuota gratis, dan 11 SOP yang siap diadaptasi.”</a:t>
+              <a:t>Siap direplikasi sesuai kebutuhan: </a:t>
+            </a:r>
+            <a:pPr indent="0" marL="0">
+              <a:buNone/>
+            </a:pPr>
+            <a:r>
+              <a:rPr lang="en-US" sz="1400" dirty="0">
+                <a:solidFill>
+                  <a:schemeClr val="tx2"/>
+                </a:solidFill>
+              </a:rPr>
+              <a:t>cukup peramban, kuota tanpa biaya, dan 11 SOP yang dapat diadaptasi.</a:t>
             </a:r>
             <a:endParaRPr lang="en-US" sz="1400" dirty="0"/>
           </a:p>
@@ -3618,7 +3629,7 @@
                   <a:schemeClr val="tx2"/>
                 </a:solidFill>
               </a:rPr>
-              <a:t>Okt–Des 2026</a:t>
+              <a:t>Nov 2026–Feb 2027</a:t>
             </a:r>
             <a:endParaRPr lang="en-US" sz="1500" dirty="0"/>
           </a:p>
@@ -3654,7 +3665,7 @@
                   <a:schemeClr val="tx1"/>
                 </a:solidFill>
               </a:rPr>
-              <a:t>Pengesahan 11 SOP oleh Sekretaris Daerah</a:t>
+              <a:t>Revisi dan pengesahan 11 SOP mengikuti nomenklatur baru</a:t>
             </a:r>
             <a:endParaRPr lang="en-US" sz="1400" dirty="0"/>
           </a:p>

</xml_diff>

<commit_message>
Lomba Kaltara: jadwal pengesahan SOP kembali sesuai proposal
Okt–Des 2026, pengesahan 11 SOP oleh Sekretaris Daerah, disesuaikan dengan
nomenklatur baru.

Co-Authored-By: Claude Opus 5.5 <noreply@anthropic.com>
Claude-Session: https://claude.ai/code/session_01TchDZWsQsgeuq52sKmozd1
</commit_message>
<xml_diff>
--- a/docs/lomba/kaltara/Paparan-Prokopim-Hibot-Kaltara-2026.pptx
+++ b/docs/lomba/kaltara/Paparan-Prokopim-Hibot-Kaltara-2026.pptx
@@ -118,46 +118,46 @@
   <p:extLst>
     <p:ext uri="{521415D9-36F7-43E2-AB2F-B90AF26B5E84}">
       <p14:sectionLst xmlns:p14="http://schemas.microsoft.com/office/powerpoint/2010/main">
-        <p14:section name="Pembuka" id="{559a64d0-fb67-86d2-ac61-865376edba9f}">
+        <p14:section name="Pembuka" id="{a7f5a0ec-6837-07e4-2c19-2eff62272460}">
           <p14:sldIdLst>
             <p14:sldId id="256"/>
           </p14:sldIdLst>
         </p14:section>
-        <p14:section name="Latar belakang" id="{a11319f2-8b51-37fe-f57c-d6fd24bd001d}">
+        <p14:section name="Latar belakang" id="{feefa21b-1544-ac6d-e85f-b45f497f0a07}">
           <p14:sldIdLst>
             <p14:sldId id="257"/>
             <p14:sldId id="258"/>
           </p14:sldIdLst>
         </p14:section>
-        <p14:section name="Terobosan inovasi" id="{f05bc113-5172-0a74-4058-e5a4cd92a985}">
+        <p14:section name="Terobosan inovasi" id="{da13d5c0-accb-d1fa-7a98-126527f0bb14}">
           <p14:sldIdLst>
             <p14:sldId id="259"/>
             <p14:sldId id="260"/>
           </p14:sldIdLst>
         </p14:section>
-        <p14:section name="Manfaat inovasi" id="{efe4d48e-0036-a0cf-047f-edc74deb6047}">
+        <p14:section name="Manfaat inovasi" id="{3fa812f3-f54a-9168-21e3-6c2e6c094214}">
           <p14:sldIdLst>
             <p14:sldId id="261"/>
             <p14:sldId id="262"/>
             <p14:sldId id="263"/>
           </p14:sldIdLst>
         </p14:section>
-        <p14:section name="Pemanfaatan sumber daya" id="{7af7bd23-9c7c-2d7c-d94e-1e0a2b157457}">
+        <p14:section name="Pemanfaatan sumber daya" id="{6da53843-2e89-7215-4242-44c878bb78b9}">
           <p14:sldIdLst>
             <p14:sldId id="264"/>
           </p14:sldIdLst>
         </p14:section>
-        <p14:section name="Diseminasi inovasi" id="{284e0802-24e1-75af-c342-6a40cc4ac2cd}">
+        <p14:section name="Diseminasi inovasi" id="{6b08a7ad-a53a-e7ed-6788-1e135736286e}">
           <p14:sldIdLst>
             <p14:sldId id="265"/>
           </p14:sldIdLst>
         </p14:section>
-        <p14:section name="Kompatibilitas" id="{ca31231f-8011-5838-89f8-79257619cbd6}">
+        <p14:section name="Kompatibilitas" id="{8fcb96ae-8322-45cc-1bf9-f3e186a41a93}">
           <p14:sldIdLst>
             <p14:sldId id="266"/>
           </p14:sldIdLst>
         </p14:section>
-        <p14:section name="Penutup" id="{3d3cf0f4-3207-31c2-7373-c81f7a45f994}">
+        <p14:section name="Penutup" id="{808a7742-1736-4137-5844-7044ec0dc658}">
           <p14:sldIdLst>
             <p14:sldId id="267"/>
           </p14:sldIdLst>
@@ -654,7 +654,7 @@
           <a:p>
             <a:r>
               <a:rPr lang="en-US" dirty="0"/>
-              <a:t>Penyebarluasan: 21 akun di luar Bagian, kanal publik dipakai 66 dan 53 instansi, Tim Koordinasi lintas perangkat daerah. Inovasi ini siap direplikasi sesuai kebutuhan: yang disesuaikan hanya nama jabatan, pengguna, dan tata naskah. SOP direvisi dan disahkan November 2026–Februari 2027 mengikuti nomenklatur baru. (±30 detik)</a:t>
+              <a:t>Penyebarluasan: 21 akun di luar Bagian, kanal publik dipakai 66 dan 53 instansi, Tim Koordinasi lintas perangkat daerah. Inovasi ini siap direplikasi sesuai kebutuhan: yang disesuaikan hanya nama jabatan, pengguna, dan tata naskah. Sebelas SOP disahkan Sekretaris Daerah pada Oktober–Desember 2026, disesuaikan dengan nomenklatur baru. (±30 detik)</a:t>
             </a:r>
             <a:endParaRPr lang="en-US" dirty="0"/>
           </a:p>
@@ -3629,7 +3629,7 @@
                   <a:schemeClr val="tx2"/>
                 </a:solidFill>
               </a:rPr>
-              <a:t>Nov 2026–Feb 2027</a:t>
+              <a:t>Okt–Des 2026</a:t>
             </a:r>
             <a:endParaRPr lang="en-US" sz="1500" dirty="0"/>
           </a:p>
@@ -3665,7 +3665,7 @@
                   <a:schemeClr val="tx1"/>
                 </a:solidFill>
               </a:rPr>
-              <a:t>Revisi dan pengesahan 11 SOP mengikuti nomenklatur baru</a:t>
+              <a:t>Pengesahan 11 SOP oleh Sekretaris Daerah, disesuaikan dengan nomenklatur baru</a:t>
             </a:r>
             <a:endParaRPr lang="en-US" sz="1400" dirty="0"/>
           </a:p>

</xml_diff>

<commit_message>
Lomba Kaltara: logo Pemprov Kaltara resolusi tinggi
Logo dari Kabag (960×1286, latar transparan) menggantikan logo 135×180 dari
berkas TM; salinan aslinya disimpan untuk sampul video.

Co-Authored-By: Claude Opus 5.5 <noreply@anthropic.com>
Claude-Session: https://claude.ai/code/session_01TchDZWsQsgeuq52sKmozd1
</commit_message>
<xml_diff>
--- a/docs/lomba/kaltara/Paparan-Prokopim-Hibot-Kaltara-2026.pptx
+++ b/docs/lomba/kaltara/Paparan-Prokopim-Hibot-Kaltara-2026.pptx
@@ -118,46 +118,46 @@
   <p:extLst>
     <p:ext uri="{521415D9-36F7-43E2-AB2F-B90AF26B5E84}">
       <p14:sectionLst xmlns:p14="http://schemas.microsoft.com/office/powerpoint/2010/main">
-        <p14:section name="Pembuka" id="{a7f5a0ec-6837-07e4-2c19-2eff62272460}">
+        <p14:section name="Pembuka" id="{4d6c23b1-bd77-fa89-6c04-98e6433aef1a}">
           <p14:sldIdLst>
             <p14:sldId id="256"/>
           </p14:sldIdLst>
         </p14:section>
-        <p14:section name="Latar belakang" id="{feefa21b-1544-ac6d-e85f-b45f497f0a07}">
+        <p14:section name="Latar belakang" id="{e5237b37-481c-574a-edd1-84621c26c9e7}">
           <p14:sldIdLst>
             <p14:sldId id="257"/>
             <p14:sldId id="258"/>
           </p14:sldIdLst>
         </p14:section>
-        <p14:section name="Terobosan inovasi" id="{da13d5c0-accb-d1fa-7a98-126527f0bb14}">
+        <p14:section name="Terobosan inovasi" id="{bf79fef1-ab47-c466-393b-cc2bb5af02c0}">
           <p14:sldIdLst>
             <p14:sldId id="259"/>
             <p14:sldId id="260"/>
           </p14:sldIdLst>
         </p14:section>
-        <p14:section name="Manfaat inovasi" id="{3fa812f3-f54a-9168-21e3-6c2e6c094214}">
+        <p14:section name="Manfaat inovasi" id="{152c5317-d97e-2949-17c3-a50e6d3de6f7}">
           <p14:sldIdLst>
             <p14:sldId id="261"/>
             <p14:sldId id="262"/>
             <p14:sldId id="263"/>
           </p14:sldIdLst>
         </p14:section>
-        <p14:section name="Pemanfaatan sumber daya" id="{6da53843-2e89-7215-4242-44c878bb78b9}">
+        <p14:section name="Pemanfaatan sumber daya" id="{94313a47-39ca-e969-e741-619b601e36e7}">
           <p14:sldIdLst>
             <p14:sldId id="264"/>
           </p14:sldIdLst>
         </p14:section>
-        <p14:section name="Diseminasi inovasi" id="{6b08a7ad-a53a-e7ed-6788-1e135736286e}">
+        <p14:section name="Diseminasi inovasi" id="{4274d43f-a364-79d5-ed33-e329e4f94fb0}">
           <p14:sldIdLst>
             <p14:sldId id="265"/>
           </p14:sldIdLst>
         </p14:section>
-        <p14:section name="Kompatibilitas" id="{8fcb96ae-8322-45cc-1bf9-f3e186a41a93}">
+        <p14:section name="Kompatibilitas" id="{d3327bc3-74d4-61cb-cfc3-db686193c8be}">
           <p14:sldIdLst>
             <p14:sldId id="266"/>
           </p14:sldIdLst>
         </p14:section>
-        <p14:section name="Penutup" id="{808a7742-1736-4137-5844-7044ec0dc658}">
+        <p14:section name="Penutup" id="{908073f2-2039-002d-30cc-ef722c204daa}">
           <p14:sldIdLst>
             <p14:sldId id="267"/>
           </p14:sldIdLst>

</xml_diff>

<commit_message>
Lomba Kaltara: video v2 (zoom aplikasi, suara otomatis), slide 13 perubahan sejak proposal
- Rekaman aplikasi memakai jendela lebih kecil dan bingkai lebih besar
  (isi ±1,4× lebih besar); takarir adegan ponsel digeser ke ruang kanan.
- Suara pemandu otomatis (espeak-ng + MBROLA) per kalimat dari lembar naskah
  dubber; takarir diselaraskan dengan waktu ucapan. Berkas rekaman dubber
  bernama narasi/adegan-NN.* menggantikannya otomatis.
- Paparan: slide 13 (cadangan) menjelaskan yang berubah sejak proposal.

Co-Authored-By: Claude Opus 5.5 <noreply@anthropic.com>
Claude-Session: https://claude.ai/code/session_01TchDZWsQsgeuq52sKmozd1
</commit_message>
<xml_diff>
--- a/docs/lomba/kaltara/Paparan-Prokopim-Hibot-Kaltara-2026.pptx
+++ b/docs/lomba/kaltara/Paparan-Prokopim-Hibot-Kaltara-2026.pptx
@@ -17,9 +17,10 @@
     <p:sldId id="265" r:id="rId11"/>
     <p:sldId id="266" r:id="rId12"/>
     <p:sldId id="267" r:id="rId13"/>
+    <p:sldId id="268" r:id="rId14"/>
   </p:sldIdLst>
   <p:notesMasterIdLst>
-    <p:notesMasterId r:id="rId14"/>
+    <p:notesMasterId r:id="rId15"/>
   </p:notesMasterIdLst>
   <p:sldSz cx="12192000" cy="6858000"/>
   <p:notesSz cx="6858000" cy="12192000"/>
@@ -118,48 +119,53 @@
   <p:extLst>
     <p:ext uri="{521415D9-36F7-43E2-AB2F-B90AF26B5E84}">
       <p14:sectionLst xmlns:p14="http://schemas.microsoft.com/office/powerpoint/2010/main">
-        <p14:section name="Pembuka" id="{4d6c23b1-bd77-fa89-6c04-98e6433aef1a}">
+        <p14:section name="Pembuka" id="{4a1f4674-0f06-5155-fe52-de5983b02e9d}">
           <p14:sldIdLst>
             <p14:sldId id="256"/>
           </p14:sldIdLst>
         </p14:section>
-        <p14:section name="Latar belakang" id="{e5237b37-481c-574a-edd1-84621c26c9e7}">
+        <p14:section name="Latar belakang" id="{8a18d7b6-e033-97fe-6215-dd09803ccd1c}">
           <p14:sldIdLst>
             <p14:sldId id="257"/>
             <p14:sldId id="258"/>
           </p14:sldIdLst>
         </p14:section>
-        <p14:section name="Terobosan inovasi" id="{bf79fef1-ab47-c466-393b-cc2bb5af02c0}">
+        <p14:section name="Terobosan inovasi" id="{9465ad2b-e496-3cc7-302e-8c61622f7f03}">
           <p14:sldIdLst>
             <p14:sldId id="259"/>
             <p14:sldId id="260"/>
           </p14:sldIdLst>
         </p14:section>
-        <p14:section name="Manfaat inovasi" id="{152c5317-d97e-2949-17c3-a50e6d3de6f7}">
+        <p14:section name="Manfaat inovasi" id="{2bba3e50-c573-7e3a-68f1-6df7dcd5fae2}">
           <p14:sldIdLst>
             <p14:sldId id="261"/>
             <p14:sldId id="262"/>
             <p14:sldId id="263"/>
           </p14:sldIdLst>
         </p14:section>
-        <p14:section name="Pemanfaatan sumber daya" id="{94313a47-39ca-e969-e741-619b601e36e7}">
+        <p14:section name="Pemanfaatan sumber daya" id="{29940c43-31ab-dc4e-3ec0-6e3e84a0e53b}">
           <p14:sldIdLst>
             <p14:sldId id="264"/>
           </p14:sldIdLst>
         </p14:section>
-        <p14:section name="Diseminasi inovasi" id="{4274d43f-a364-79d5-ed33-e329e4f94fb0}">
+        <p14:section name="Diseminasi inovasi" id="{35503bf9-7a1f-2e08-e7d5-eaecb04ee407}">
           <p14:sldIdLst>
             <p14:sldId id="265"/>
           </p14:sldIdLst>
         </p14:section>
-        <p14:section name="Kompatibilitas" id="{d3327bc3-74d4-61cb-cfc3-db686193c8be}">
+        <p14:section name="Kompatibilitas" id="{79118008-65ed-8dce-181d-1cb3db135b11}">
           <p14:sldIdLst>
             <p14:sldId id="266"/>
           </p14:sldIdLst>
         </p14:section>
-        <p14:section name="Penutup" id="{908073f2-2039-002d-30cc-ef722c204daa}">
+        <p14:section name="Penutup" id="{69fdfff4-a073-f354-12fb-5cee1e15d8d4}">
           <p14:sldIdLst>
             <p14:sldId id="267"/>
+          </p14:sldIdLst>
+        </p14:section>
+        <p14:section name="Cadangan penjelasan" id="{bad290bf-dc3b-ba97-c20d-ababf701f44f}">
+          <p14:sldIdLst>
+            <p14:sldId id="268"/>
           </p14:sldIdLst>
         </p14:section>
       </p14:sectionLst>
@@ -854,6 +860,94 @@
             <a:fld id="{F7021451-1387-4CA6-816F-3879F97B5CBC}" type="slidenum">
               <a:rPr lang="en-US"/>
               <a:t>12</a:t>
+            </a:fld>
+            <a:endParaRPr lang="en-US"/>
+          </a:p>
+        </p:txBody>
+      </p:sp>
+    </p:spTree>
+    <p:extLst>
+      <p:ext uri="{BB962C8B-B14F-4D97-AF65-F5344CB8AC3E}">
+        <p14:creationId xmlns:p14="http://schemas.microsoft.com/office/powerpoint/2010/main" val="1024086991"/>
+      </p:ext>
+    </p:extLst>
+  </p:cSld>
+  <p:clrMapOvr>
+    <a:masterClrMapping/>
+  </p:clrMapOvr>
+</p:notes>
+</file>
+
+<file path=ppt/notesSlides/notesSlide13.xml><?xml version="1.0" encoding="utf-8"?>
+<p:notes xmlns:a="http://schemas.openxmlformats.org/drawingml/2006/main" xmlns:r="http://schemas.openxmlformats.org/officeDocument/2006/relationships" xmlns:p="http://schemas.openxmlformats.org/presentationml/2006/main">
+  <p:cSld>
+    <p:spTree>
+      <p:nvGrpSpPr>
+        <p:cNvPr id="1" name=""/>
+        <p:cNvGrpSpPr/>
+        <p:nvPr/>
+      </p:nvGrpSpPr>
+      <p:grpSpPr>
+        <a:xfrm>
+          <a:off x="0" y="0"/>
+          <a:ext cx="0" cy="0"/>
+          <a:chOff x="0" y="0"/>
+          <a:chExt cx="0" cy="0"/>
+        </a:xfrm>
+      </p:grpSpPr>
+      <p:sp>
+        <p:nvSpPr>
+          <p:cNvPr id="2" name="Slide Image Placeholder 1"/>
+          <p:cNvSpPr>
+            <a:spLocks noGrp="1" noRot="1" noChangeAspect="1"/>
+          </p:cNvSpPr>
+          <p:nvPr>
+            <p:ph type="sldImg"/>
+          </p:nvPr>
+        </p:nvSpPr>
+        <p:spPr/>
+      </p:sp>
+      <p:sp>
+        <p:nvSpPr>
+          <p:cNvPr id="3" name="Notes Placeholder 2"/>
+          <p:cNvSpPr>
+            <a:spLocks noGrp="1"/>
+          </p:cNvSpPr>
+          <p:nvPr>
+            <p:ph type="body" idx="1"/>
+          </p:nvPr>
+        </p:nvSpPr>
+        <p:spPr/>
+        <p:txBody>
+          <a:bodyPr/>
+          <a:lstStyle/>
+          <a:p>
+            <a:r>
+              <a:rPr lang="en-US" dirty="0"/>
+              <a:t>Gunakan hanya bila juri menanyakan perbedaan dengan proposal. Jujur dan ringkas: pengingat lima kali sehari dirampingkan menjadi tiga waktu berdasarkan data pemakaian; WhatsApp hanya untuk acara hari ini atau besok; notifikasi tamu berjenjang; Monitor WA; masuk dengan sidik jari dan Google; jam acara berzona. Semua pembaruan berangkat dari kendala pengguna dan tanpa belanja pengadaan.</a:t>
+            </a:r>
+            <a:endParaRPr lang="en-US" dirty="0"/>
+          </a:p>
+        </p:txBody>
+      </p:sp>
+      <p:sp>
+        <p:nvSpPr>
+          <p:cNvPr id="4" name="Slide Number Placeholder 3"/>
+          <p:cNvSpPr>
+            <a:spLocks noGrp="1"/>
+          </p:cNvSpPr>
+          <p:nvPr>
+            <p:ph type="sldNum" sz="quarter" idx="10"/>
+          </p:nvPr>
+        </p:nvSpPr>
+        <p:spPr/>
+        <p:txBody>
+          <a:bodyPr/>
+          <a:lstStyle/>
+          <a:p>
+            <a:fld id="{F7021451-1387-4CA6-816F-3879F97B5CBC}" type="slidenum">
+              <a:rPr lang="en-US"/>
+              <a:t>13</a:t>
             </a:fld>
             <a:endParaRPr lang="en-US"/>
           </a:p>
@@ -4934,6 +5028,1222 @@
             <a:fld id="{F7021451-1387-4CA6-816F-3879F97B5CBC}" type="slidenum">
               <a:rPr b="0" lang="en-US"/>
               <a:t>12</a:t>
+            </a:fld>
+            <a:endParaRPr lang="en-US"/>
+          </a:p>
+        </p:txBody>
+      </p:sp>
+    </p:spTree>
+  </p:cSld>
+  <p:clrMapOvr>
+    <a:masterClrMapping/>
+  </p:clrMapOvr>
+</p:sld>
+</file>
+
+<file path=ppt/slides/slide13.xml><?xml version="1.0" encoding="utf-8"?>
+<p:sld xmlns:a="http://schemas.openxmlformats.org/drawingml/2006/main" xmlns:r="http://schemas.openxmlformats.org/officeDocument/2006/relationships" xmlns:p="http://schemas.openxmlformats.org/presentationml/2006/main">
+  <p:cSld name="Slide 13">
+    <p:spTree>
+      <p:nvGrpSpPr>
+        <p:cNvPr id="1" name=""/>
+        <p:cNvGrpSpPr/>
+        <p:nvPr/>
+      </p:nvGrpSpPr>
+      <p:grpSpPr>
+        <a:xfrm>
+          <a:off x="0" y="0"/>
+          <a:ext cx="0" cy="0"/>
+          <a:chOff x="0" y="0"/>
+          <a:chExt cx="0" cy="0"/>
+        </a:xfrm>
+      </p:grpSpPr>
+      <p:sp>
+        <p:nvSpPr>
+          <p:cNvPr id="2" name="Text 0"/>
+          <p:cNvSpPr/>
+          <p:nvPr>
+            <p:ph idx="100" type="body" hasCustomPrompt="1"/>
+          </p:nvPr>
+        </p:nvSpPr>
+        <p:spPr>
+          <a:xfrm>
+            <a:off x="548640" y="292608"/>
+            <a:ext cx="8229600" cy="292608"/>
+          </a:xfrm>
+          <a:prstGeom prst="rect">
+            <a:avLst/>
+          </a:prstGeom>
+          <a:noFill/>
+          <a:ln/>
+        </p:spPr>
+        <p:txBody>
+          <a:bodyPr wrap="square" lIns="0" tIns="0" rIns="0" bIns="0" rtlCol="0" anchor="ctr"/>
+          <a:lstStyle/>
+          <a:p>
+            <a:pPr indent="0" marL="0">
+              <a:buNone/>
+            </a:pPr>
+            <a:r>
+              <a:rPr lang="en-US" sz="1200" b="1" spc="200" kern="0" dirty="0">
+                <a:solidFill>
+                  <a:schemeClr val="accent5"/>
+                </a:solidFill>
+              </a:rPr>
+              <a:t>CADANGAN PENJELASAN  ·  JIKA DITANYA</a:t>
+            </a:r>
+            <a:endParaRPr lang="en-US" sz="1200" dirty="0"/>
+          </a:p>
+        </p:txBody>
+      </p:sp>
+      <p:sp>
+        <p:nvSpPr>
+          <p:cNvPr id="3" name="Text 0"/>
+          <p:cNvSpPr/>
+          <p:nvPr>
+            <p:ph idx="101" type="title" hasCustomPrompt="1"/>
+          </p:nvPr>
+        </p:nvSpPr>
+        <p:spPr>
+          <a:xfrm>
+            <a:off x="548640" y="603504"/>
+            <a:ext cx="11094415" cy="777240"/>
+          </a:xfrm>
+          <a:prstGeom prst="rect">
+            <a:avLst/>
+          </a:prstGeom>
+          <a:noFill/>
+          <a:ln/>
+        </p:spPr>
+        <p:txBody>
+          <a:bodyPr wrap="square" lIns="0" tIns="0" rIns="0" bIns="0" rtlCol="0" anchor="t"/>
+          <a:lstStyle/>
+          <a:p>
+            <a:pPr algn="l" indent="0" marL="0">
+              <a:buNone/>
+            </a:pPr>
+            <a:r>
+              <a:rPr lang="en-US" sz="2800" b="1" dirty="0">
+                <a:solidFill>
+                  <a:schemeClr val="tx2"/>
+                </a:solidFill>
+              </a:rPr>
+              <a:t>Sejak proposal, inovasi ini terus disempurnakan</a:t>
+            </a:r>
+            <a:endParaRPr lang="en-US" sz="2800" dirty="0"/>
+          </a:p>
+        </p:txBody>
+      </p:sp>
+      <p:sp>
+        <p:nvSpPr>
+          <p:cNvPr id="4" name="Text 2"/>
+          <p:cNvSpPr txBox="1"/>
+          <p:nvPr/>
+        </p:nvSpPr>
+        <p:spPr>
+          <a:xfrm>
+            <a:off x="548640" y="1371600"/>
+            <a:ext cx="11094415" cy="365760"/>
+          </a:xfrm>
+          <a:prstGeom prst="rect">
+            <a:avLst/>
+          </a:prstGeom>
+          <a:noFill/>
+          <a:ln/>
+        </p:spPr>
+        <p:txBody>
+          <a:bodyPr wrap="square" lIns="0" tIns="0" rIns="0" bIns="0" rtlCol="0" anchor="t"/>
+          <a:lstStyle/>
+          <a:p>
+            <a:pPr indent="0" marL="0">
+              <a:buNone/>
+            </a:pPr>
+            <a:r>
+              <a:rPr lang="en-US" sz="1300" dirty="0">
+                <a:solidFill>
+                  <a:schemeClr val="accent5"/>
+                </a:solidFill>
+              </a:rPr>
+              <a:t>Proposal memuat keadaan per 24 September 2026. Pembaruan Oktober 2026 berikut berangkat dari pemakaian dan masukan pengguna.</a:t>
+            </a:r>
+            <a:endParaRPr lang="en-US" sz="1300" dirty="0"/>
+          </a:p>
+        </p:txBody>
+      </p:sp>
+      <p:sp>
+        <p:nvSpPr>
+          <p:cNvPr id="5" name="baru1"/>
+          <p:cNvSpPr/>
+          <p:nvPr/>
+        </p:nvSpPr>
+        <p:spPr>
+          <a:xfrm>
+            <a:off x="548640" y="1783080"/>
+            <a:ext cx="3545738" cy="1828800"/>
+          </a:xfrm>
+          <a:prstGeom prst="roundRect">
+            <a:avLst>
+              <a:gd name="adj" fmla="val 6000"/>
+            </a:avLst>
+          </a:prstGeom>
+          <a:solidFill>
+            <a:schemeClr val="bg2"/>
+          </a:solidFill>
+          <a:ln w="9525">
+            <a:solidFill>
+              <a:schemeClr val="bg2"/>
+            </a:solidFill>
+            <a:prstDash val="solid"/>
+          </a:ln>
+        </p:spPr>
+      </p:sp>
+      <p:sp>
+        <p:nvSpPr>
+          <p:cNvPr id="6" name="Shape 4"/>
+          <p:cNvSpPr/>
+          <p:nvPr/>
+        </p:nvSpPr>
+        <p:spPr>
+          <a:xfrm>
+            <a:off x="731520" y="1947672"/>
+            <a:ext cx="365760" cy="365760"/>
+          </a:xfrm>
+          <a:prstGeom prst="ellipse">
+            <a:avLst/>
+          </a:prstGeom>
+          <a:solidFill>
+            <a:schemeClr val="tx2"/>
+          </a:solidFill>
+          <a:ln w="12700">
+            <a:solidFill>
+              <a:schemeClr val="tx2"/>
+            </a:solidFill>
+            <a:prstDash val="solid"/>
+          </a:ln>
+        </p:spPr>
+      </p:sp>
+      <p:sp>
+        <p:nvSpPr>
+          <p:cNvPr id="7" name="Text 5"/>
+          <p:cNvSpPr txBox="1"/>
+          <p:nvPr/>
+        </p:nvSpPr>
+        <p:spPr>
+          <a:xfrm>
+            <a:off x="731520" y="1947672"/>
+            <a:ext cx="365760" cy="365760"/>
+          </a:xfrm>
+          <a:prstGeom prst="rect">
+            <a:avLst/>
+          </a:prstGeom>
+          <a:noFill/>
+          <a:ln/>
+        </p:spPr>
+        <p:txBody>
+          <a:bodyPr wrap="square" lIns="0" tIns="0" rIns="0" bIns="0" rtlCol="0" anchor="ctr"/>
+          <a:lstStyle/>
+          <a:p>
+            <a:pPr algn="ctr" indent="0" marL="0">
+              <a:buNone/>
+            </a:pPr>
+            <a:r>
+              <a:rPr lang="en-US" sz="1400" b="1" dirty="0">
+                <a:solidFill>
+                  <a:schemeClr val="accent1"/>
+                </a:solidFill>
+              </a:rPr>
+              <a:t>1</a:t>
+            </a:r>
+            <a:endParaRPr lang="en-US" sz="1400" dirty="0"/>
+          </a:p>
+        </p:txBody>
+      </p:sp>
+      <p:sp>
+        <p:nvSpPr>
+          <p:cNvPr id="8" name="Text 6"/>
+          <p:cNvSpPr txBox="1"/>
+          <p:nvPr/>
+        </p:nvSpPr>
+        <p:spPr>
+          <a:xfrm>
+            <a:off x="1234440" y="1947672"/>
+            <a:ext cx="2677058" cy="365760"/>
+          </a:xfrm>
+          <a:prstGeom prst="rect">
+            <a:avLst/>
+          </a:prstGeom>
+          <a:noFill/>
+          <a:ln/>
+        </p:spPr>
+        <p:txBody>
+          <a:bodyPr wrap="square" lIns="0" tIns="0" rIns="0" bIns="0" rtlCol="0" anchor="ctr"/>
+          <a:lstStyle/>
+          <a:p>
+            <a:pPr indent="0" marL="0">
+              <a:buNone/>
+            </a:pPr>
+            <a:r>
+              <a:rPr lang="en-US" sz="1500" b="1" dirty="0">
+                <a:solidFill>
+                  <a:schemeClr val="tx2"/>
+                </a:solidFill>
+              </a:rPr>
+              <a:t>Pengingat dirampingkan</a:t>
+            </a:r>
+            <a:endParaRPr lang="en-US" sz="1500" dirty="0"/>
+          </a:p>
+        </p:txBody>
+      </p:sp>
+      <p:sp>
+        <p:nvSpPr>
+          <p:cNvPr id="9" name="Text 7"/>
+          <p:cNvSpPr txBox="1"/>
+          <p:nvPr/>
+        </p:nvSpPr>
+        <p:spPr>
+          <a:xfrm>
+            <a:off x="731520" y="2404872"/>
+            <a:ext cx="3179978" cy="1143000"/>
+          </a:xfrm>
+          <a:prstGeom prst="rect">
+            <a:avLst/>
+          </a:prstGeom>
+          <a:noFill/>
+          <a:ln/>
+        </p:spPr>
+        <p:txBody>
+          <a:bodyPr wrap="square" lIns="0" tIns="0" rIns="0" bIns="0" rtlCol="0" anchor="t"/>
+          <a:lstStyle/>
+          <a:p>
+            <a:pPr indent="0" marL="0">
+              <a:buNone/>
+            </a:pPr>
+            <a:r>
+              <a:rPr lang="en-US" sz="1200" dirty="0">
+                <a:solidFill>
+                  <a:schemeClr val="tx1"/>
+                </a:solidFill>
+              </a:rPr>
+              <a:t>Proposal: lima kali sehari. Kini tiga waktu (06.30, 07.30, 16.00) ditambah kabar seketika, berdasarkan data pemakaian agar pesan tidak berulang.</a:t>
+            </a:r>
+            <a:endParaRPr lang="en-US" sz="1200" dirty="0"/>
+          </a:p>
+        </p:txBody>
+      </p:sp>
+      <p:sp>
+        <p:nvSpPr>
+          <p:cNvPr id="10" name="baru2"/>
+          <p:cNvSpPr/>
+          <p:nvPr/>
+        </p:nvSpPr>
+        <p:spPr>
+          <a:xfrm>
+            <a:off x="4322978" y="1783080"/>
+            <a:ext cx="3545738" cy="1828800"/>
+          </a:xfrm>
+          <a:prstGeom prst="roundRect">
+            <a:avLst>
+              <a:gd name="adj" fmla="val 6000"/>
+            </a:avLst>
+          </a:prstGeom>
+          <a:solidFill>
+            <a:schemeClr val="bg2"/>
+          </a:solidFill>
+          <a:ln w="9525">
+            <a:solidFill>
+              <a:schemeClr val="bg2"/>
+            </a:solidFill>
+            <a:prstDash val="solid"/>
+          </a:ln>
+        </p:spPr>
+      </p:sp>
+      <p:sp>
+        <p:nvSpPr>
+          <p:cNvPr id="11" name="Shape 9"/>
+          <p:cNvSpPr/>
+          <p:nvPr/>
+        </p:nvSpPr>
+        <p:spPr>
+          <a:xfrm>
+            <a:off x="4505858" y="1947672"/>
+            <a:ext cx="365760" cy="365760"/>
+          </a:xfrm>
+          <a:prstGeom prst="ellipse">
+            <a:avLst/>
+          </a:prstGeom>
+          <a:solidFill>
+            <a:schemeClr val="tx2"/>
+          </a:solidFill>
+          <a:ln w="12700">
+            <a:solidFill>
+              <a:schemeClr val="tx2"/>
+            </a:solidFill>
+            <a:prstDash val="solid"/>
+          </a:ln>
+        </p:spPr>
+      </p:sp>
+      <p:sp>
+        <p:nvSpPr>
+          <p:cNvPr id="12" name="Text 10"/>
+          <p:cNvSpPr txBox="1"/>
+          <p:nvPr/>
+        </p:nvSpPr>
+        <p:spPr>
+          <a:xfrm>
+            <a:off x="4505858" y="1947672"/>
+            <a:ext cx="365760" cy="365760"/>
+          </a:xfrm>
+          <a:prstGeom prst="rect">
+            <a:avLst/>
+          </a:prstGeom>
+          <a:noFill/>
+          <a:ln/>
+        </p:spPr>
+        <p:txBody>
+          <a:bodyPr wrap="square" lIns="0" tIns="0" rIns="0" bIns="0" rtlCol="0" anchor="ctr"/>
+          <a:lstStyle/>
+          <a:p>
+            <a:pPr algn="ctr" indent="0" marL="0">
+              <a:buNone/>
+            </a:pPr>
+            <a:r>
+              <a:rPr lang="en-US" sz="1400" b="1" dirty="0">
+                <a:solidFill>
+                  <a:schemeClr val="accent1"/>
+                </a:solidFill>
+              </a:rPr>
+              <a:t>2</a:t>
+            </a:r>
+            <a:endParaRPr lang="en-US" sz="1400" dirty="0"/>
+          </a:p>
+        </p:txBody>
+      </p:sp>
+      <p:sp>
+        <p:nvSpPr>
+          <p:cNvPr id="13" name="Text 11"/>
+          <p:cNvSpPr txBox="1"/>
+          <p:nvPr/>
+        </p:nvSpPr>
+        <p:spPr>
+          <a:xfrm>
+            <a:off x="5008778" y="1947672"/>
+            <a:ext cx="2677058" cy="365760"/>
+          </a:xfrm>
+          <a:prstGeom prst="rect">
+            <a:avLst/>
+          </a:prstGeom>
+          <a:noFill/>
+          <a:ln/>
+        </p:spPr>
+        <p:txBody>
+          <a:bodyPr wrap="square" lIns="0" tIns="0" rIns="0" bIns="0" rtlCol="0" anchor="ctr"/>
+          <a:lstStyle/>
+          <a:p>
+            <a:pPr indent="0" marL="0">
+              <a:buNone/>
+            </a:pPr>
+            <a:r>
+              <a:rPr lang="en-US" sz="1500" b="1" dirty="0">
+                <a:solidFill>
+                  <a:schemeClr val="tx2"/>
+                </a:solidFill>
+              </a:rPr>
+              <a:t>WhatsApp hanya yang perlu</a:t>
+            </a:r>
+            <a:endParaRPr lang="en-US" sz="1500" dirty="0"/>
+          </a:p>
+        </p:txBody>
+      </p:sp>
+      <p:sp>
+        <p:nvSpPr>
+          <p:cNvPr id="14" name="Text 12"/>
+          <p:cNvSpPr txBox="1"/>
+          <p:nvPr/>
+        </p:nvSpPr>
+        <p:spPr>
+          <a:xfrm>
+            <a:off x="4505858" y="2404872"/>
+            <a:ext cx="3179978" cy="1143000"/>
+          </a:xfrm>
+          <a:prstGeom prst="rect">
+            <a:avLst/>
+          </a:prstGeom>
+          <a:noFill/>
+          <a:ln/>
+        </p:spPr>
+        <p:txBody>
+          <a:bodyPr wrap="square" lIns="0" tIns="0" rIns="0" bIns="0" rtlCol="0" anchor="t"/>
+          <a:lstStyle/>
+          <a:p>
+            <a:pPr indent="0" marL="0">
+              <a:buNone/>
+            </a:pPr>
+            <a:r>
+              <a:rPr lang="en-US" sz="1200" dirty="0">
+                <a:solidFill>
+                  <a:schemeClr val="tx1"/>
+                </a:solidFill>
+              </a:rPr>
+              <a:t>Pesan WhatsApp hanya untuk acara hari ini atau besok; selebihnya lewat notifikasi aplikasi, sehingga tidak ada pesan penting yang tenggelam.</a:t>
+            </a:r>
+            <a:endParaRPr lang="en-US" sz="1200" dirty="0"/>
+          </a:p>
+        </p:txBody>
+      </p:sp>
+      <p:sp>
+        <p:nvSpPr>
+          <p:cNvPr id="15" name="baru3"/>
+          <p:cNvSpPr/>
+          <p:nvPr/>
+        </p:nvSpPr>
+        <p:spPr>
+          <a:xfrm>
+            <a:off x="8097317" y="1783080"/>
+            <a:ext cx="3545738" cy="1828800"/>
+          </a:xfrm>
+          <a:prstGeom prst="roundRect">
+            <a:avLst>
+              <a:gd name="adj" fmla="val 6000"/>
+            </a:avLst>
+          </a:prstGeom>
+          <a:solidFill>
+            <a:schemeClr val="bg2"/>
+          </a:solidFill>
+          <a:ln w="9525">
+            <a:solidFill>
+              <a:schemeClr val="bg2"/>
+            </a:solidFill>
+            <a:prstDash val="solid"/>
+          </a:ln>
+        </p:spPr>
+      </p:sp>
+      <p:sp>
+        <p:nvSpPr>
+          <p:cNvPr id="16" name="Shape 14"/>
+          <p:cNvSpPr/>
+          <p:nvPr/>
+        </p:nvSpPr>
+        <p:spPr>
+          <a:xfrm>
+            <a:off x="8280197" y="1947672"/>
+            <a:ext cx="365760" cy="365760"/>
+          </a:xfrm>
+          <a:prstGeom prst="ellipse">
+            <a:avLst/>
+          </a:prstGeom>
+          <a:solidFill>
+            <a:schemeClr val="tx2"/>
+          </a:solidFill>
+          <a:ln w="12700">
+            <a:solidFill>
+              <a:schemeClr val="tx2"/>
+            </a:solidFill>
+            <a:prstDash val="solid"/>
+          </a:ln>
+        </p:spPr>
+      </p:sp>
+      <p:sp>
+        <p:nvSpPr>
+          <p:cNvPr id="17" name="Text 15"/>
+          <p:cNvSpPr txBox="1"/>
+          <p:nvPr/>
+        </p:nvSpPr>
+        <p:spPr>
+          <a:xfrm>
+            <a:off x="8280197" y="1947672"/>
+            <a:ext cx="365760" cy="365760"/>
+          </a:xfrm>
+          <a:prstGeom prst="rect">
+            <a:avLst/>
+          </a:prstGeom>
+          <a:noFill/>
+          <a:ln/>
+        </p:spPr>
+        <p:txBody>
+          <a:bodyPr wrap="square" lIns="0" tIns="0" rIns="0" bIns="0" rtlCol="0" anchor="ctr"/>
+          <a:lstStyle/>
+          <a:p>
+            <a:pPr algn="ctr" indent="0" marL="0">
+              <a:buNone/>
+            </a:pPr>
+            <a:r>
+              <a:rPr lang="en-US" sz="1400" b="1" dirty="0">
+                <a:solidFill>
+                  <a:schemeClr val="accent1"/>
+                </a:solidFill>
+              </a:rPr>
+              <a:t>3</a:t>
+            </a:r>
+            <a:endParaRPr lang="en-US" sz="1400" dirty="0"/>
+          </a:p>
+        </p:txBody>
+      </p:sp>
+      <p:sp>
+        <p:nvSpPr>
+          <p:cNvPr id="18" name="Text 16"/>
+          <p:cNvSpPr txBox="1"/>
+          <p:nvPr/>
+        </p:nvSpPr>
+        <p:spPr>
+          <a:xfrm>
+            <a:off x="8783117" y="1947672"/>
+            <a:ext cx="2677058" cy="365760"/>
+          </a:xfrm>
+          <a:prstGeom prst="rect">
+            <a:avLst/>
+          </a:prstGeom>
+          <a:noFill/>
+          <a:ln/>
+        </p:spPr>
+        <p:txBody>
+          <a:bodyPr wrap="square" lIns="0" tIns="0" rIns="0" bIns="0" rtlCol="0" anchor="ctr"/>
+          <a:lstStyle/>
+          <a:p>
+            <a:pPr indent="0" marL="0">
+              <a:buNone/>
+            </a:pPr>
+            <a:r>
+              <a:rPr lang="en-US" sz="1500" b="1" dirty="0">
+                <a:solidFill>
+                  <a:schemeClr val="tx2"/>
+                </a:solidFill>
+              </a:rPr>
+              <a:t>Pemberitahuan tamu berjenjang</a:t>
+            </a:r>
+            <a:endParaRPr lang="en-US" sz="1500" dirty="0"/>
+          </a:p>
+        </p:txBody>
+      </p:sp>
+      <p:sp>
+        <p:nvSpPr>
+          <p:cNvPr id="19" name="Text 17"/>
+          <p:cNvSpPr txBox="1"/>
+          <p:nvPr/>
+        </p:nvSpPr>
+        <p:spPr>
+          <a:xfrm>
+            <a:off x="8280197" y="2404872"/>
+            <a:ext cx="3179978" cy="1143000"/>
+          </a:xfrm>
+          <a:prstGeom prst="rect">
+            <a:avLst/>
+          </a:prstGeom>
+          <a:noFill/>
+          <a:ln/>
+        </p:spPr>
+        <p:txBody>
+          <a:bodyPr wrap="square" lIns="0" tIns="0" rIns="0" bIns="0" rtlCol="0" anchor="t"/>
+          <a:lstStyle/>
+          <a:p>
+            <a:pPr indent="0" marL="0">
+              <a:buNone/>
+            </a:pPr>
+            <a:r>
+              <a:rPr lang="en-US" sz="1200" dirty="0">
+                <a:solidFill>
+                  <a:schemeClr val="tx1"/>
+                </a:solidFill>
+              </a:rPr>
+              <a:t>Pimpinan menerima ringkasan pagi, bukan kabar per permohonan, dengan jam tenang 21.00–06.00. Admin dapat mengirim ulang pemberitahuan ke tamu dengan jeda anti-spam.</a:t>
+            </a:r>
+            <a:endParaRPr lang="en-US" sz="1200" dirty="0"/>
+          </a:p>
+        </p:txBody>
+      </p:sp>
+      <p:sp>
+        <p:nvSpPr>
+          <p:cNvPr id="20" name="baru4"/>
+          <p:cNvSpPr/>
+          <p:nvPr/>
+        </p:nvSpPr>
+        <p:spPr>
+          <a:xfrm>
+            <a:off x="548640" y="3794760"/>
+            <a:ext cx="3545738" cy="1828800"/>
+          </a:xfrm>
+          <a:prstGeom prst="roundRect">
+            <a:avLst>
+              <a:gd name="adj" fmla="val 6000"/>
+            </a:avLst>
+          </a:prstGeom>
+          <a:solidFill>
+            <a:schemeClr val="bg2"/>
+          </a:solidFill>
+          <a:ln w="9525">
+            <a:solidFill>
+              <a:schemeClr val="bg2"/>
+            </a:solidFill>
+            <a:prstDash val="solid"/>
+          </a:ln>
+        </p:spPr>
+      </p:sp>
+      <p:sp>
+        <p:nvSpPr>
+          <p:cNvPr id="21" name="Shape 19"/>
+          <p:cNvSpPr/>
+          <p:nvPr/>
+        </p:nvSpPr>
+        <p:spPr>
+          <a:xfrm>
+            <a:off x="731520" y="3959352"/>
+            <a:ext cx="365760" cy="365760"/>
+          </a:xfrm>
+          <a:prstGeom prst="ellipse">
+            <a:avLst/>
+          </a:prstGeom>
+          <a:solidFill>
+            <a:schemeClr val="tx2"/>
+          </a:solidFill>
+          <a:ln w="12700">
+            <a:solidFill>
+              <a:schemeClr val="tx2"/>
+            </a:solidFill>
+            <a:prstDash val="solid"/>
+          </a:ln>
+        </p:spPr>
+      </p:sp>
+      <p:sp>
+        <p:nvSpPr>
+          <p:cNvPr id="22" name="Text 20"/>
+          <p:cNvSpPr txBox="1"/>
+          <p:nvPr/>
+        </p:nvSpPr>
+        <p:spPr>
+          <a:xfrm>
+            <a:off x="731520" y="3959352"/>
+            <a:ext cx="365760" cy="365760"/>
+          </a:xfrm>
+          <a:prstGeom prst="rect">
+            <a:avLst/>
+          </a:prstGeom>
+          <a:noFill/>
+          <a:ln/>
+        </p:spPr>
+        <p:txBody>
+          <a:bodyPr wrap="square" lIns="0" tIns="0" rIns="0" bIns="0" rtlCol="0" anchor="ctr"/>
+          <a:lstStyle/>
+          <a:p>
+            <a:pPr algn="ctr" indent="0" marL="0">
+              <a:buNone/>
+            </a:pPr>
+            <a:r>
+              <a:rPr lang="en-US" sz="1400" b="1" dirty="0">
+                <a:solidFill>
+                  <a:schemeClr val="accent1"/>
+                </a:solidFill>
+              </a:rPr>
+              <a:t>4</a:t>
+            </a:r>
+            <a:endParaRPr lang="en-US" sz="1400" dirty="0"/>
+          </a:p>
+        </p:txBody>
+      </p:sp>
+      <p:sp>
+        <p:nvSpPr>
+          <p:cNvPr id="23" name="Text 21"/>
+          <p:cNvSpPr txBox="1"/>
+          <p:nvPr/>
+        </p:nvSpPr>
+        <p:spPr>
+          <a:xfrm>
+            <a:off x="1234440" y="3959352"/>
+            <a:ext cx="2677058" cy="365760"/>
+          </a:xfrm>
+          <a:prstGeom prst="rect">
+            <a:avLst/>
+          </a:prstGeom>
+          <a:noFill/>
+          <a:ln/>
+        </p:spPr>
+        <p:txBody>
+          <a:bodyPr wrap="square" lIns="0" tIns="0" rIns="0" bIns="0" rtlCol="0" anchor="ctr"/>
+          <a:lstStyle/>
+          <a:p>
+            <a:pPr indent="0" marL="0">
+              <a:buNone/>
+            </a:pPr>
+            <a:r>
+              <a:rPr lang="en-US" sz="1500" b="1" dirty="0">
+                <a:solidFill>
+                  <a:schemeClr val="tx2"/>
+                </a:solidFill>
+              </a:rPr>
+              <a:t>Monitor WA</a:t>
+            </a:r>
+            <a:endParaRPr lang="en-US" sz="1500" dirty="0"/>
+          </a:p>
+        </p:txBody>
+      </p:sp>
+      <p:sp>
+        <p:nvSpPr>
+          <p:cNvPr id="24" name="Text 22"/>
+          <p:cNvSpPr txBox="1"/>
+          <p:nvPr/>
+        </p:nvSpPr>
+        <p:spPr>
+          <a:xfrm>
+            <a:off x="731520" y="4416552"/>
+            <a:ext cx="3179978" cy="1143000"/>
+          </a:xfrm>
+          <a:prstGeom prst="rect">
+            <a:avLst/>
+          </a:prstGeom>
+          <a:noFill/>
+          <a:ln/>
+        </p:spPr>
+        <p:txBody>
+          <a:bodyPr wrap="square" lIns="0" tIns="0" rIns="0" bIns="0" rtlCol="0" anchor="t"/>
+          <a:lstStyle/>
+          <a:p>
+            <a:pPr indent="0" marL="0">
+              <a:buNone/>
+            </a:pPr>
+            <a:r>
+              <a:rPr lang="en-US" sz="1200" dirty="0">
+                <a:solidFill>
+                  <a:schemeClr val="tx1"/>
+                </a:solidFill>
+              </a:rPr>
+              <a:t>Meteran dan arsip pesan keluar dengan status terkirim atau dibaca, peringatan dini bila gagal beruntun. Isi pesan dihapus setelah 90 hari; OTP tidak disimpan.</a:t>
+            </a:r>
+            <a:endParaRPr lang="en-US" sz="1200" dirty="0"/>
+          </a:p>
+        </p:txBody>
+      </p:sp>
+      <p:sp>
+        <p:nvSpPr>
+          <p:cNvPr id="25" name="baru5"/>
+          <p:cNvSpPr/>
+          <p:nvPr/>
+        </p:nvSpPr>
+        <p:spPr>
+          <a:xfrm>
+            <a:off x="4322978" y="3794760"/>
+            <a:ext cx="3545738" cy="1828800"/>
+          </a:xfrm>
+          <a:prstGeom prst="roundRect">
+            <a:avLst>
+              <a:gd name="adj" fmla="val 6000"/>
+            </a:avLst>
+          </a:prstGeom>
+          <a:solidFill>
+            <a:schemeClr val="bg2"/>
+          </a:solidFill>
+          <a:ln w="9525">
+            <a:solidFill>
+              <a:schemeClr val="bg2"/>
+            </a:solidFill>
+            <a:prstDash val="solid"/>
+          </a:ln>
+        </p:spPr>
+      </p:sp>
+      <p:sp>
+        <p:nvSpPr>
+          <p:cNvPr id="26" name="Shape 24"/>
+          <p:cNvSpPr/>
+          <p:nvPr/>
+        </p:nvSpPr>
+        <p:spPr>
+          <a:xfrm>
+            <a:off x="4505858" y="3959352"/>
+            <a:ext cx="365760" cy="365760"/>
+          </a:xfrm>
+          <a:prstGeom prst="ellipse">
+            <a:avLst/>
+          </a:prstGeom>
+          <a:solidFill>
+            <a:schemeClr val="tx2"/>
+          </a:solidFill>
+          <a:ln w="12700">
+            <a:solidFill>
+              <a:schemeClr val="tx2"/>
+            </a:solidFill>
+            <a:prstDash val="solid"/>
+          </a:ln>
+        </p:spPr>
+      </p:sp>
+      <p:sp>
+        <p:nvSpPr>
+          <p:cNvPr id="27" name="Text 25"/>
+          <p:cNvSpPr txBox="1"/>
+          <p:nvPr/>
+        </p:nvSpPr>
+        <p:spPr>
+          <a:xfrm>
+            <a:off x="4505858" y="3959352"/>
+            <a:ext cx="365760" cy="365760"/>
+          </a:xfrm>
+          <a:prstGeom prst="rect">
+            <a:avLst/>
+          </a:prstGeom>
+          <a:noFill/>
+          <a:ln/>
+        </p:spPr>
+        <p:txBody>
+          <a:bodyPr wrap="square" lIns="0" tIns="0" rIns="0" bIns="0" rtlCol="0" anchor="ctr"/>
+          <a:lstStyle/>
+          <a:p>
+            <a:pPr algn="ctr" indent="0" marL="0">
+              <a:buNone/>
+            </a:pPr>
+            <a:r>
+              <a:rPr lang="en-US" sz="1400" b="1" dirty="0">
+                <a:solidFill>
+                  <a:schemeClr val="accent1"/>
+                </a:solidFill>
+              </a:rPr>
+              <a:t>5</a:t>
+            </a:r>
+            <a:endParaRPr lang="en-US" sz="1400" dirty="0"/>
+          </a:p>
+        </p:txBody>
+      </p:sp>
+      <p:sp>
+        <p:nvSpPr>
+          <p:cNvPr id="28" name="Text 26"/>
+          <p:cNvSpPr txBox="1"/>
+          <p:nvPr/>
+        </p:nvSpPr>
+        <p:spPr>
+          <a:xfrm>
+            <a:off x="5008778" y="3959352"/>
+            <a:ext cx="2677058" cy="365760"/>
+          </a:xfrm>
+          <a:prstGeom prst="rect">
+            <a:avLst/>
+          </a:prstGeom>
+          <a:noFill/>
+          <a:ln/>
+        </p:spPr>
+        <p:txBody>
+          <a:bodyPr wrap="square" lIns="0" tIns="0" rIns="0" bIns="0" rtlCol="0" anchor="ctr"/>
+          <a:lstStyle/>
+          <a:p>
+            <a:pPr indent="0" marL="0">
+              <a:buNone/>
+            </a:pPr>
+            <a:r>
+              <a:rPr lang="en-US" sz="1500" b="1" dirty="0">
+                <a:solidFill>
+                  <a:schemeClr val="tx2"/>
+                </a:solidFill>
+              </a:rPr>
+              <a:t>Masuk lebih mudah dan aman</a:t>
+            </a:r>
+            <a:endParaRPr lang="en-US" sz="1500" dirty="0"/>
+          </a:p>
+        </p:txBody>
+      </p:sp>
+      <p:sp>
+        <p:nvSpPr>
+          <p:cNvPr id="29" name="Text 27"/>
+          <p:cNvSpPr txBox="1"/>
+          <p:nvPr/>
+        </p:nvSpPr>
+        <p:spPr>
+          <a:xfrm>
+            <a:off x="4505858" y="4416552"/>
+            <a:ext cx="3179978" cy="1143000"/>
+          </a:xfrm>
+          <a:prstGeom prst="rect">
+            <a:avLst/>
+          </a:prstGeom>
+          <a:noFill/>
+          <a:ln/>
+        </p:spPr>
+        <p:txBody>
+          <a:bodyPr wrap="square" lIns="0" tIns="0" rIns="0" bIns="0" rtlCol="0" anchor="t"/>
+          <a:lstStyle/>
+          <a:p>
+            <a:pPr indent="0" marL="0">
+              <a:buNone/>
+            </a:pPr>
+            <a:r>
+              <a:rPr lang="en-US" sz="1200" dirty="0">
+                <a:solidFill>
+                  <a:schemeClr val="tx1"/>
+                </a:solidFill>
+              </a:rPr>
+              <a:t>Sidik jari atau wajah (passkey) dan akun Google, tetap hanya untuk akun yang didaftarkan Admin. Kebijakan privasi dan ketentuan mengikuti UU 27/2022.</a:t>
+            </a:r>
+            <a:endParaRPr lang="en-US" sz="1200" dirty="0"/>
+          </a:p>
+        </p:txBody>
+      </p:sp>
+      <p:sp>
+        <p:nvSpPr>
+          <p:cNvPr id="30" name="baru6"/>
+          <p:cNvSpPr/>
+          <p:nvPr/>
+        </p:nvSpPr>
+        <p:spPr>
+          <a:xfrm>
+            <a:off x="8097317" y="3794760"/>
+            <a:ext cx="3545738" cy="1828800"/>
+          </a:xfrm>
+          <a:prstGeom prst="roundRect">
+            <a:avLst>
+              <a:gd name="adj" fmla="val 6000"/>
+            </a:avLst>
+          </a:prstGeom>
+          <a:solidFill>
+            <a:schemeClr val="bg2"/>
+          </a:solidFill>
+          <a:ln w="9525">
+            <a:solidFill>
+              <a:schemeClr val="bg2"/>
+            </a:solidFill>
+            <a:prstDash val="solid"/>
+          </a:ln>
+        </p:spPr>
+      </p:sp>
+      <p:sp>
+        <p:nvSpPr>
+          <p:cNvPr id="31" name="Shape 29"/>
+          <p:cNvSpPr/>
+          <p:nvPr/>
+        </p:nvSpPr>
+        <p:spPr>
+          <a:xfrm>
+            <a:off x="8280197" y="3959352"/>
+            <a:ext cx="365760" cy="365760"/>
+          </a:xfrm>
+          <a:prstGeom prst="ellipse">
+            <a:avLst/>
+          </a:prstGeom>
+          <a:solidFill>
+            <a:schemeClr val="tx2"/>
+          </a:solidFill>
+          <a:ln w="12700">
+            <a:solidFill>
+              <a:schemeClr val="tx2"/>
+            </a:solidFill>
+            <a:prstDash val="solid"/>
+          </a:ln>
+        </p:spPr>
+      </p:sp>
+      <p:sp>
+        <p:nvSpPr>
+          <p:cNvPr id="32" name="Text 30"/>
+          <p:cNvSpPr txBox="1"/>
+          <p:nvPr/>
+        </p:nvSpPr>
+        <p:spPr>
+          <a:xfrm>
+            <a:off x="8280197" y="3959352"/>
+            <a:ext cx="365760" cy="365760"/>
+          </a:xfrm>
+          <a:prstGeom prst="rect">
+            <a:avLst/>
+          </a:prstGeom>
+          <a:noFill/>
+          <a:ln/>
+        </p:spPr>
+        <p:txBody>
+          <a:bodyPr wrap="square" lIns="0" tIns="0" rIns="0" bIns="0" rtlCol="0" anchor="ctr"/>
+          <a:lstStyle/>
+          <a:p>
+            <a:pPr algn="ctr" indent="0" marL="0">
+              <a:buNone/>
+            </a:pPr>
+            <a:r>
+              <a:rPr lang="en-US" sz="1400" b="1" dirty="0">
+                <a:solidFill>
+                  <a:schemeClr val="accent1"/>
+                </a:solidFill>
+              </a:rPr>
+              <a:t>6</a:t>
+            </a:r>
+            <a:endParaRPr lang="en-US" sz="1400" dirty="0"/>
+          </a:p>
+        </p:txBody>
+      </p:sp>
+      <p:sp>
+        <p:nvSpPr>
+          <p:cNvPr id="33" name="Text 31"/>
+          <p:cNvSpPr txBox="1"/>
+          <p:nvPr/>
+        </p:nvSpPr>
+        <p:spPr>
+          <a:xfrm>
+            <a:off x="8783117" y="3959352"/>
+            <a:ext cx="2677058" cy="365760"/>
+          </a:xfrm>
+          <a:prstGeom prst="rect">
+            <a:avLst/>
+          </a:prstGeom>
+          <a:noFill/>
+          <a:ln/>
+        </p:spPr>
+        <p:txBody>
+          <a:bodyPr wrap="square" lIns="0" tIns="0" rIns="0" bIns="0" rtlCol="0" anchor="ctr"/>
+          <a:lstStyle/>
+          <a:p>
+            <a:pPr indent="0" marL="0">
+              <a:buNone/>
+            </a:pPr>
+            <a:r>
+              <a:rPr lang="en-US" sz="1500" b="1" dirty="0">
+                <a:solidFill>
+                  <a:schemeClr val="tx2"/>
+                </a:solidFill>
+              </a:rPr>
+              <a:t>Jam acara mengikuti zona</a:t>
+            </a:r>
+            <a:endParaRPr lang="en-US" sz="1500" dirty="0"/>
+          </a:p>
+        </p:txBody>
+      </p:sp>
+      <p:sp>
+        <p:nvSpPr>
+          <p:cNvPr id="34" name="Text 32"/>
+          <p:cNvSpPr txBox="1"/>
+          <p:nvPr/>
+        </p:nvSpPr>
+        <p:spPr>
+          <a:xfrm>
+            <a:off x="8280197" y="4416552"/>
+            <a:ext cx="3179978" cy="1143000"/>
+          </a:xfrm>
+          <a:prstGeom prst="rect">
+            <a:avLst/>
+          </a:prstGeom>
+          <a:noFill/>
+          <a:ln/>
+        </p:spPr>
+        <p:txBody>
+          <a:bodyPr wrap="square" lIns="0" tIns="0" rIns="0" bIns="0" rtlCol="0" anchor="t"/>
+          <a:lstStyle/>
+          <a:p>
+            <a:pPr indent="0" marL="0">
+              <a:buNone/>
+            </a:pPr>
+            <a:r>
+              <a:rPr lang="en-US" sz="1200" dirty="0">
+                <a:solidFill>
+                  <a:schemeClr val="tx1"/>
+                </a:solidFill>
+              </a:rPr>
+              <a:t>Acara di zona WIB, WITA, atau WIT ditulis menurut undangan dan ditampilkan menurut tempat pengguna, sehingga jam tidak lagi tertukar.</a:t>
+            </a:r>
+            <a:endParaRPr lang="en-US" sz="1200" dirty="0"/>
+          </a:p>
+        </p:txBody>
+      </p:sp>
+      <p:sp>
+        <p:nvSpPr>
+          <p:cNvPr id="35" name="nilaitambah"/>
+          <p:cNvSpPr/>
+          <p:nvPr/>
+        </p:nvSpPr>
+        <p:spPr>
+          <a:xfrm>
+            <a:off x="548640" y="5669280"/>
+            <a:ext cx="11094415" cy="640080"/>
+          </a:xfrm>
+          <a:prstGeom prst="roundRect">
+            <a:avLst>
+              <a:gd name="adj" fmla="val 17143"/>
+            </a:avLst>
+          </a:prstGeom>
+          <a:solidFill>
+            <a:schemeClr val="tx2"/>
+          </a:solidFill>
+          <a:ln w="9525">
+            <a:solidFill>
+              <a:schemeClr val="tx2"/>
+            </a:solidFill>
+            <a:prstDash val="solid"/>
+          </a:ln>
+        </p:spPr>
+      </p:sp>
+      <p:sp>
+        <p:nvSpPr>
+          <p:cNvPr id="36" name="Text 34"/>
+          <p:cNvSpPr txBox="1"/>
+          <p:nvPr/>
+        </p:nvSpPr>
+        <p:spPr>
+          <a:xfrm>
+            <a:off x="822960" y="5669280"/>
+            <a:ext cx="10545775" cy="640080"/>
+          </a:xfrm>
+          <a:prstGeom prst="rect">
+            <a:avLst/>
+          </a:prstGeom>
+          <a:noFill/>
+          <a:ln/>
+        </p:spPr>
+        <p:txBody>
+          <a:bodyPr wrap="square" lIns="0" tIns="0" rIns="0" bIns="0" rtlCol="0" anchor="ctr"/>
+          <a:lstStyle/>
+          <a:p>
+            <a:pPr indent="0" marL="0">
+              <a:buNone/>
+            </a:pPr>
+            <a:r>
+              <a:rPr lang="en-US" sz="1300" b="1" dirty="0">
+                <a:solidFill>
+                  <a:schemeClr val="accent1"/>
+                </a:solidFill>
+              </a:rPr>
+              <a:t>Nilai tambah  </a:t>
+            </a:r>
+            <a:pPr indent="0" marL="0">
+              <a:buNone/>
+            </a:pPr>
+            <a:r>
+              <a:rPr lang="en-US" sz="1300" dirty="0">
+                <a:solidFill>
+                  <a:schemeClr val="bg1"/>
+                </a:solidFill>
+              </a:rPr>
+              <a:t>Setiap pembaruan berangkat dari kendala pengguna, dikerjakan tim sendiri tanpa belanja pengadaan, dan dicatat dalam riwayat perubahan aplikasi.</a:t>
+            </a:r>
+            <a:endParaRPr lang="en-US" sz="1300" dirty="0"/>
+          </a:p>
+        </p:txBody>
+      </p:sp>
+      <p:sp>
+        <p:nvSpPr>
+          <p:cNvPr id="25" name="Slide Number Placeholder 0"/>
+          <p:cNvSpPr>
+            <a:spLocks noGrp="1"/>
+          </p:cNvSpPr>
+          <p:nvPr>
+            <p:ph type="sldNum" sz="quarter" idx="4294967295"/>
+          </p:nvPr>
+        </p:nvSpPr>
+        <p:spPr>
+          <a:xfrm>
+            <a:off x="11094415" y="6419088"/>
+            <a:ext cx="548640" cy="274320"/>
+          </a:xfrm>
+          <a:prstGeom prst="rect">
+            <a:avLst/>
+          </a:prstGeom>
+          <a:extLst>
+            <a:ext uri="{C572A759-6A51-4108-AA02-DFA0A04FC94B}">
+              <ma14:wrappingTextBoxFlag xmlns:ma14="http://schemas.microsoft.com/office/mac/drawingml/2011/main" val="0"/>
+            </a:ext>
+          </a:extLst>
+        </p:spPr>
+        <p:txBody>
+          <a:bodyPr/>
+          <a:lstStyle>
+            <a:lvl1pPr>
+              <a:defRPr sz="1000">
+                <a:solidFill>
+                  <a:schemeClr val="accent5"/>
+                </a:solidFill>
+              </a:defRPr>
+            </a:lvl1pPr>
+          </a:lstStyle>
+          <a:p>
+            <a:pPr algn="r"/>
+            <a:fld id="{F7021451-1387-4CA6-816F-3879F97B5CBC}" type="slidenum">
+              <a:rPr b="0" lang="en-US"/>
+              <a:t>13</a:t>
             </a:fld>
             <a:endParaRPr lang="en-US"/>
           </a:p>

</xml_diff>

<commit_message>
Lomba Kaltara: hapus "median 8 menit"; judul slide 8 disesuaikan
Angka median keputusan Kabag tidak lagi ditampilkan agar tidak terbaca
sebagai tenggat; slide 4, slide 7, judul adegan video, narasi, takarir,
dan potongan vertikal disesuaikan. Judul slide 8 menjadi "Pimpinan dan
jajarannya" karena angka kanal publik sudah dipindah ke slide 9.

Co-Authored-By: Claude Opus 5.5 <noreply@anthropic.com>
Claude-Session: https://claude.ai/code/session_01TchDZWsQsgeuq52sKmozd1
</commit_message>
<xml_diff>
--- a/docs/lomba/kaltara/Paparan-Prokopim-Hibot-Kaltara-2026.pptx
+++ b/docs/lomba/kaltara/Paparan-Prokopim-Hibot-Kaltara-2026.pptx
@@ -120,56 +120,56 @@
   <p:extLst>
     <p:ext uri="{521415D9-36F7-43E2-AB2F-B90AF26B5E84}">
       <p14:sectionLst xmlns:p14="http://schemas.microsoft.com/office/powerpoint/2010/main">
-        <p14:section name="Pembuka" id="{7eca5c91-7d83-cd3b-7f39-9bdd048d699b}">
+        <p14:section name="Pembuka" id="{650129ec-3255-2607-d395-d661638558fb}">
           <p14:sldIdLst>
             <p14:sldId id="256"/>
           </p14:sldIdLst>
         </p14:section>
-        <p14:section name="Latar belakang" id="{de93b904-ebcd-ae70-2c61-f6e1b19d47cc}">
+        <p14:section name="Latar belakang" id="{24e10f60-3c00-7933-c8df-f7d59ffc2ff1}">
           <p14:sldIdLst>
             <p14:sldId id="257"/>
             <p14:sldId id="258"/>
           </p14:sldIdLst>
         </p14:section>
-        <p14:section name="Terobosan inovasi" id="{c973de0e-a12c-4872-8aeb-c74cfcdbf1a5}">
+        <p14:section name="Terobosan inovasi" id="{93a8342c-7126-b6dd-c883-afd5462a65e1}">
           <p14:sldIdLst>
             <p14:sldId id="259"/>
             <p14:sldId id="260"/>
           </p14:sldIdLst>
         </p14:section>
-        <p14:section name="Manfaat inovasi" id="{1d7dc967-8b6d-160c-8823-7e97d4ce6a86}">
+        <p14:section name="Manfaat inovasi" id="{fa5c3e6e-81ba-9841-51d2-91452437bbfd}">
           <p14:sldIdLst>
             <p14:sldId id="261"/>
             <p14:sldId id="262"/>
             <p14:sldId id="263"/>
           </p14:sldIdLst>
         </p14:section>
-        <p14:section name="Fitur lain: kanal publik" id="{f03caa7a-3aea-2324-b6d1-c7d6dd06c6f4}">
+        <p14:section name="Fitur lain: kanal publik" id="{007775c1-4687-8b6f-78f7-1bd072e4bb39}">
           <p14:sldIdLst>
             <p14:sldId id="264"/>
           </p14:sldIdLst>
         </p14:section>
-        <p14:section name="Pemanfaatan sumber daya" id="{4585dc65-64b5-6a5e-b95d-8605bb74efe7}">
+        <p14:section name="Pemanfaatan sumber daya" id="{2b80c2d8-f478-5509-3989-34c3cb49cb63}">
           <p14:sldIdLst>
             <p14:sldId id="265"/>
           </p14:sldIdLst>
         </p14:section>
-        <p14:section name="Diseminasi inovasi" id="{063a9443-1a06-7e66-bf92-3c2125b6add5}">
+        <p14:section name="Diseminasi inovasi" id="{f205a2ab-2211-fab2-9658-a9f960af8f90}">
           <p14:sldIdLst>
             <p14:sldId id="266"/>
           </p14:sldIdLst>
         </p14:section>
-        <p14:section name="Kompatibilitas" id="{0996533e-80d4-ea76-f779-83c147dfbad3}">
+        <p14:section name="Kompatibilitas" id="{17ddd206-05f1-e822-6d51-e2d3ddea24a1}">
           <p14:sldIdLst>
             <p14:sldId id="267"/>
           </p14:sldIdLst>
         </p14:section>
-        <p14:section name="Penutup" id="{69db6d32-45b0-77ff-e42f-dc0c6183741d}">
+        <p14:section name="Penutup" id="{c3a357ae-08a8-5bb2-edf1-f8a63be65346}">
           <p14:sldIdLst>
             <p14:sldId id="268"/>
           </p14:sldIdLst>
         </p14:section>
-        <p14:section name="Cadangan penjelasan" id="{34fbebea-e6c2-32ad-5af1-9cf3755d9dc6}">
+        <p14:section name="Cadangan penjelasan" id="{a6dc6592-600f-f9d6-5bef-2ad007b007bf}">
           <p14:sldIdLst>
             <p14:sldId id="269"/>
           </p14:sldIdLst>
@@ -11283,7 +11283,7 @@
                   <a:schemeClr val="tx1"/>
                 </a:solidFill>
               </a:rPr>
-              <a:t>Memutus; median 8 menit</a:t>
+              <a:t>Memutus dan menayangkan</a:t>
             </a:r>
             <a:endParaRPr lang="en-US" sz="1400" dirty="0"/>
           </a:p>
@@ -14508,7 +14508,7 @@
                   <a:schemeClr val="tx2"/>
                 </a:solidFill>
               </a:rPr>
-              <a:t>8 menit</a:t>
+              <a:t>47,5%</a:t>
             </a:r>
             <a:endParaRPr lang="en-US" sz="1500" dirty="0"/>
           </a:p>
@@ -14544,7 +14544,7 @@
                   <a:schemeClr val="accent5"/>
                 </a:solidFill>
               </a:rPr>
-              <a:t>median keputusan Kabag</a:t>
+              <a:t>telaah di luar jam kerja</a:t>
             </a:r>
             <a:endParaRPr lang="en-US" sz="1200" dirty="0"/>
           </a:p>
@@ -14580,7 +14580,7 @@
                   <a:schemeClr val="tx2"/>
                 </a:solidFill>
               </a:rPr>
-              <a:t>47,5%</a:t>
+              <a:t>3.072</a:t>
             </a:r>
             <a:endParaRPr lang="en-US" sz="1500" dirty="0"/>
           </a:p>
@@ -14616,7 +14616,7 @@
                   <a:schemeClr val="accent5"/>
                 </a:solidFill>
               </a:rPr>
-              <a:t>telaah di luar jam kerja</a:t>
+              <a:t>peristiwa jejak audit</a:t>
             </a:r>
             <a:endParaRPr lang="en-US" sz="1200" dirty="0"/>
           </a:p>
@@ -14652,7 +14652,7 @@
                   <a:schemeClr val="tx2"/>
                 </a:solidFill>
               </a:rPr>
-              <a:t>3.072</a:t>
+              <a:t>92,4%</a:t>
             </a:r>
             <a:endParaRPr lang="en-US" sz="1500" dirty="0"/>
           </a:p>
@@ -14688,7 +14688,7 @@
                   <a:schemeClr val="accent5"/>
                 </a:solidFill>
               </a:rPr>
-              <a:t>peristiwa jejak audit</a:t>
+              <a:t>kegiatan ada petugasnya</a:t>
             </a:r>
             <a:endParaRPr lang="en-US" sz="1200" dirty="0"/>
           </a:p>
@@ -14724,7 +14724,7 @@
                   <a:schemeClr val="tx2"/>
                 </a:solidFill>
               </a:rPr>
-              <a:t>92,4%</a:t>
+              <a:t>Rp0</a:t>
             </a:r>
             <a:endParaRPr lang="en-US" sz="1500" dirty="0"/>
           </a:p>
@@ -14760,7 +14760,7 @@
                   <a:schemeClr val="accent5"/>
                 </a:solidFill>
               </a:rPr>
-              <a:t>kegiatan ada petugasnya</a:t>
+              <a:t>belanja pengadaan</a:t>
             </a:r>
             <a:endParaRPr lang="en-US" sz="1200" dirty="0"/>
           </a:p>
@@ -14769,78 +14769,6 @@
       <p:sp>
         <p:nvSpPr>
           <p:cNvPr id="24" name="Text 22"/>
-          <p:cNvSpPr txBox="1"/>
-          <p:nvPr/>
-        </p:nvSpPr>
-        <p:spPr>
-          <a:xfrm>
-            <a:off x="8412480" y="3977640"/>
-            <a:ext cx="960120" cy="347472"/>
-          </a:xfrm>
-          <a:prstGeom prst="rect">
-            <a:avLst/>
-          </a:prstGeom>
-          <a:noFill/>
-          <a:ln/>
-        </p:spPr>
-        <p:txBody>
-          <a:bodyPr wrap="square" lIns="0" tIns="0" rIns="0" bIns="0" rtlCol="0" anchor="ctr"/>
-          <a:lstStyle/>
-          <a:p>
-            <a:pPr indent="0" marL="0">
-              <a:buNone/>
-            </a:pPr>
-            <a:r>
-              <a:rPr lang="en-US" sz="1500" b="1" dirty="0">
-                <a:solidFill>
-                  <a:schemeClr val="tx2"/>
-                </a:solidFill>
-              </a:rPr>
-              <a:t>Rp0</a:t>
-            </a:r>
-            <a:endParaRPr lang="en-US" sz="1500" dirty="0"/>
-          </a:p>
-        </p:txBody>
-      </p:sp>
-      <p:sp>
-        <p:nvSpPr>
-          <p:cNvPr id="25" name="Text 23"/>
-          <p:cNvSpPr txBox="1"/>
-          <p:nvPr/>
-        </p:nvSpPr>
-        <p:spPr>
-          <a:xfrm>
-            <a:off x="9418320" y="3977640"/>
-            <a:ext cx="2224735" cy="347472"/>
-          </a:xfrm>
-          <a:prstGeom prst="rect">
-            <a:avLst/>
-          </a:prstGeom>
-          <a:noFill/>
-          <a:ln/>
-        </p:spPr>
-        <p:txBody>
-          <a:bodyPr wrap="square" lIns="0" tIns="0" rIns="0" bIns="0" rtlCol="0" anchor="ctr"/>
-          <a:lstStyle/>
-          <a:p>
-            <a:pPr indent="0" marL="0">
-              <a:buNone/>
-            </a:pPr>
-            <a:r>
-              <a:rPr lang="en-US" sz="1200" dirty="0">
-                <a:solidFill>
-                  <a:schemeClr val="accent5"/>
-                </a:solidFill>
-              </a:rPr>
-              <a:t>belanja pengadaan</a:t>
-            </a:r>
-            <a:endParaRPr lang="en-US" sz="1200" dirty="0"/>
-          </a:p>
-        </p:txBody>
-      </p:sp>
-      <p:sp>
-        <p:nvSpPr>
-          <p:cNvPr id="26" name="Text 24"/>
           <p:cNvSpPr txBox="1"/>
           <p:nvPr/>
         </p:nvSpPr>
@@ -14876,7 +14804,7 @@
       </p:sp>
       <p:sp>
         <p:nvSpPr>
-          <p:cNvPr id="27" name="sebab1"/>
+          <p:cNvPr id="25" name="sebab1"/>
           <p:cNvSpPr/>
           <p:nvPr/>
         </p:nvSpPr>
@@ -14903,7 +14831,7 @@
       </p:sp>
       <p:sp>
         <p:nvSpPr>
-          <p:cNvPr id="28" name="Text 26"/>
+          <p:cNvPr id="26" name="Text 24"/>
           <p:cNvSpPr txBox="1"/>
           <p:nvPr/>
         </p:nvSpPr>
@@ -14939,7 +14867,7 @@
       </p:sp>
       <p:sp>
         <p:nvSpPr>
-          <p:cNvPr id="29" name="Text 27"/>
+          <p:cNvPr id="27" name="Text 25"/>
           <p:cNvSpPr txBox="1"/>
           <p:nvPr/>
         </p:nvSpPr>
@@ -14975,7 +14903,7 @@
       </p:sp>
       <p:sp>
         <p:nvSpPr>
-          <p:cNvPr id="30" name="sebab2"/>
+          <p:cNvPr id="28" name="sebab2"/>
           <p:cNvSpPr/>
           <p:nvPr/>
         </p:nvSpPr>
@@ -15002,7 +14930,7 @@
       </p:sp>
       <p:sp>
         <p:nvSpPr>
-          <p:cNvPr id="31" name="Text 29"/>
+          <p:cNvPr id="29" name="Text 27"/>
           <p:cNvSpPr txBox="1"/>
           <p:nvPr/>
         </p:nvSpPr>
@@ -15038,7 +14966,7 @@
       </p:sp>
       <p:sp>
         <p:nvSpPr>
-          <p:cNvPr id="32" name="Text 30"/>
+          <p:cNvPr id="30" name="Text 28"/>
           <p:cNvSpPr txBox="1"/>
           <p:nvPr/>
         </p:nvSpPr>
@@ -15074,7 +15002,7 @@
       </p:sp>
       <p:sp>
         <p:nvSpPr>
-          <p:cNvPr id="33" name="sebab3"/>
+          <p:cNvPr id="31" name="sebab3"/>
           <p:cNvSpPr/>
           <p:nvPr/>
         </p:nvSpPr>
@@ -15101,7 +15029,7 @@
       </p:sp>
       <p:sp>
         <p:nvSpPr>
-          <p:cNvPr id="34" name="Text 32"/>
+          <p:cNvPr id="32" name="Text 30"/>
           <p:cNvSpPr txBox="1"/>
           <p:nvPr/>
         </p:nvSpPr>
@@ -15137,7 +15065,7 @@
       </p:sp>
       <p:sp>
         <p:nvSpPr>
-          <p:cNvPr id="35" name="Text 33"/>
+          <p:cNvPr id="33" name="Text 31"/>
           <p:cNvSpPr txBox="1"/>
           <p:nvPr/>
         </p:nvSpPr>
@@ -15173,7 +15101,7 @@
       </p:sp>
       <p:sp>
         <p:nvSpPr>
-          <p:cNvPr id="36" name="Text 34"/>
+          <p:cNvPr id="34" name="Text 32"/>
           <p:cNvSpPr txBox="1"/>
           <p:nvPr/>
         </p:nvSpPr>
@@ -15347,7 +15275,7 @@
                   <a:schemeClr val="tx2"/>
                 </a:solidFill>
               </a:rPr>
-              <a:t>Dirasakan langsung oleh Pimpinan dan masyarakat</a:t>
+              <a:t>Dirasakan langsung oleh Pimpinan dan jajarannya</a:t>
             </a:r>
             <a:endParaRPr lang="en-US" sz="2800" dirty="0"/>
           </a:p>

</xml_diff>

<commit_message>
Lomba Kaltara: perbaikan hasil telaah juri (video dan huruf paparan)
Video:
- Data contoh diberi riwayat alur sesuai tahap; layar Kasubbag/Kabag tidak lagi
  menampilkan "Belum ada riwayat alur".
- Adegan 10 berakhir di Riwayat Alur kegiatan (6 langkah) dan ditambah klip
  daftar hadir di ponsel (isi nama dan tanda tangan) sesuai narasi QR.
- Peringatan "jadwal belum ditugaskan" tidak lagi muncul di rekaman.
- Narasi adegan aplikasi diperpanjang; adegan 13 bernarasi; musik latar pelan
  (dibuat sendiri, bebas hak cipta). Tidak ada jeda hening di atas 2 detik.
- Latar belakang dipadatkan (35 → 25 detik); aplikasi tampil di 1:45.
  Durasi 4:40.

Paparan: batas bawah huruf 14 pt untuk teks isi; teks slide 5 dan 14 diringkas;
QR penutup berlabel "Alamat resmi aplikasi".

Co-Authored-By: Claude Opus 5.5 <noreply@anthropic.com>
Claude-Session: https://claude.ai/code/session_01TchDZWsQsgeuq52sKmozd1
</commit_message>
<xml_diff>
--- a/docs/lomba/kaltara/Paparan-Prokopim-Hibot-Kaltara-2026.pptx
+++ b/docs/lomba/kaltara/Paparan-Prokopim-Hibot-Kaltara-2026.pptx
@@ -120,56 +120,56 @@
   <p:extLst>
     <p:ext uri="{521415D9-36F7-43E2-AB2F-B90AF26B5E84}">
       <p14:sectionLst xmlns:p14="http://schemas.microsoft.com/office/powerpoint/2010/main">
-        <p14:section name="Pembuka" id="{650129ec-3255-2607-d395-d661638558fb}">
+        <p14:section name="Pembuka" id="{a9f2cc64-228c-f840-6ca2-18a47224f42c}">
           <p14:sldIdLst>
             <p14:sldId id="256"/>
           </p14:sldIdLst>
         </p14:section>
-        <p14:section name="Latar belakang" id="{24e10f60-3c00-7933-c8df-f7d59ffc2ff1}">
+        <p14:section name="Latar belakang" id="{eab581e2-7239-2846-5987-441c711149d2}">
           <p14:sldIdLst>
             <p14:sldId id="257"/>
             <p14:sldId id="258"/>
           </p14:sldIdLst>
         </p14:section>
-        <p14:section name="Terobosan inovasi" id="{93a8342c-7126-b6dd-c883-afd5462a65e1}">
+        <p14:section name="Terobosan inovasi" id="{fc4b64ef-e8d3-c890-c4a9-17a9643ab68c}">
           <p14:sldIdLst>
             <p14:sldId id="259"/>
             <p14:sldId id="260"/>
           </p14:sldIdLst>
         </p14:section>
-        <p14:section name="Manfaat inovasi" id="{fa5c3e6e-81ba-9841-51d2-91452437bbfd}">
+        <p14:section name="Manfaat inovasi" id="{eec40268-1589-7b54-de0d-d6a606a90916}">
           <p14:sldIdLst>
             <p14:sldId id="261"/>
             <p14:sldId id="262"/>
             <p14:sldId id="263"/>
           </p14:sldIdLst>
         </p14:section>
-        <p14:section name="Fitur lain: kanal publik" id="{007775c1-4687-8b6f-78f7-1bd072e4bb39}">
+        <p14:section name="Fitur lain: kanal publik" id="{b00138ce-8f9f-a8db-a932-8b97b3017a28}">
           <p14:sldIdLst>
             <p14:sldId id="264"/>
           </p14:sldIdLst>
         </p14:section>
-        <p14:section name="Pemanfaatan sumber daya" id="{2b80c2d8-f478-5509-3989-34c3cb49cb63}">
+        <p14:section name="Pemanfaatan sumber daya" id="{02547ae8-9921-4853-6b5d-b90d4834d32e}">
           <p14:sldIdLst>
             <p14:sldId id="265"/>
           </p14:sldIdLst>
         </p14:section>
-        <p14:section name="Diseminasi inovasi" id="{f205a2ab-2211-fab2-9658-a9f960af8f90}">
+        <p14:section name="Diseminasi inovasi" id="{aeba8a88-bb9c-323c-9efb-9ee77021b5d7}">
           <p14:sldIdLst>
             <p14:sldId id="266"/>
           </p14:sldIdLst>
         </p14:section>
-        <p14:section name="Kompatibilitas" id="{17ddd206-05f1-e822-6d51-e2d3ddea24a1}">
+        <p14:section name="Kompatibilitas" id="{637262c2-39ba-fe84-e005-46fa3bb73921}">
           <p14:sldIdLst>
             <p14:sldId id="267"/>
           </p14:sldIdLst>
         </p14:section>
-        <p14:section name="Penutup" id="{c3a357ae-08a8-5bb2-edf1-f8a63be65346}">
+        <p14:section name="Penutup" id="{687a0048-6a32-7a26-86c0-d8c4f8691f3e}">
           <p14:sldIdLst>
             <p14:sldId id="268"/>
           </p14:sldIdLst>
         </p14:section>
-        <p14:section name="Cadangan penjelasan" id="{a6dc6592-600f-f9d6-5bef-2ad007b007bf}">
+        <p14:section name="Cadangan penjelasan" id="{c0b9a3a2-7edc-3903-5edb-ffecd33460cf}">
           <p14:sldIdLst>
             <p14:sldId id="269"/>
           </p14:sldIdLst>
@@ -2832,7 +2832,7 @@
               <a:buNone/>
             </a:pPr>
             <a:r>
-              <a:rPr lang="en-US" sz="1300" b="1" dirty="0">
+              <a:rPr lang="en-US" sz="1400" b="1" dirty="0">
                 <a:solidFill>
                   <a:schemeClr val="accent1"/>
                 </a:solidFill>
@@ -2843,14 +2843,14 @@
               <a:buNone/>
             </a:pPr>
             <a:r>
-              <a:rPr lang="en-US" sz="1300" dirty="0">
+              <a:rPr lang="en-US" sz="1400" dirty="0">
                 <a:solidFill>
                   <a:schemeClr val="bg1"/>
                 </a:solidFill>
               </a:rPr>
               <a:t>Anugrah Yega Pranatha, M.Si. (Ketua)  ·  Saifullah, S.H.  ·  Juliyanti, S.AP.  ·  Mastura, S.Sos.  ·  Ni Kade Sari Handayani, S.AP.</a:t>
             </a:r>
-            <a:endParaRPr lang="en-US" sz="1300" dirty="0"/>
+            <a:endParaRPr lang="en-US" sz="1400" dirty="0"/>
           </a:p>
         </p:txBody>
       </p:sp>
@@ -4085,14 +4085,14 @@
               <a:buNone/>
             </a:pPr>
             <a:r>
-              <a:rPr lang="en-US" sz="1300" dirty="0">
+              <a:rPr lang="en-US" sz="1400" dirty="0">
                 <a:solidFill>
                   <a:schemeClr val="accent5"/>
                 </a:solidFill>
               </a:rPr>
               <a:t>Efisiensi: ketika lalu lintas data mencapai 6,4 GB/bulan (kuota 5 GB), pengambilan data diubah hanya untuk data yang berubah — turun ke ±1 GB.</a:t>
             </a:r>
-            <a:endParaRPr lang="en-US" sz="1300" dirty="0"/>
+            <a:endParaRPr lang="en-US" sz="1400" dirty="0"/>
           </a:p>
         </p:txBody>
       </p:sp>
@@ -4184,14 +4184,14 @@
               <a:buNone/>
             </a:pPr>
             <a:r>
-              <a:rPr lang="en-US" sz="1300" dirty="0">
+              <a:rPr lang="en-US" sz="1400" dirty="0">
                 <a:solidFill>
                   <a:schemeClr val="tx1"/>
                 </a:solidFill>
               </a:rPr>
               <a:t>Tim inovasi: perancang, penyelia, penguji</a:t>
             </a:r>
-            <a:endParaRPr lang="en-US" sz="1300" dirty="0"/>
+            <a:endParaRPr lang="en-US" sz="1400" dirty="0"/>
           </a:p>
         </p:txBody>
       </p:sp>
@@ -4283,14 +4283,14 @@
               <a:buNone/>
             </a:pPr>
             <a:r>
-              <a:rPr lang="en-US" sz="1300" dirty="0">
+              <a:rPr lang="en-US" sz="1400" dirty="0">
                 <a:solidFill>
                   <a:schemeClr val="tx1"/>
                 </a:solidFill>
               </a:rPr>
               <a:t>Tim Koordinasi lintas unit (Keputusan Sekda)</a:t>
             </a:r>
-            <a:endParaRPr lang="en-US" sz="1300" dirty="0"/>
+            <a:endParaRPr lang="en-US" sz="1400" dirty="0"/>
           </a:p>
         </p:txBody>
       </p:sp>
@@ -4382,14 +4382,14 @@
               <a:buNone/>
             </a:pPr>
             <a:r>
-              <a:rPr lang="en-US" sz="1300" dirty="0">
+              <a:rPr lang="en-US" sz="1400" dirty="0">
                 <a:solidFill>
                   <a:schemeClr val="tx1"/>
                 </a:solidFill>
               </a:rPr>
               <a:t>Memfasilitasi subdomain resmi prokopim.tarakankota.go.id</a:t>
             </a:r>
-            <a:endParaRPr lang="en-US" sz="1300" dirty="0"/>
+            <a:endParaRPr lang="en-US" sz="1400" dirty="0"/>
           </a:p>
         </p:txBody>
       </p:sp>
@@ -4726,14 +4726,14 @@
               <a:buNone/>
             </a:pPr>
             <a:r>
-              <a:rPr lang="en-US" sz="1300" dirty="0">
+              <a:rPr lang="en-US" sz="1400" dirty="0">
                 <a:solidFill>
                   <a:schemeClr val="accent5"/>
                 </a:solidFill>
               </a:rPr>
               <a:t>14 jenis peran pengguna</a:t>
             </a:r>
-            <a:endParaRPr lang="en-US" sz="1300" dirty="0"/>
+            <a:endParaRPr lang="en-US" sz="1400" dirty="0"/>
           </a:p>
         </p:txBody>
       </p:sp>
@@ -4825,14 +4825,14 @@
               <a:buNone/>
             </a:pPr>
             <a:r>
-              <a:rPr lang="en-US" sz="1300" dirty="0">
+              <a:rPr lang="en-US" sz="1400" dirty="0">
                 <a:solidFill>
                   <a:schemeClr val="bg1"/>
                 </a:solidFill>
               </a:rPr>
               <a:t>di luar Bagian: Pimpinan, ajudan, pengawal, mitra DKISP</a:t>
             </a:r>
-            <a:endParaRPr lang="en-US" sz="1300" dirty="0"/>
+            <a:endParaRPr lang="en-US" sz="1400" dirty="0"/>
           </a:p>
         </p:txBody>
       </p:sp>
@@ -4924,14 +4924,14 @@
               <a:buNone/>
             </a:pPr>
             <a:r>
-              <a:rPr lang="en-US" sz="1300" dirty="0">
+              <a:rPr lang="en-US" sz="1400" dirty="0">
                 <a:solidFill>
                   <a:schemeClr val="accent5"/>
                 </a:solidFill>
               </a:rPr>
               <a:t>instansi memakai kanal publik ruangan dan audiensi</a:t>
             </a:r>
-            <a:endParaRPr lang="en-US" sz="1300" dirty="0"/>
+            <a:endParaRPr lang="en-US" sz="1400" dirty="0"/>
           </a:p>
         </p:txBody>
       </p:sp>
@@ -5023,14 +5023,14 @@
               <a:buNone/>
             </a:pPr>
             <a:r>
-              <a:rPr lang="en-US" sz="1300" dirty="0">
+              <a:rPr lang="en-US" sz="1400" dirty="0">
                 <a:solidFill>
                   <a:schemeClr val="accent5"/>
                 </a:solidFill>
               </a:rPr>
               <a:t>Tim Koordinasi lintas perangkat daerah</a:t>
             </a:r>
-            <a:endParaRPr lang="en-US" sz="1300" dirty="0"/>
+            <a:endParaRPr lang="en-US" sz="1400" dirty="0"/>
           </a:p>
         </p:txBody>
       </p:sp>
@@ -6435,14 +6435,14 @@
               <a:buNone/>
             </a:pPr>
             <a:r>
-              <a:rPr lang="en-US" sz="1300" dirty="0">
+              <a:rPr lang="en-US" sz="1400" dirty="0">
                 <a:solidFill>
                   <a:schemeClr val="accent6"/>
                 </a:solidFill>
               </a:rPr>
               <a:t>Tim Inovasi Prokopim Hibot  ·  Bagian Protokol dan Komunikasi Pimpinan, Setda Kota Tarakan</a:t>
             </a:r>
-            <a:endParaRPr lang="en-US" sz="1300" dirty="0"/>
+            <a:endParaRPr lang="en-US" sz="1400" dirty="0"/>
           </a:p>
         </p:txBody>
       </p:sp>
@@ -6558,14 +6558,14 @@
               <a:buNone/>
             </a:pPr>
             <a:r>
-              <a:rPr lang="en-US" sz="1100" dirty="0">
+              <a:rPr lang="en-US" sz="1400" dirty="0">
                 <a:solidFill>
                   <a:schemeClr val="accent5"/>
                 </a:solidFill>
               </a:rPr>
-              <a:t>Akses juri baca-saja tersedia saat demonstrasi</a:t>
-            </a:r>
-            <a:endParaRPr lang="en-US" sz="1100" dirty="0"/>
+              <a:t>Alamat resmi aplikasi</a:t>
+            </a:r>
+            <a:endParaRPr lang="en-US" sz="1400" dirty="0"/>
           </a:p>
         </p:txBody>
       </p:sp>
@@ -6800,14 +6800,14 @@
               <a:buNone/>
             </a:pPr>
             <a:r>
-              <a:rPr lang="en-US" sz="1300" dirty="0">
+              <a:rPr lang="en-US" sz="1400" dirty="0">
                 <a:solidFill>
                   <a:schemeClr val="accent5"/>
                 </a:solidFill>
               </a:rPr>
               <a:t>Proposal memuat keadaan per 24 September 2026. Pembaruan Oktober 2026 berikut berangkat dari pemakaian dan masukan pengguna.</a:t>
             </a:r>
-            <a:endParaRPr lang="en-US" sz="1300" dirty="0"/>
+            <a:endParaRPr lang="en-US" sz="1400" dirty="0"/>
           </a:p>
         </p:txBody>
       </p:sp>
@@ -6960,14 +6960,14 @@
               <a:buNone/>
             </a:pPr>
             <a:r>
-              <a:rPr lang="en-US" sz="1200" dirty="0">
+              <a:rPr lang="en-US" sz="1400" dirty="0">
                 <a:solidFill>
                   <a:schemeClr val="tx1"/>
                 </a:solidFill>
               </a:rPr>
-              <a:t>Proposal: lima kali sehari. Kini tiga waktu (06.30, 07.30, 16.00) ditambah kabar seketika, berdasarkan data pemakaian agar pesan tidak berulang.</a:t>
-            </a:r>
-            <a:endParaRPr lang="en-US" sz="1200" dirty="0"/>
+              <a:t>Proposal: lima kali sehari. Kini tiga waktu (06.30, 07.30, 16.00) plus kabar seketika, agar pesan tidak berulang.</a:t>
+            </a:r>
+            <a:endParaRPr lang="en-US" sz="1400" dirty="0"/>
           </a:p>
         </p:txBody>
       </p:sp>
@@ -7120,14 +7120,14 @@
               <a:buNone/>
             </a:pPr>
             <a:r>
-              <a:rPr lang="en-US" sz="1200" dirty="0">
+              <a:rPr lang="en-US" sz="1400" dirty="0">
                 <a:solidFill>
                   <a:schemeClr val="tx1"/>
                 </a:solidFill>
               </a:rPr>
-              <a:t>Pesan WhatsApp hanya untuk acara hari ini atau besok; selebihnya lewat notifikasi aplikasi, sehingga tidak ada pesan penting yang tenggelam.</a:t>
-            </a:r>
-            <a:endParaRPr lang="en-US" sz="1200" dirty="0"/>
+              <a:t>WhatsApp hanya untuk acara hari ini atau besok; selebihnya lewat notifikasi aplikasi.</a:t>
+            </a:r>
+            <a:endParaRPr lang="en-US" sz="1400" dirty="0"/>
           </a:p>
         </p:txBody>
       </p:sp>
@@ -7249,7 +7249,7 @@
                   <a:schemeClr val="tx2"/>
                 </a:solidFill>
               </a:rPr>
-              <a:t>Pemberitahuan tamu berjenjang</a:t>
+              <a:t>Tamu berjenjang</a:t>
             </a:r>
             <a:endParaRPr lang="en-US" sz="1500" dirty="0"/>
           </a:p>
@@ -7280,14 +7280,14 @@
               <a:buNone/>
             </a:pPr>
             <a:r>
-              <a:rPr lang="en-US" sz="1200" dirty="0">
+              <a:rPr lang="en-US" sz="1400" dirty="0">
                 <a:solidFill>
                   <a:schemeClr val="tx1"/>
                 </a:solidFill>
               </a:rPr>
-              <a:t>Pimpinan menerima ringkasan pagi, bukan kabar per permohonan, dengan jam tenang 21.00–06.00. Admin dapat mengirim ulang pemberitahuan ke tamu dengan jeda anti-spam.</a:t>
-            </a:r>
-            <a:endParaRPr lang="en-US" sz="1200" dirty="0"/>
+              <a:t>Pimpinan menerima ringkasan pagi, jam tenang 21.00–06.00; admin dapat mengirim ulang pemberitahuan ke tamu.</a:t>
+            </a:r>
+            <a:endParaRPr lang="en-US" sz="1400" dirty="0"/>
           </a:p>
         </p:txBody>
       </p:sp>
@@ -7440,14 +7440,14 @@
               <a:buNone/>
             </a:pPr>
             <a:r>
-              <a:rPr lang="en-US" sz="1200" dirty="0">
+              <a:rPr lang="en-US" sz="1400" dirty="0">
                 <a:solidFill>
                   <a:schemeClr val="tx1"/>
                 </a:solidFill>
               </a:rPr>
-              <a:t>Meteran dan arsip pesan keluar dengan status terkirim atau dibaca, peringatan dini bila gagal beruntun. Isi pesan dihapus setelah 90 hari; OTP tidak disimpan.</a:t>
-            </a:r>
-            <a:endParaRPr lang="en-US" sz="1200" dirty="0"/>
+              <a:t>Arsip pesan keluar dengan status terkirim atau dibaca dan peringatan dini; isi dihapus setelah 90 hari.</a:t>
+            </a:r>
+            <a:endParaRPr lang="en-US" sz="1400" dirty="0"/>
           </a:p>
         </p:txBody>
       </p:sp>
@@ -7569,7 +7569,7 @@
                   <a:schemeClr val="tx2"/>
                 </a:solidFill>
               </a:rPr>
-              <a:t>Masuk lebih mudah dan aman</a:t>
+              <a:t>Masuk lebih aman</a:t>
             </a:r>
             <a:endParaRPr lang="en-US" sz="1500" dirty="0"/>
           </a:p>
@@ -7600,14 +7600,14 @@
               <a:buNone/>
             </a:pPr>
             <a:r>
-              <a:rPr lang="en-US" sz="1200" dirty="0">
+              <a:rPr lang="en-US" sz="1400" dirty="0">
                 <a:solidFill>
                   <a:schemeClr val="tx1"/>
                 </a:solidFill>
               </a:rPr>
-              <a:t>Sidik jari atau wajah (passkey) dan akun Google, tetap hanya untuk akun yang didaftarkan Admin. Kebijakan privasi dan ketentuan mengikuti UU 27/2022.</a:t>
-            </a:r>
-            <a:endParaRPr lang="en-US" sz="1200" dirty="0"/>
+              <a:t>Sidik jari atau wajah dan akun Google, hanya untuk akun terdaftar; kebijakan privasi sesuai UU 27/2022.</a:t>
+            </a:r>
+            <a:endParaRPr lang="en-US" sz="1400" dirty="0"/>
           </a:p>
         </p:txBody>
       </p:sp>
@@ -7760,14 +7760,14 @@
               <a:buNone/>
             </a:pPr>
             <a:r>
-              <a:rPr lang="en-US" sz="1200" dirty="0">
+              <a:rPr lang="en-US" sz="1400" dirty="0">
                 <a:solidFill>
                   <a:schemeClr val="tx1"/>
                 </a:solidFill>
               </a:rPr>
-              <a:t>Acara di zona WIB, WITA, atau WIT ditulis menurut undangan dan ditampilkan menurut tempat pengguna, sehingga jam tidak lagi tertukar.</a:t>
-            </a:r>
-            <a:endParaRPr lang="en-US" sz="1200" dirty="0"/>
+              <a:t>Acara WIB, WITA, atau WIT ditulis menurut undangan dan tampil menurut tempat pengguna.</a:t>
+            </a:r>
+            <a:endParaRPr lang="en-US" sz="1400" dirty="0"/>
           </a:p>
         </p:txBody>
       </p:sp>
@@ -7823,7 +7823,7 @@
               <a:buNone/>
             </a:pPr>
             <a:r>
-              <a:rPr lang="en-US" sz="1300" b="1" dirty="0">
+              <a:rPr lang="en-US" sz="1400" b="1" dirty="0">
                 <a:solidFill>
                   <a:schemeClr val="accent1"/>
                 </a:solidFill>
@@ -7834,14 +7834,14 @@
               <a:buNone/>
             </a:pPr>
             <a:r>
-              <a:rPr lang="en-US" sz="1300" dirty="0">
+              <a:rPr lang="en-US" sz="1400" dirty="0">
                 <a:solidFill>
                   <a:schemeClr val="bg1"/>
                 </a:solidFill>
               </a:rPr>
               <a:t>Setiap pembaruan berangkat dari kendala pengguna, dikerjakan tim sendiri tanpa belanja pengadaan, dan dicatat dalam riwayat perubahan aplikasi.</a:t>
             </a:r>
-            <a:endParaRPr lang="en-US" sz="1300" dirty="0"/>
+            <a:endParaRPr lang="en-US" sz="1400" dirty="0"/>
           </a:p>
         </p:txBody>
       </p:sp>
@@ -10227,14 +10227,14 @@
               <a:buNone/>
             </a:pPr>
             <a:r>
-              <a:rPr lang="en-US" sz="1200" dirty="0">
+              <a:rPr lang="en-US" sz="1400" dirty="0">
                 <a:solidFill>
                   <a:schemeClr val="accent5"/>
                 </a:solidFill>
               </a:rPr>
               <a:t>Tidak menyentuh akar masalah</a:t>
             </a:r>
-            <a:endParaRPr lang="en-US" sz="1200" dirty="0"/>
+            <a:endParaRPr lang="en-US" sz="1400" dirty="0"/>
           </a:p>
         </p:txBody>
       </p:sp>
@@ -10387,14 +10387,14 @@
               <a:buNone/>
             </a:pPr>
             <a:r>
-              <a:rPr lang="en-US" sz="1200" dirty="0">
+              <a:rPr lang="en-US" sz="1400" dirty="0">
                 <a:solidFill>
                   <a:schemeClr val="accent5"/>
                 </a:solidFill>
               </a:rPr>
               <a:t>Tetap banyak versi, tanpa jejak keputusan</a:t>
             </a:r>
-            <a:endParaRPr lang="en-US" sz="1200" dirty="0"/>
+            <a:endParaRPr lang="en-US" sz="1400" dirty="0"/>
           </a:p>
         </p:txBody>
       </p:sp>
@@ -10547,14 +10547,14 @@
               <a:buNone/>
             </a:pPr>
             <a:r>
-              <a:rPr lang="en-US" sz="1200" dirty="0">
+              <a:rPr lang="en-US" sz="1400" dirty="0">
                 <a:solidFill>
                   <a:schemeClr val="accent5"/>
                 </a:solidFill>
               </a:rPr>
               <a:t>Butuh anggaran; alur keprotokolan sangat khas</a:t>
             </a:r>
-            <a:endParaRPr lang="en-US" sz="1200" dirty="0"/>
+            <a:endParaRPr lang="en-US" sz="1400" dirty="0"/>
           </a:p>
         </p:txBody>
       </p:sp>
@@ -10714,14 +10714,14 @@
               <a:buNone/>
             </a:pPr>
             <a:r>
-              <a:rPr lang="en-US" sz="1200" dirty="0">
+              <a:rPr lang="en-US" sz="1400" dirty="0">
                 <a:solidFill>
                   <a:schemeClr val="accent1"/>
                 </a:solidFill>
               </a:rPr>
               <a:t>Dipilih — tanpa anggaran pengadaan</a:t>
             </a:r>
-            <a:endParaRPr lang="en-US" sz="1200" dirty="0"/>
+            <a:endParaRPr lang="en-US" sz="1400" dirty="0"/>
           </a:p>
         </p:txBody>
       </p:sp>
@@ -11768,14 +11768,14 @@
               <a:buNone/>
             </a:pPr>
             <a:r>
-              <a:rPr lang="en-US" sz="1200" dirty="0">
+              <a:rPr lang="en-US" sz="1400" dirty="0">
                 <a:solidFill>
                   <a:schemeClr val="accent5"/>
                 </a:solidFill>
               </a:rPr>
-              <a:t>Siapa, kapan, apa keputusannya — 3.072 peristiwa</a:t>
-            </a:r>
-            <a:endParaRPr lang="en-US" sz="1200" dirty="0"/>
+              <a:t>Siapa, kapan, apa keputusannya</a:t>
+            </a:r>
+            <a:endParaRPr lang="en-US" sz="1400" dirty="0"/>
           </a:p>
         </p:txBody>
       </p:sp>
@@ -11928,14 +11928,14 @@
               <a:buNone/>
             </a:pPr>
             <a:r>
-              <a:rPr lang="en-US" sz="1200" dirty="0">
+              <a:rPr lang="en-US" sz="1400" dirty="0">
                 <a:solidFill>
                   <a:schemeClr val="accent5"/>
                 </a:solidFill>
               </a:rPr>
-              <a:t>Tombol setuju baru aktif sesudah butir dicentang</a:t>
-            </a:r>
-            <a:endParaRPr lang="en-US" sz="1200" dirty="0"/>
+              <a:t>Setuju baru aktif sesudah dicentang</a:t>
+            </a:r>
+            <a:endParaRPr lang="en-US" sz="1400" dirty="0"/>
           </a:p>
         </p:txBody>
       </p:sp>
@@ -12088,14 +12088,14 @@
               <a:buNone/>
             </a:pPr>
             <a:r>
-              <a:rPr lang="en-US" sz="1200" dirty="0">
+              <a:rPr lang="en-US" sz="1400" dirty="0">
                 <a:solidFill>
                   <a:schemeClr val="accent5"/>
                 </a:solidFill>
               </a:rPr>
-              <a:t>Kewenangan padam sendiri pada tanggal akhirnya</a:t>
-            </a:r>
-            <a:endParaRPr lang="en-US" sz="1200" dirty="0"/>
+              <a:t>Padam sendiri pada tanggal akhirnya</a:t>
+            </a:r>
+            <a:endParaRPr lang="en-US" sz="1400" dirty="0"/>
           </a:p>
         </p:txBody>
       </p:sp>
@@ -12248,14 +12248,14 @@
               <a:buNone/>
             </a:pPr>
             <a:r>
-              <a:rPr lang="en-US" sz="1200" dirty="0">
+              <a:rPr lang="en-US" sz="1400" dirty="0">
                 <a:solidFill>
                   <a:schemeClr val="accent5"/>
                 </a:solidFill>
               </a:rPr>
-              <a:t>Usulan tertahan ditandai menurut umur dan hari H</a:t>
-            </a:r>
-            <a:endParaRPr lang="en-US" sz="1200" dirty="0"/>
+              <a:t>Ditandai menurut umur dan hari H</a:t>
+            </a:r>
+            <a:endParaRPr lang="en-US" sz="1400" dirty="0"/>
           </a:p>
         </p:txBody>
       </p:sp>
@@ -12408,14 +12408,14 @@
               <a:buNone/>
             </a:pPr>
             <a:r>
-              <a:rPr lang="en-US" sz="1200" dirty="0">
+              <a:rPr lang="en-US" sz="1400" dirty="0">
                 <a:solidFill>
                   <a:schemeClr val="accent5"/>
                 </a:solidFill>
               </a:rPr>
-              <a:t>Pemohon memantau sendiri dengan kode penelusuran</a:t>
-            </a:r>
-            <a:endParaRPr lang="en-US" sz="1200" dirty="0"/>
+              <a:t>Dipantau sendiri dengan kode</a:t>
+            </a:r>
+            <a:endParaRPr lang="en-US" sz="1400" dirty="0"/>
           </a:p>
         </p:txBody>
       </p:sp>
@@ -12568,14 +12568,14 @@
               <a:buNone/>
             </a:pPr>
             <a:r>
-              <a:rPr lang="en-US" sz="1200" dirty="0">
+              <a:rPr lang="en-US" sz="1400" dirty="0">
                 <a:solidFill>
                   <a:schemeClr val="accent5"/>
                 </a:solidFill>
               </a:rPr>
-              <a:t>Agenda tersetujui tampil sendiri di Google Calendar</a:t>
-            </a:r>
-            <a:endParaRPr lang="en-US" sz="1200" dirty="0"/>
+              <a:t>Agenda tersetujui tampil sendiri</a:t>
+            </a:r>
+            <a:endParaRPr lang="en-US" sz="1400" dirty="0"/>
           </a:p>
         </p:txBody>
       </p:sp>
@@ -14200,14 +14200,14 @@
               <a:buNone/>
             </a:pPr>
             <a:r>
-              <a:rPr lang="en-US" sz="1300" dirty="0">
+              <a:rPr lang="en-US" sz="1400" dirty="0">
                 <a:solidFill>
                   <a:schemeClr val="accent5"/>
                 </a:solidFill>
               </a:rPr>
               <a:t>dari pengajuan sampai tayang; perkiraan alur lama yang tidak pernah dicatat</a:t>
             </a:r>
-            <a:endParaRPr lang="en-US" sz="1300" dirty="0"/>
+            <a:endParaRPr lang="en-US" sz="1400" dirty="0"/>
           </a:p>
         </p:txBody>
       </p:sp>
@@ -14359,14 +14359,14 @@
               <a:buNone/>
             </a:pPr>
             <a:r>
-              <a:rPr lang="en-US" sz="1300" dirty="0">
+              <a:rPr lang="en-US" sz="1400" dirty="0">
                 <a:solidFill>
                   <a:schemeClr val="accent6"/>
                 </a:solidFill>
               </a:rPr>
               <a:t>median terukur dari basis data; 99,3% tayang kurang dari 24 jam</a:t>
             </a:r>
-            <a:endParaRPr lang="en-US" sz="1300" dirty="0"/>
+            <a:endParaRPr lang="en-US" sz="1400" dirty="0"/>
           </a:p>
         </p:txBody>
       </p:sp>
@@ -14467,14 +14467,14 @@
               <a:buNone/>
             </a:pPr>
             <a:r>
-              <a:rPr lang="en-US" sz="1200" dirty="0">
+              <a:rPr lang="en-US" sz="1400" dirty="0">
                 <a:solidFill>
                   <a:schemeClr val="accent5"/>
                 </a:solidFill>
               </a:rPr>
               <a:t>kegiatan terkelola</a:t>
             </a:r>
-            <a:endParaRPr lang="en-US" sz="1200" dirty="0"/>
+            <a:endParaRPr lang="en-US" sz="1400" dirty="0"/>
           </a:p>
         </p:txBody>
       </p:sp>
@@ -14539,14 +14539,14 @@
               <a:buNone/>
             </a:pPr>
             <a:r>
-              <a:rPr lang="en-US" sz="1200" dirty="0">
+              <a:rPr lang="en-US" sz="1400" dirty="0">
                 <a:solidFill>
                   <a:schemeClr val="accent5"/>
                 </a:solidFill>
               </a:rPr>
               <a:t>telaah di luar jam kerja</a:t>
             </a:r>
-            <a:endParaRPr lang="en-US" sz="1200" dirty="0"/>
+            <a:endParaRPr lang="en-US" sz="1400" dirty="0"/>
           </a:p>
         </p:txBody>
       </p:sp>
@@ -14611,14 +14611,14 @@
               <a:buNone/>
             </a:pPr>
             <a:r>
-              <a:rPr lang="en-US" sz="1200" dirty="0">
+              <a:rPr lang="en-US" sz="1400" dirty="0">
                 <a:solidFill>
                   <a:schemeClr val="accent5"/>
                 </a:solidFill>
               </a:rPr>
               <a:t>peristiwa jejak audit</a:t>
             </a:r>
-            <a:endParaRPr lang="en-US" sz="1200" dirty="0"/>
+            <a:endParaRPr lang="en-US" sz="1400" dirty="0"/>
           </a:p>
         </p:txBody>
       </p:sp>
@@ -14683,14 +14683,14 @@
               <a:buNone/>
             </a:pPr>
             <a:r>
-              <a:rPr lang="en-US" sz="1200" dirty="0">
+              <a:rPr lang="en-US" sz="1400" dirty="0">
                 <a:solidFill>
                   <a:schemeClr val="accent5"/>
                 </a:solidFill>
               </a:rPr>
               <a:t>kegiatan ada petugasnya</a:t>
             </a:r>
-            <a:endParaRPr lang="en-US" sz="1200" dirty="0"/>
+            <a:endParaRPr lang="en-US" sz="1400" dirty="0"/>
           </a:p>
         </p:txBody>
       </p:sp>
@@ -14755,14 +14755,14 @@
               <a:buNone/>
             </a:pPr>
             <a:r>
-              <a:rPr lang="en-US" sz="1200" dirty="0">
+              <a:rPr lang="en-US" sz="1400" dirty="0">
                 <a:solidFill>
                   <a:schemeClr val="accent5"/>
                 </a:solidFill>
               </a:rPr>
               <a:t>belanja pengadaan</a:t>
             </a:r>
-            <a:endParaRPr lang="en-US" sz="1200" dirty="0"/>
+            <a:endParaRPr lang="en-US" sz="1400" dirty="0"/>
           </a:p>
         </p:txBody>
       </p:sp>
@@ -14890,14 +14890,14 @@
               <a:buNone/>
             </a:pPr>
             <a:r>
-              <a:rPr lang="en-US" sz="1200" dirty="0">
+              <a:rPr lang="en-US" sz="1400" dirty="0">
                 <a:solidFill>
                   <a:schemeClr val="tx1"/>
                 </a:solidFill>
               </a:rPr>
               <a:t>telaah dan persetujuan bisa dilakukan kapan saja, dari mana saja</a:t>
             </a:r>
-            <a:endParaRPr lang="en-US" sz="1200" dirty="0"/>
+            <a:endParaRPr lang="en-US" sz="1400" dirty="0"/>
           </a:p>
         </p:txBody>
       </p:sp>
@@ -14989,14 +14989,14 @@
               <a:buNone/>
             </a:pPr>
             <a:r>
-              <a:rPr lang="en-US" sz="1200" dirty="0">
+              <a:rPr lang="en-US" sz="1400" dirty="0">
                 <a:solidFill>
                   <a:schemeClr val="tx1"/>
                 </a:solidFill>
               </a:rPr>
               <a:t>tidak ada versi ganda, foto disposisi, atau grup yang harus ditelusuri</a:t>
             </a:r>
-            <a:endParaRPr lang="en-US" sz="1200" dirty="0"/>
+            <a:endParaRPr lang="en-US" sz="1400" dirty="0"/>
           </a:p>
         </p:txBody>
       </p:sp>
@@ -15088,14 +15088,14 @@
               <a:buNone/>
             </a:pPr>
             <a:r>
-              <a:rPr lang="en-US" sz="1200" dirty="0">
+              <a:rPr lang="en-US" sz="1400" dirty="0">
                 <a:solidFill>
                   <a:schemeClr val="tx1"/>
                 </a:solidFill>
               </a:rPr>
               <a:t>kekeliruan tertahan sebelum tayang, bukan sesudahnya</a:t>
             </a:r>
-            <a:endParaRPr lang="en-US" sz="1200" dirty="0"/>
+            <a:endParaRPr lang="en-US" sz="1400" dirty="0"/>
           </a:p>
         </p:txBody>
       </p:sp>
@@ -15124,14 +15124,14 @@
               <a:buNone/>
             </a:pPr>
             <a:r>
-              <a:rPr lang="en-US" sz="1000" dirty="0">
+              <a:rPr lang="en-US" sz="1100" dirty="0">
                 <a:solidFill>
                   <a:schemeClr val="accent5"/>
                 </a:solidFill>
               </a:rPr>
               <a:t>Sumber: basis data Prokopim Hibot, 24 September 2026. Angka "sebelum" adalah estimasi dari alur lama.</a:t>
             </a:r>
-            <a:endParaRPr lang="en-US" sz="1000" dirty="0"/>
+            <a:endParaRPr lang="en-US" sz="1100" dirty="0"/>
           </a:p>
         </p:txBody>
       </p:sp>
@@ -15400,14 +15400,14 @@
               <a:buNone/>
             </a:pPr>
             <a:r>
-              <a:rPr lang="en-US" sz="1300" b="1" dirty="0">
+              <a:rPr lang="en-US" sz="1400" b="1" dirty="0">
                 <a:solidFill>
                   <a:schemeClr val="accent1"/>
                 </a:solidFill>
               </a:rPr>
               <a:t>dr. H. Khairul, M.Kes. — Wali Kota Tarakan</a:t>
             </a:r>
-            <a:endParaRPr lang="en-US" sz="1300" dirty="0"/>
+            <a:endParaRPr lang="en-US" sz="1400" dirty="0"/>
           </a:p>
         </p:txBody>
       </p:sp>
@@ -15499,14 +15499,14 @@
               <a:buNone/>
             </a:pPr>
             <a:r>
-              <a:rPr lang="en-US" sz="1200" b="1" dirty="0">
+              <a:rPr lang="en-US" sz="1400" b="1" dirty="0">
                 <a:solidFill>
                   <a:schemeClr val="accent5"/>
                 </a:solidFill>
               </a:rPr>
               <a:t>Muhammad Rizky Dinata Putra, S.Tr.IP. — Ajudan Wakil Wali Kota</a:t>
             </a:r>
-            <a:endParaRPr lang="en-US" sz="1200" dirty="0"/>
+            <a:endParaRPr lang="en-US" sz="1400" dirty="0"/>
           </a:p>
         </p:txBody>
       </p:sp>
@@ -15571,14 +15571,14 @@
               <a:buNone/>
             </a:pPr>
             <a:r>
-              <a:rPr lang="en-US" sz="1200" dirty="0">
+              <a:rPr lang="en-US" sz="1400" dirty="0">
                 <a:solidFill>
                   <a:schemeClr val="accent5"/>
                 </a:solidFill>
               </a:rPr>
               <a:t>kegiatan didisposisikan Wali Kota kepada Wakil langsung dari aplikasi</a:t>
             </a:r>
-            <a:endParaRPr lang="en-US" sz="1200" dirty="0"/>
+            <a:endParaRPr lang="en-US" sz="1400" dirty="0"/>
           </a:p>
         </p:txBody>
       </p:sp>
@@ -15643,14 +15643,14 @@
               <a:buNone/>
             </a:pPr>
             <a:r>
-              <a:rPr lang="en-US" sz="1200" dirty="0">
+              <a:rPr lang="en-US" sz="1400" dirty="0">
                 <a:solidFill>
                   <a:schemeClr val="accent5"/>
                 </a:solidFill>
               </a:rPr>
               <a:t>konfirmasi kehadiran oleh ajudan</a:t>
             </a:r>
-            <a:endParaRPr lang="en-US" sz="1200" dirty="0"/>
+            <a:endParaRPr lang="en-US" sz="1400" dirty="0"/>
           </a:p>
         </p:txBody>
       </p:sp>
@@ -15715,14 +15715,14 @@
               <a:buNone/>
             </a:pPr>
             <a:r>
-              <a:rPr lang="en-US" sz="1200" dirty="0">
+              <a:rPr lang="en-US" sz="1400" dirty="0">
                 <a:solidFill>
                   <a:schemeClr val="accent5"/>
                 </a:solidFill>
               </a:rPr>
               <a:t>tindakan Pelaksana Harian tercatat atas nama pelakunya</a:t>
             </a:r>
-            <a:endParaRPr lang="en-US" sz="1200" dirty="0"/>
+            <a:endParaRPr lang="en-US" sz="1400" dirty="0"/>
           </a:p>
         </p:txBody>
       </p:sp>
@@ -15787,14 +15787,14 @@
               <a:buNone/>
             </a:pPr>
             <a:r>
-              <a:rPr lang="en-US" sz="1200" dirty="0">
+              <a:rPr lang="en-US" sz="1400" dirty="0">
                 <a:solidFill>
                   <a:schemeClr val="accent5"/>
                 </a:solidFill>
               </a:rPr>
               <a:t>perangkat dengan notifikasi aktif, milik 21 pengguna</a:t>
             </a:r>
-            <a:endParaRPr lang="en-US" sz="1200" dirty="0"/>
+            <a:endParaRPr lang="en-US" sz="1400" dirty="0"/>
           </a:p>
         </p:txBody>
       </p:sp>
@@ -16144,14 +16144,14 @@
               <a:buChar char="•"/>
             </a:pPr>
             <a:r>
-              <a:rPr lang="en-US" sz="1300" dirty="0">
+              <a:rPr lang="en-US" sz="1400" dirty="0">
                 <a:solidFill>
                   <a:schemeClr val="tx1"/>
                 </a:solidFill>
               </a:rPr>
               <a:t>98 disetujui, total 3.023 peserta kegiatan</a:t>
             </a:r>
-            <a:endParaRPr lang="en-US" sz="1300" dirty="0"/>
+            <a:endParaRPr lang="en-US" sz="1400" dirty="0"/>
           </a:p>
           <a:p>
             <a:pPr marL="342900" indent="-342900">
@@ -16162,14 +16162,14 @@
               <a:buChar char="•"/>
             </a:pPr>
             <a:r>
-              <a:rPr lang="en-US" sz="1300" dirty="0">
+              <a:rPr lang="en-US" sz="1400" dirty="0">
                 <a:solidFill>
                   <a:schemeClr val="tx1"/>
                 </a:solidFill>
               </a:rPr>
               <a:t>Kalender ketersediaan terbuka untuk umum</a:t>
             </a:r>
-            <a:endParaRPr lang="en-US" sz="1300" dirty="0"/>
+            <a:endParaRPr lang="en-US" sz="1400" dirty="0"/>
           </a:p>
           <a:p>
             <a:pPr marL="342900" indent="-342900">
@@ -16180,14 +16180,14 @@
               <a:buChar char="•"/>
             </a:pPr>
             <a:r>
-              <a:rPr lang="en-US" sz="1300" dirty="0">
+              <a:rPr lang="en-US" sz="1400" dirty="0">
                 <a:solidFill>
                   <a:schemeClr val="tx1"/>
                 </a:solidFill>
               </a:rPr>
               <a:t>Hanya keterpakaian slot; tanpa identitas atau kontak pemohon</a:t>
             </a:r>
-            <a:endParaRPr lang="en-US" sz="1300" dirty="0"/>
+            <a:endParaRPr lang="en-US" sz="1400" dirty="0"/>
           </a:p>
         </p:txBody>
       </p:sp>
@@ -16355,14 +16355,14 @@
               <a:buChar char="•"/>
             </a:pPr>
             <a:r>
-              <a:rPr lang="en-US" sz="1300" dirty="0">
+              <a:rPr lang="en-US" sz="1400" dirty="0">
                 <a:solidFill>
                   <a:schemeClr val="bg1"/>
                 </a:solidFill>
               </a:rPr>
               <a:t>48 telah selesai diproses</a:t>
             </a:r>
-            <a:endParaRPr lang="en-US" sz="1300" dirty="0"/>
+            <a:endParaRPr lang="en-US" sz="1400" dirty="0"/>
           </a:p>
           <a:p>
             <a:pPr marL="342900" indent="-342900">
@@ -16373,14 +16373,14 @@
               <a:buChar char="•"/>
             </a:pPr>
             <a:r>
-              <a:rPr lang="en-US" sz="1300" dirty="0">
+              <a:rPr lang="en-US" sz="1400" dirty="0">
                 <a:solidFill>
                   <a:schemeClr val="bg1"/>
                 </a:solidFill>
               </a:rPr>
               <a:t>31 di antaranya menjadi agenda Pimpinan</a:t>
             </a:r>
-            <a:endParaRPr lang="en-US" sz="1300" dirty="0"/>
+            <a:endParaRPr lang="en-US" sz="1400" dirty="0"/>
           </a:p>
           <a:p>
             <a:pPr marL="342900" indent="-342900">
@@ -16391,14 +16391,14 @@
               <a:buChar char="•"/>
             </a:pPr>
             <a:r>
-              <a:rPr lang="en-US" sz="1300" dirty="0">
+              <a:rPr lang="en-US" sz="1400" dirty="0">
                 <a:solidFill>
                   <a:schemeClr val="bg1"/>
                 </a:solidFill>
               </a:rPr>
               <a:t>Pemberitahuan berjenjang; Pimpinan tidak diganggu per permohonan</a:t>
             </a:r>
-            <a:endParaRPr lang="en-US" sz="1300" dirty="0"/>
+            <a:endParaRPr lang="en-US" sz="1400" dirty="0"/>
           </a:p>
         </p:txBody>
       </p:sp>

</xml_diff>

<commit_message>
Lomba Kaltara: slide 2 tabel cara kerja lama lebih ringkas
Baris terakhir menjadi "Pengajuan → tayang" (satu baris) dan tinggi baris
dikurangi, sehingga tabel tidak memanjang ke kaki slide.

Co-Authored-By: Claude Opus 5.5 <noreply@anthropic.com>
Claude-Session: https://claude.ai/code/session_01TchDZWsQsgeuq52sKmozd1
</commit_message>
<xml_diff>
--- a/docs/lomba/kaltara/Paparan-Prokopim-Hibot-Kaltara-2026.pptx
+++ b/docs/lomba/kaltara/Paparan-Prokopim-Hibot-Kaltara-2026.pptx
@@ -120,56 +120,56 @@
   <p:extLst>
     <p:ext uri="{521415D9-36F7-43E2-AB2F-B90AF26B5E84}">
       <p14:sectionLst xmlns:p14="http://schemas.microsoft.com/office/powerpoint/2010/main">
-        <p14:section name="Pembuka" id="{a9f2cc64-228c-f840-6ca2-18a47224f42c}">
+        <p14:section name="Pembuka" id="{51cf0cad-da0b-ac28-c27f-16a22d223971}">
           <p14:sldIdLst>
             <p14:sldId id="256"/>
           </p14:sldIdLst>
         </p14:section>
-        <p14:section name="Latar belakang" id="{eab581e2-7239-2846-5987-441c711149d2}">
+        <p14:section name="Latar belakang" id="{f6cc05e3-d649-c4a8-416d-9ba99c1b86e6}">
           <p14:sldIdLst>
             <p14:sldId id="257"/>
             <p14:sldId id="258"/>
           </p14:sldIdLst>
         </p14:section>
-        <p14:section name="Terobosan inovasi" id="{fc4b64ef-e8d3-c890-c4a9-17a9643ab68c}">
+        <p14:section name="Terobosan inovasi" id="{e397a59b-c2fd-9c92-5a49-4fd15cca0fd1}">
           <p14:sldIdLst>
             <p14:sldId id="259"/>
             <p14:sldId id="260"/>
           </p14:sldIdLst>
         </p14:section>
-        <p14:section name="Manfaat inovasi" id="{eec40268-1589-7b54-de0d-d6a606a90916}">
+        <p14:section name="Manfaat inovasi" id="{45b38ebb-c7b5-1213-c831-577559f461f2}">
           <p14:sldIdLst>
             <p14:sldId id="261"/>
             <p14:sldId id="262"/>
             <p14:sldId id="263"/>
           </p14:sldIdLst>
         </p14:section>
-        <p14:section name="Fitur lain: kanal publik" id="{b00138ce-8f9f-a8db-a932-8b97b3017a28}">
+        <p14:section name="Fitur lain: kanal publik" id="{32e5240d-25bb-7570-f808-ddbe7d0029a7}">
           <p14:sldIdLst>
             <p14:sldId id="264"/>
           </p14:sldIdLst>
         </p14:section>
-        <p14:section name="Pemanfaatan sumber daya" id="{02547ae8-9921-4853-6b5d-b90d4834d32e}">
+        <p14:section name="Pemanfaatan sumber daya" id="{bea47bc6-ab4b-a184-b507-4c9abb85b3a3}">
           <p14:sldIdLst>
             <p14:sldId id="265"/>
           </p14:sldIdLst>
         </p14:section>
-        <p14:section name="Diseminasi inovasi" id="{aeba8a88-bb9c-323c-9efb-9ee77021b5d7}">
+        <p14:section name="Diseminasi inovasi" id="{f59c59fb-89eb-5573-b811-e775065e8030}">
           <p14:sldIdLst>
             <p14:sldId id="266"/>
           </p14:sldIdLst>
         </p14:section>
-        <p14:section name="Kompatibilitas" id="{637262c2-39ba-fe84-e005-46fa3bb73921}">
+        <p14:section name="Kompatibilitas" id="{241a1636-1690-4514-2a92-e5abb61fcb8b}">
           <p14:sldIdLst>
             <p14:sldId id="267"/>
           </p14:sldIdLst>
         </p14:section>
-        <p14:section name="Penutup" id="{687a0048-6a32-7a26-86c0-d8c4f8691f3e}">
+        <p14:section name="Penutup" id="{a0f7488c-d2d8-61ff-daab-5c19aad7d240}">
           <p14:sldIdLst>
             <p14:sldId id="268"/>
           </p14:sldIdLst>
         </p14:section>
-        <p14:section name="Cadangan penjelasan" id="{c0b9a3a2-7edc-3903-5edb-ffecd33460cf}">
+        <p14:section name="Cadangan penjelasan" id="{ac82f500-d1cb-6ee5-d65b-7677500ccd7e}">
           <p14:sldIdLst>
             <p14:sldId id="269"/>
           </p14:sldIdLst>
@@ -8479,7 +8479,7 @@
         </p:nvSpPr>
         <p:spPr>
           <a:xfrm>
-            <a:off x="548640" y="5440680"/>
+            <a:off x="548640" y="5349240"/>
             <a:ext cx="4480560" cy="640080"/>
           </a:xfrm>
           <a:prstGeom prst="rect">
@@ -8569,7 +8569,7 @@
                 <a:gridCol w="2331720"/>
                 <a:gridCol w="3642055"/>
               </a:tblGrid>
-              <a:tr h="566928">
+              <a:tr h="512064">
                 <a:tc>
                   <a:txBody>
                     <a:bodyPr/>
@@ -8659,7 +8659,7 @@
                   </a:tcPr>
                 </a:tc>
               </a:tr>
-              <a:tr h="566928">
+              <a:tr h="512064">
                 <a:tc>
                   <a:txBody>
                     <a:bodyPr/>
@@ -8749,7 +8749,7 @@
                   </a:tcPr>
                 </a:tc>
               </a:tr>
-              <a:tr h="566928">
+              <a:tr h="512064">
                 <a:tc>
                   <a:txBody>
                     <a:bodyPr/>
@@ -8839,7 +8839,7 @@
                   </a:tcPr>
                 </a:tc>
               </a:tr>
-              <a:tr h="566928">
+              <a:tr h="512064">
                 <a:tc>
                   <a:txBody>
                     <a:bodyPr/>
@@ -8929,7 +8929,7 @@
                   </a:tcPr>
                 </a:tc>
               </a:tr>
-              <a:tr h="566928">
+              <a:tr h="512064">
                 <a:tc>
                   <a:txBody>
                     <a:bodyPr/>
@@ -9019,7 +9019,7 @@
                   </a:tcPr>
                 </a:tc>
               </a:tr>
-              <a:tr h="566928">
+              <a:tr h="512064">
                 <a:tc>
                   <a:txBody>
                     <a:bodyPr/>
@@ -9037,7 +9037,7 @@
                           <a:ea typeface="Arial" pitchFamily="34" charset="-122"/>
                           <a:cs typeface="Arial" pitchFamily="34" charset="-120"/>
                         </a:rPr>
-                        <a:t>Dari undangan sampai tayang</a:t>
+                        <a:t>Pengajuan → tayang</a:t>
                       </a:r>
                       <a:endParaRPr lang="en-US" sz="1400" dirty="0">
                         <a:latin typeface="Arial" charset="0"/>

</xml_diff>

<commit_message>
Lomba Kaltara: "hemat kertas" di paparan dan narasi video
Slide 7 mendapat kartu "Hemat kertas" (tanpa cetak ulang RK; 452 undangan
terarsip digital). Narasi adegan 8 dan 10 menyebut tanpa cetak ulang dan
daftar hadir tanpa kertas. Angka hanya dari proposal; tidak ada perkiraan
jumlah lembar yang dikarang.

Co-Authored-By: Claude Opus 5.5 <noreply@anthropic.com>
Claude-Session: https://claude.ai/code/session_01TchDZWsQsgeuq52sKmozd1
</commit_message>
<xml_diff>
--- a/docs/lomba/kaltara/Paparan-Prokopim-Hibot-Kaltara-2026.pptx
+++ b/docs/lomba/kaltara/Paparan-Prokopim-Hibot-Kaltara-2026.pptx
@@ -120,56 +120,56 @@
   <p:extLst>
     <p:ext uri="{521415D9-36F7-43E2-AB2F-B90AF26B5E84}">
       <p14:sectionLst xmlns:p14="http://schemas.microsoft.com/office/powerpoint/2010/main">
-        <p14:section name="Pembuka" id="{51cf0cad-da0b-ac28-c27f-16a22d223971}">
+        <p14:section name="Pembuka" id="{41eda60c-a636-814b-cfa3-39ce78766800}">
           <p14:sldIdLst>
             <p14:sldId id="256"/>
           </p14:sldIdLst>
         </p14:section>
-        <p14:section name="Latar belakang" id="{f6cc05e3-d649-c4a8-416d-9ba99c1b86e6}">
+        <p14:section name="Latar belakang" id="{1ce1bfc6-5a9d-2767-162b-eb5768654b95}">
           <p14:sldIdLst>
             <p14:sldId id="257"/>
             <p14:sldId id="258"/>
           </p14:sldIdLst>
         </p14:section>
-        <p14:section name="Terobosan inovasi" id="{e397a59b-c2fd-9c92-5a49-4fd15cca0fd1}">
+        <p14:section name="Terobosan inovasi" id="{434145d3-6236-b5e1-3057-2bec91efd0fa}">
           <p14:sldIdLst>
             <p14:sldId id="259"/>
             <p14:sldId id="260"/>
           </p14:sldIdLst>
         </p14:section>
-        <p14:section name="Manfaat inovasi" id="{45b38ebb-c7b5-1213-c831-577559f461f2}">
+        <p14:section name="Manfaat inovasi" id="{1118b31b-e1ef-3c75-c13e-970342e0f0f0}">
           <p14:sldIdLst>
             <p14:sldId id="261"/>
             <p14:sldId id="262"/>
             <p14:sldId id="263"/>
           </p14:sldIdLst>
         </p14:section>
-        <p14:section name="Fitur lain: kanal publik" id="{32e5240d-25bb-7570-f808-ddbe7d0029a7}">
+        <p14:section name="Fitur lain: kanal publik" id="{7a88ccb9-463f-716c-2e6b-af2e7fe56121}">
           <p14:sldIdLst>
             <p14:sldId id="264"/>
           </p14:sldIdLst>
         </p14:section>
-        <p14:section name="Pemanfaatan sumber daya" id="{bea47bc6-ab4b-a184-b507-4c9abb85b3a3}">
+        <p14:section name="Pemanfaatan sumber daya" id="{9dd06105-cc4b-b5c2-ebc4-80b9048a42d7}">
           <p14:sldIdLst>
             <p14:sldId id="265"/>
           </p14:sldIdLst>
         </p14:section>
-        <p14:section name="Diseminasi inovasi" id="{f59c59fb-89eb-5573-b811-e775065e8030}">
+        <p14:section name="Diseminasi inovasi" id="{066f4c46-908b-52c8-a2f3-4484cd8d8946}">
           <p14:sldIdLst>
             <p14:sldId id="266"/>
           </p14:sldIdLst>
         </p14:section>
-        <p14:section name="Kompatibilitas" id="{241a1636-1690-4514-2a92-e5abb61fcb8b}">
+        <p14:section name="Kompatibilitas" id="{405da916-c68d-7ade-65ad-2b49e72530d7}">
           <p14:sldIdLst>
             <p14:sldId id="267"/>
           </p14:sldIdLst>
         </p14:section>
-        <p14:section name="Penutup" id="{a0f7488c-d2d8-61ff-daab-5c19aad7d240}">
+        <p14:section name="Penutup" id="{7e0a71d5-f30d-46be-d4c9-6256709caed2}">
           <p14:sldIdLst>
             <p14:sldId id="268"/>
           </p14:sldIdLst>
         </p14:section>
-        <p14:section name="Cadangan penjelasan" id="{ac82f500-d1cb-6ee5-d65b-7677500ccd7e}">
+        <p14:section name="Cadangan penjelasan" id="{bcf9a5bc-d8fd-9d6d-b7d7-96af8f09e53a}">
           <p14:sldIdLst>
             <p14:sldId id="269"/>
           </p14:sldIdLst>
@@ -1546,7 +1546,7 @@
           <a:p>
             <a:r>
               <a:rPr lang="en-US" dirty="0"/>
-              <a:t>Baca dari kiri ke kanan: sebelumnya diperkirakan 18–24 jam (tidak pernah dicatat), sekarang median 1,99 jam yang terukur, dan 99,3% tayang kurang dari sehari. Sebutkan tiga angka saja: 1,99 jam, 99,3%, dan 47,5% penelaahan di luar jam kerja (405 dari 852), artinya pekerjaan tidak lagi menunggu jendela 30 menit. Jejak audit: 3.072 peristiwa pada 438 kegiatan; penugasan petugas pada 92,4% kegiatan. (±50 detik)</a:t>
+              <a:t>Baca dari kiri ke kanan: sebelumnya diperkirakan 18–24 jam (tidak pernah dicatat), sekarang median 1,99 jam yang terukur, dan 99,3% tayang kurang dari sehari. Sebutkan tiga angka saja: 1,99 jam, 99,3%, dan 47,5% penelaahan di luar jam kerja (405 dari 852), artinya pekerjaan tidak lagi menunggu jendela 30 menit. Jejak audit: 3.072 peristiwa pada 438 kegiatan; penugasan petugas pada 92,4% kegiatan. Tutup dengan hemat kertas: rencana kegiatan tidak lagi dicetak ulang setiap ada perubahan, 452 berkas undangan terarsip digital, daftar hadir dan persetujuan cukup di layar. (±50 detik)</a:t>
             </a:r>
             <a:endParaRPr lang="en-US" dirty="0"/>
           </a:p>
@@ -14775,7 +14775,7 @@
         <p:spPr>
           <a:xfrm>
             <a:off x="548640" y="4526280"/>
-            <a:ext cx="5486400" cy="320040"/>
+            <a:ext cx="7315200" cy="320040"/>
           </a:xfrm>
           <a:prstGeom prst="rect">
             <a:avLst/>
@@ -14796,7 +14796,7 @@
                   <a:schemeClr val="tx2"/>
                 </a:solidFill>
               </a:rPr>
-              <a:t>Mengapa lebih cepat</a:t>
+              <a:t>Mengapa lebih cepat, dan lebih hemat</a:t>
             </a:r>
             <a:endParaRPr lang="en-US" sz="1500" dirty="0"/>
           </a:p>
@@ -14811,7 +14811,7 @@
         <p:spPr>
           <a:xfrm>
             <a:off x="548640" y="4892040"/>
-            <a:ext cx="3545738" cy="1097280"/>
+            <a:ext cx="2636444" cy="1097280"/>
           </a:xfrm>
           <a:prstGeom prst="roundRect">
             <a:avLst>
@@ -14837,8 +14837,8 @@
         </p:nvSpPr>
         <p:spPr>
           <a:xfrm>
-            <a:off x="749808" y="4983480"/>
-            <a:ext cx="3143402" cy="365760"/>
+            <a:off x="731520" y="4983480"/>
+            <a:ext cx="2270684" cy="365760"/>
           </a:xfrm>
           <a:prstGeom prst="rect">
             <a:avLst/>
@@ -14873,8 +14873,8 @@
         </p:nvSpPr>
         <p:spPr>
           <a:xfrm>
-            <a:off x="749808" y="5349240"/>
-            <a:ext cx="3143402" cy="594360"/>
+            <a:off x="731520" y="5349240"/>
+            <a:ext cx="2270684" cy="594360"/>
           </a:xfrm>
           <a:prstGeom prst="rect">
             <a:avLst/>
@@ -14895,7 +14895,7 @@
                   <a:schemeClr val="tx1"/>
                 </a:solidFill>
               </a:rPr>
-              <a:t>telaah dan persetujuan bisa dilakukan kapan saja, dari mana saja</a:t>
+              <a:t>telaah dan persetujuan kapan saja, dari mana saja</a:t>
             </a:r>
             <a:endParaRPr lang="en-US" sz="1400" dirty="0"/>
           </a:p>
@@ -14909,8 +14909,8 @@
         </p:nvSpPr>
         <p:spPr>
           <a:xfrm>
-            <a:off x="4322978" y="4892040"/>
-            <a:ext cx="3545738" cy="1097280"/>
+            <a:off x="3367964" y="4892040"/>
+            <a:ext cx="2636444" cy="1097280"/>
           </a:xfrm>
           <a:prstGeom prst="roundRect">
             <a:avLst>
@@ -14936,8 +14936,8 @@
         </p:nvSpPr>
         <p:spPr>
           <a:xfrm>
-            <a:off x="4524146" y="4983480"/>
-            <a:ext cx="3143402" cy="365760"/>
+            <a:off x="3550844" y="4983480"/>
+            <a:ext cx="2270684" cy="365760"/>
           </a:xfrm>
           <a:prstGeom prst="rect">
             <a:avLst/>
@@ -14972,8 +14972,8 @@
         </p:nvSpPr>
         <p:spPr>
           <a:xfrm>
-            <a:off x="4524146" y="5349240"/>
-            <a:ext cx="3143402" cy="594360"/>
+            <a:off x="3550844" y="5349240"/>
+            <a:ext cx="2270684" cy="594360"/>
           </a:xfrm>
           <a:prstGeom prst="rect">
             <a:avLst/>
@@ -14994,7 +14994,7 @@
                   <a:schemeClr val="tx1"/>
                 </a:solidFill>
               </a:rPr>
-              <a:t>tidak ada versi ganda, foto disposisi, atau grup yang harus ditelusuri</a:t>
+              <a:t>tanpa versi ganda, foto disposisi, atau grup</a:t>
             </a:r>
             <a:endParaRPr lang="en-US" sz="1400" dirty="0"/>
           </a:p>
@@ -15008,8 +15008,8 @@
         </p:nvSpPr>
         <p:spPr>
           <a:xfrm>
-            <a:off x="8097317" y="4892040"/>
-            <a:ext cx="3545738" cy="1097280"/>
+            <a:off x="6187288" y="4892040"/>
+            <a:ext cx="2636444" cy="1097280"/>
           </a:xfrm>
           <a:prstGeom prst="roundRect">
             <a:avLst>
@@ -15035,8 +15035,8 @@
         </p:nvSpPr>
         <p:spPr>
           <a:xfrm>
-            <a:off x="8298485" y="4983480"/>
-            <a:ext cx="3143402" cy="365760"/>
+            <a:off x="6370168" y="4983480"/>
+            <a:ext cx="2270684" cy="365760"/>
           </a:xfrm>
           <a:prstGeom prst="rect">
             <a:avLst/>
@@ -15071,8 +15071,8 @@
         </p:nvSpPr>
         <p:spPr>
           <a:xfrm>
-            <a:off x="8298485" y="5349240"/>
-            <a:ext cx="3143402" cy="594360"/>
+            <a:off x="6370168" y="5349240"/>
+            <a:ext cx="2270684" cy="594360"/>
           </a:xfrm>
           <a:prstGeom prst="rect">
             <a:avLst/>
@@ -15093,7 +15093,7 @@
                   <a:schemeClr val="tx1"/>
                 </a:solidFill>
               </a:rPr>
-              <a:t>kekeliruan tertahan sebelum tayang, bukan sesudahnya</a:t>
+              <a:t>kekeliruan tertahan sebelum tayang</a:t>
             </a:r>
             <a:endParaRPr lang="en-US" sz="1400" dirty="0"/>
           </a:p>
@@ -15101,7 +15101,106 @@
       </p:sp>
       <p:sp>
         <p:nvSpPr>
-          <p:cNvPr id="34" name="Text 32"/>
+          <p:cNvPr id="34" name="sebab4"/>
+          <p:cNvSpPr/>
+          <p:nvPr/>
+        </p:nvSpPr>
+        <p:spPr>
+          <a:xfrm>
+            <a:off x="9006611" y="4892040"/>
+            <a:ext cx="2636444" cy="1097280"/>
+          </a:xfrm>
+          <a:prstGeom prst="roundRect">
+            <a:avLst>
+              <a:gd name="adj" fmla="val 10000"/>
+            </a:avLst>
+          </a:prstGeom>
+          <a:solidFill>
+            <a:srgbClr val="ECFDF5"/>
+          </a:solidFill>
+          <a:ln w="19050">
+            <a:solidFill>
+              <a:schemeClr val="accent3"/>
+            </a:solidFill>
+            <a:prstDash val="solid"/>
+          </a:ln>
+        </p:spPr>
+      </p:sp>
+      <p:sp>
+        <p:nvSpPr>
+          <p:cNvPr id="35" name="Text 33"/>
+          <p:cNvSpPr txBox="1"/>
+          <p:nvPr/>
+        </p:nvSpPr>
+        <p:spPr>
+          <a:xfrm>
+            <a:off x="9189491" y="4983480"/>
+            <a:ext cx="2270684" cy="365760"/>
+          </a:xfrm>
+          <a:prstGeom prst="rect">
+            <a:avLst/>
+          </a:prstGeom>
+          <a:noFill/>
+          <a:ln/>
+        </p:spPr>
+        <p:txBody>
+          <a:bodyPr wrap="square" lIns="0" tIns="0" rIns="0" bIns="0" rtlCol="0" anchor="ctr"/>
+          <a:lstStyle/>
+          <a:p>
+            <a:pPr indent="0" marL="0">
+              <a:buNone/>
+            </a:pPr>
+            <a:r>
+              <a:rPr lang="en-US" sz="1400" b="1" dirty="0">
+                <a:solidFill>
+                  <a:schemeClr val="accent3"/>
+                </a:solidFill>
+              </a:rPr>
+              <a:t>Hemat kertas</a:t>
+            </a:r>
+            <a:endParaRPr lang="en-US" sz="1400" dirty="0"/>
+          </a:p>
+        </p:txBody>
+      </p:sp>
+      <p:sp>
+        <p:nvSpPr>
+          <p:cNvPr id="36" name="Text 34"/>
+          <p:cNvSpPr txBox="1"/>
+          <p:nvPr/>
+        </p:nvSpPr>
+        <p:spPr>
+          <a:xfrm>
+            <a:off x="9189491" y="5349240"/>
+            <a:ext cx="2270684" cy="594360"/>
+          </a:xfrm>
+          <a:prstGeom prst="rect">
+            <a:avLst/>
+          </a:prstGeom>
+          <a:noFill/>
+          <a:ln/>
+        </p:spPr>
+        <p:txBody>
+          <a:bodyPr wrap="square" lIns="0" tIns="0" rIns="0" bIns="0" rtlCol="0" anchor="t"/>
+          <a:lstStyle/>
+          <a:p>
+            <a:pPr indent="0" marL="0">
+              <a:buNone/>
+            </a:pPr>
+            <a:r>
+              <a:rPr lang="en-US" sz="1400" dirty="0">
+                <a:solidFill>
+                  <a:schemeClr val="tx1"/>
+                </a:solidFill>
+              </a:rPr>
+              <a:t>Tanpa cetak ulang RK; 452 undangan terarsip digital</a:t>
+            </a:r>
+            <a:endParaRPr lang="en-US" sz="1400" dirty="0"/>
+          </a:p>
+        </p:txBody>
+      </p:sp>
+      <p:sp>
+        <p:nvSpPr>
+          <p:cNvPr id="37" name="Text 35"/>
           <p:cNvSpPr txBox="1"/>
           <p:nvPr/>
         </p:nvSpPr>

</xml_diff>

<commit_message>
Lomba Kaltara: koreksi menjadi dua lembar, kategori di paparan, naskah paparan 10 menit
- Adegan 1 video dan slide 2: dua lembar (rencana kegiatan sampai, rencana
  audiensi tertinggal), sesuai lembar aslinya; slide 14 memuat koreksi data
  terhadap proposal.
- Slide 1 menonjolkan kategori Inovasi Terapan – ASN Pemerintah
  Kabupaten/Kota; kaki slide memakai nama kategori lengkap.
- Naskah bicara paparan (target 9:15) dengan dialog demo, tanya jawab, dan
  panduan latihan; teks yang sama menjadi catatan pembicara PPTX.

Co-Authored-By: Claude Opus 5.5 <noreply@anthropic.com>
Claude-Session: https://claude.ai/code/session_01TchDZWsQsgeuq52sKmozd1
</commit_message>
<xml_diff>
--- a/docs/lomba/kaltara/Paparan-Prokopim-Hibot-Kaltara-2026.pptx
+++ b/docs/lomba/kaltara/Paparan-Prokopim-Hibot-Kaltara-2026.pptx
@@ -120,56 +120,56 @@
   <p:extLst>
     <p:ext uri="{521415D9-36F7-43E2-AB2F-B90AF26B5E84}">
       <p14:sectionLst xmlns:p14="http://schemas.microsoft.com/office/powerpoint/2010/main">
-        <p14:section name="Pembuka" id="{41eda60c-a636-814b-cfa3-39ce78766800}">
+        <p14:section name="Pembuka" id="{22b31861-89e8-529c-3ddd-68de11282f5a}">
           <p14:sldIdLst>
             <p14:sldId id="256"/>
           </p14:sldIdLst>
         </p14:section>
-        <p14:section name="Latar belakang" id="{1ce1bfc6-5a9d-2767-162b-eb5768654b95}">
+        <p14:section name="Latar belakang" id="{c62de004-ec85-8b49-21d5-5eac92a678b4}">
           <p14:sldIdLst>
             <p14:sldId id="257"/>
             <p14:sldId id="258"/>
           </p14:sldIdLst>
         </p14:section>
-        <p14:section name="Terobosan inovasi" id="{434145d3-6236-b5e1-3057-2bec91efd0fa}">
+        <p14:section name="Terobosan inovasi" id="{b51b8a1c-4ce1-ad87-c9f8-91a5fb530d90}">
           <p14:sldIdLst>
             <p14:sldId id="259"/>
             <p14:sldId id="260"/>
           </p14:sldIdLst>
         </p14:section>
-        <p14:section name="Manfaat inovasi" id="{1118b31b-e1ef-3c75-c13e-970342e0f0f0}">
+        <p14:section name="Manfaat inovasi" id="{766c32ba-9e80-3efd-661d-74e82d4b46a8}">
           <p14:sldIdLst>
             <p14:sldId id="261"/>
             <p14:sldId id="262"/>
             <p14:sldId id="263"/>
           </p14:sldIdLst>
         </p14:section>
-        <p14:section name="Fitur lain: kanal publik" id="{7a88ccb9-463f-716c-2e6b-af2e7fe56121}">
+        <p14:section name="Fitur lain: kanal publik" id="{23628f64-73fd-5023-cc57-7f27981caeb8}">
           <p14:sldIdLst>
             <p14:sldId id="264"/>
           </p14:sldIdLst>
         </p14:section>
-        <p14:section name="Pemanfaatan sumber daya" id="{9dd06105-cc4b-b5c2-ebc4-80b9048a42d7}">
+        <p14:section name="Pemanfaatan sumber daya" id="{c1e47e3a-038c-c442-c240-f212efb985b6}">
           <p14:sldIdLst>
             <p14:sldId id="265"/>
           </p14:sldIdLst>
         </p14:section>
-        <p14:section name="Diseminasi inovasi" id="{066f4c46-908b-52c8-a2f3-4484cd8d8946}">
+        <p14:section name="Diseminasi inovasi" id="{2d2e970c-e0e4-87e2-9e3f-1a70f75e9683}">
           <p14:sldIdLst>
             <p14:sldId id="266"/>
           </p14:sldIdLst>
         </p14:section>
-        <p14:section name="Kompatibilitas" id="{405da916-c68d-7ade-65ad-2b49e72530d7}">
+        <p14:section name="Kompatibilitas" id="{ba8ac8fb-48fb-1330-b201-54c89ef97fdd}">
           <p14:sldIdLst>
             <p14:sldId id="267"/>
           </p14:sldIdLst>
         </p14:section>
-        <p14:section name="Penutup" id="{7e0a71d5-f30d-46be-d4c9-6256709caed2}">
+        <p14:section name="Penutup" id="{65a6dd3a-cd16-f7c7-d5eb-61f926578fd3}">
           <p14:sldIdLst>
             <p14:sldId id="268"/>
           </p14:sldIdLst>
         </p14:section>
-        <p14:section name="Cadangan penjelasan" id="{bcf9a5bc-d8fd-9d6d-b7d7-96af8f09e53a}">
+        <p14:section name="Cadangan penjelasan" id="{a7a31cc3-34aa-1c7c-2df8-d4855af55963}">
           <p14:sldIdLst>
             <p14:sldId id="269"/>
           </p14:sldIdLst>
@@ -578,7 +578,10 @@
           <a:p>
             <a:r>
               <a:rPr lang="en-US" dirty="0"/>
-              <a:t>Izin kami sampaikan Prokopim Hibot, satu alur digital terverifikasi untuk agenda Pimpinan Daerah. (±20 detik)</a:t>
+              <a:t>0:00–0:25 · Pembuka
+Assalamualaikum warahmatullahi wabarakatuh. Selamat [pagi/siang], Bapak dan Ibu Dewan Juri yang kami hormati.
+Izin kami sampaikan Prokopim Hibot, satu alur digital terverifikasi untuk agenda Pimpinan Daerah, dari Bagian Protokol dan Komunikasi Pimpinan, Sekretariat Daerah Kota Tarakan. Kami mengikuti kategori Inovasi Terapan, ASN Pemerintah Kabupaten/Kota.
+Isyarat: Berdiri tegak, tatap juri, senyum. Jangan buru-buru; kalimat pertama menentukan kesan.</a:t>
             </a:r>
             <a:endParaRPr lang="en-US" dirty="0"/>
           </a:p>
@@ -666,7 +669,10 @@
           <a:p>
             <a:r>
               <a:rPr lang="en-US" dirty="0"/>
-              <a:t>Jawab lebih dulu pertanyaan 'bila Kabag dimutasi': kewenangan melekat pada jabatan, 11 SOP, kode dan riwayat tersimpan lengkap, akun layanan atas nama instansi, pengelola kedua didampingi mulai 2027. Biaya berjalan mendekati nol. (±40 detik)</a:t>
+              <a:t>7:25–7:55 · Pemanfaatan sumber daya
+Seluruhnya dibangun tim sendiri, tanpa belanja pengadaan, dengan layanan tanpa biaya.
+Bagaimana bila pengelolanya pindah? Kewenangan melekat pada jabatan, sebelas SOP disiapkan, kode dan riwayat tersimpan lengkap atas nama instansi, dan pengelola kedua didampingi mulai 2027.
+Isyarat: Pertanyaan 'bila Kabag pindah' hampir pasti muncul; dengan menjawabnya lebih dulu, Bapak menguasai arah tanya jawab.</a:t>
             </a:r>
             <a:endParaRPr lang="en-US" dirty="0"/>
           </a:p>
@@ -754,7 +760,10 @@
           <a:p>
             <a:r>
               <a:rPr lang="en-US" dirty="0"/>
-              <a:t>Penyebarluasan: 21 akun di luar Bagian, kanal publik dipakai 66 dan 53 instansi, Tim Koordinasi lintas perangkat daerah. Inovasi ini siap direplikasi sesuai kebutuhan: yang disesuaikan hanya nama jabatan, pengguna, dan tata naskah. Sebelas SOP disahkan Sekretaris Daerah pada Oktober–Desember 2026, disesuaikan dengan nomenklatur baru. (±30 detik)</a:t>
+              <a:t>7:55–8:25 · Diseminasi
+Pemakaiannya sudah melampaui Bagian kami: Pimpinan, ajudan, pengawal, mitra di DKISP, dan Tim Koordinasi lintas perangkat daerah.
+Inovasi ini siap direplikasi sesuai kebutuhan; yang disesuaikan hanya nama jabatan, pengguna, dan tata naskah. Sebelas SOP disahkan Sekretaris Daerah pada Oktober sampai Desember 2026.
+Isyarat: Sebut 'siap direplikasi' dengan yakin; jangan menjanjikan daerah tertentu.</a:t>
             </a:r>
             <a:endParaRPr lang="en-US" dirty="0"/>
           </a:p>
@@ -842,7 +851,10 @@
           <a:p>
             <a:r>
               <a:rPr lang="en-US" dirty="0"/>
-              <a:t>Kompatibilitas: dasar regulasi pelayanan publik, keprotokolan, inovasi daerah, SPBE; selaras Misi 3 RPJMD Kaltara dan Misi 4 Kota Tarakan. Aplikasi menyesuaikan cara kerja Pimpinan — contohnya naskah sambutan tetap tercetak. (±30 detik)</a:t>
+              <a:t>8:25–8:50 · Kompatibilitas
+Inovasi ini selaras dengan Undang-Undang Pelayanan Publik dan Keprotokolan, Peraturan Pemerintah tentang Inovasi Daerah, dan SPBE, serta mendukung Misi 3 RPJMD Kalimantan Utara dan Misi 4 Kota Tarakan.
+Aplikasi menyesuaikan cara kerja Pimpinan, bukan sebaliknya: naskah sambutan tetap tersedia tercetak.
+Isyarat: Cukup sebut garis besar; nomor peraturan sudah tertulis di slide.</a:t>
             </a:r>
             <a:endParaRPr lang="en-US" dirty="0"/>
           </a:p>
@@ -930,7 +942,10 @@
           <a:p>
             <a:r>
               <a:rPr lang="en-US" dirty="0"/>
-              <a:t>Penutup: 'Satu alur. Satu data. Setiap keputusan tercatat.' Terima kasih. Tawarkan akun juri baca-saja bila juri ingin mencoba.</a:t>
+              <a:t>8:50–9:15 · Penutup
+Bapak dan Ibu Dewan Juri, Januari lalu satu lembar tertinggal tanpa ada yang tahu. Hari ini, setiap lembar dan setiap keputusan tercatat.
+Prokopim Hibot: satu alur, satu data, setiap keputusan tercatat. Terima kasih. Wassalamualaikum warahmatullahi wabarakatuh.
+Isyarat: Ucapkan slogan perlahan, satu frasa satu tarikan napas, lalu diam dan tatap juri. Jangan menambah kalimat sesudah 'terima kasih'.</a:t>
             </a:r>
             <a:endParaRPr lang="en-US" dirty="0"/>
           </a:p>
@@ -1018,7 +1033,10 @@
           <a:p>
             <a:r>
               <a:rPr lang="en-US" dirty="0"/>
-              <a:t>Gunakan hanya bila juri menanyakan perbedaan dengan proposal. Jujur dan ringkas: pengingat lima kali sehari dirampingkan menjadi tiga waktu berdasarkan data pemakaian; WhatsApp hanya untuk acara hari ini atau besok; notifikasi tamu berjenjang; Monitor WA; masuk dengan sidik jari dan Google; jam acara berzona. Semua pembaruan berangkat dari kendala pengguna dan tanpa belanja pengadaan.</a:t>
+              <a:t>—–— · CADANGAN: bila ditanya perbedaan dengan proposal
+Proposal memuat keadaan per 24 September 2026. Pembaruan Oktober 2026 berangkat dari pemakaian: pengingat dirampingkan menjadi tiga waktu, WhatsApp hanya untuk acara hari ini atau besok, notifikasi tamu berjenjang, Monitor WA, masuk dengan sidik jari dan akun Google, dan jam acara mengikuti zona waktu.
+Koreksi data: di proposal kami menulis tiga lembar berdasarkan ingatan. Saat menyiapkan paparan ini kami menelusuri lembar aslinya; ternyata dua lembar, rencana kegiatan sampai dan rencana audiensi tertinggal. Inilah alasan aplikasi ini dibangun: tanpa catatan, bahkan jumlah lembar pun bergantung pada ingatan.
+Isyarat: Tampilkan hanya bila ditanya. Jawab jujur dan tenang; koreksi yang disampaikan terbuka menambah kepercayaan.</a:t>
             </a:r>
             <a:endParaRPr lang="en-US" dirty="0"/>
           </a:p>
@@ -1106,7 +1124,12 @@
           <a:p>
             <a:r>
               <a:rPr lang="en-US" dirty="0"/>
-              <a:t>Januari 2026. Tiga lembar disposisi agenda diturunkan; yang sampai ke kami hanya dua. Tidak ada yang lalai, tetapi tidak ada pula yang bisa mengetahuinya. Sebelum Maret 2026: rencana kegiatan di spreadsheet lalu dicetak, penelaahan hanya sempat sekitar 30 menit menjelang jam pulang, disposisi beredar sebagai foto, penugasan bergantung pada ingatan. (±40 detik)</a:t>
+              <a:t>0:25–1:10 · Latar belakang: peristiwa Januari
+Awal Januari 2026, dua lembar disposisi agenda turun dari meja Pimpinan: rencana kegiatan dan rencana audiensi.
+Yang ini sampai kepada kami, karena difoto dan dikirim ke grup. Yang ini, rencana audiensi untuk Senin, 5 Januari, tertinggal.
+Tidak ada yang lalai. Tetapi tidak ada pula yang bisa mengetahuinya, karena tidak ada catatan berapa lembar yang seharusnya kami terima.
+Saat itu rencana kegiatan disusun di spreadsheet lalu dicetak, penelaahan hanya sempat sekitar 30 menit menjelang jam pulang, disposisi beredar sebagai foto, dan dari pengajuan sampai tayang diperkirakan 18 sampai 24 jam.
+Isyarat: Tunjuk foto atas saat 'yang ini sampai', foto bawah saat 'yang ini tertinggal'. Pelankan suara di 'tidak ada yang lalai', beri jeda sejenak.</a:t>
             </a:r>
             <a:endParaRPr lang="en-US" dirty="0"/>
           </a:p>
@@ -1194,7 +1217,10 @@
           <a:p>
             <a:r>
               <a:rPr lang="en-US" dirty="0"/>
-              <a:t>Telaah bersama seluruh Bagian sesudah peristiwa Januari menemukan pola yang sama di banyak tempat: penugasan tersimpan dalam ingatan, ruangan hanya tercatat di papan tulis, arsip tersebar. Akarnya satu: tidak ada satu sumber data yang sahih. Data pembanding: dari undangan sampai tayang diperkirakan 18–24 jam. (±40 detik)</a:t>
+              <a:t>1:10–1:40 · Akar masalah
+Kami lalu menelaah bersama seluruh Bagian, dan menemukan pola yang sama di banyak tempat: keputusan tidak meninggalkan jejak, beberapa versi cetakan beredar bersamaan, pengetahuan kerja melekat pada orang.
+Akarnya satu: tidak ada satu sumber data yang dapat dirujuk semua pihak.
+Isyarat: Tunjuk kotak 'Akar masalah'. Kalimat terakhir diucapkan pelan dan tegas.</a:t>
             </a:r>
             <a:endParaRPr lang="en-US" dirty="0"/>
           </a:p>
@@ -1282,7 +1308,10 @@
           <a:p>
             <a:r>
               <a:rPr lang="en-US" dirty="0"/>
-              <a:t>Ada empat pilihan. Menambah pengawasan tidak menyentuh akar masalah. Merapikan spreadsheet tetap menyisakan banyak versi. Membeli aplikasi jadi butuh anggaran, padahal alur keprotokolan sangat khas. Kami memilih membangun sendiri. Hasilnya satu alur: Admin RK → Kasubbag → Kabag → tayang di HP Pimpinan. Sebut daftar periksa wajib, Pelaksana Harian, dan kanal publik. (±40 detik)</a:t>
+              <a:t>1:40–2:15 · Terobosan: pilihan dan alur
+Kami menimbang empat pilihan. Menambah pengawasan tidak menyentuh akar masalah. Merapikan spreadsheet tetap menyisakan banyak versi. Membeli aplikasi jadi butuh anggaran, padahal alur keprotokolan sangat khas.
+Maka kami membangun sendiri, tanpa belanja pengadaan. Hasilnya satu alur berjenjang: Admin Rencana Kegiatan, Kepala Sub Bagian, Kepala Bagian, lalu tayang di HP Pimpinan.
+Isyarat: Sapukan tangan dari kiri ke kanan mengikuti empat kartu, lalu empat langkah alur.</a:t>
             </a:r>
             <a:endParaRPr lang="en-US" dirty="0"/>
           </a:p>
@@ -1370,7 +1399,10 @@
           <a:p>
             <a:r>
               <a:rPr lang="en-US" dirty="0"/>
-              <a:t>Kebaruan ada pada cara aplikasi menjaga mutu keputusan: jejak audit, daftar periksa wajib, Pelaksana Harian bermasa berlaku, pengawasan menurut kegentingan, kanal publik terlacak, dan kalender bersama. Sejak proposal, aplikasi terus dikembangkan dari kendala pengguna (sebut bulannya: Oktober 2026). Lalu: 'Izin kami tunjukkan langsung di aplikasi.' → masuk demo. (±30 detik)</a:t>
+              <a:t>2:15–2:40 · Enam unsur kebaruan
+Kebaruannya ada pada cara menjaga mutu keputusan: setiap langkah tercatat, persetujuan baru aktif setelah daftar periksa dicentang, dan kewenangan Pelaksana Harian padam sendiri pada tanggal akhirnya.
+Sejak proposal, aplikasi terus dikembangkan dari kendala pengguna. Izin kami tunjukkan langsung di aplikasi.
+Isyarat: Pada 'izin kami tunjukkan', beri anggukan ke Admin RK: tanda demo dimulai.</a:t>
             </a:r>
             <a:endParaRPr lang="en-US" dirty="0"/>
           </a:p>
@@ -1458,7 +1490,14 @@
           <a:p>
             <a:r>
               <a:rPr lang="en-US" dirty="0"/>
-              <a:t>DEMO 3 menit (menit 2:50–5:50 paparan). Admin RK memegang laptop, Kasubbag dan Kabag memegang HP; Kabag memandu. Semua memakai instans demo berdata contoh. Kanal publik tidak didemokan di sini; ia fitur terpisah (slide 9). Cadangan: video demo luring di laptop dan diska lepas. Admin RK memberi isyarat pada 5:50.</a:t>
+              <a:t>2:40–5:40 · DEMONSTRASI (3 menit)
+(1) Admin RK, laptop · 0:00–0:35 — "Admin kami menerima undangan. Cukup dipindai: nama acara, tanggal, jam, lokasi, dan zona waktunya terisi sendiri. Aplikasi juga memeriksa benturan jadwal. Admin memeriksa, lalu mengirim."
+(2) Kasubbag, HP · 0:35–1:05 — "Kepala Sub Bagian langsung menerima notifikasi, di mana pun berada. Tombol teruskan baru aktif setelah undangan dibuka dan daftar periksa dicentang. Kekeliruan tertahan sebelum sampai ke Pimpinan."
+(3) Kabag, HP · 1:05–1:25 — "Saya memutus dari HP saya. Setujui, dan agenda langsung tayang, tanpa cetak ulang."
+(4) HP Wali Kota · 1:25–2:05 — "Saat itu juga agenda tiba di HP Wali Kota. Beliau atau ajudan cukup menekan Hadir, atau mendisposisikan kepada Wakil Wali Kota. Disposisi inilah yang dulu beredar sebagai foto."
+(5) Admin RK, laptop · 2:05–2:35 — "Petugas ditugaskan dan langsung diberi tahu. Di Riwayat Alur, setiap langkah tadi tercatat: siapa, kapan, dan apa keputusannya."
+(6) Kabag, HP · 2:35–3:00 — "Dan di Monitor WA kami memastikan pesan penugasan itu terkirim dan dibaca. Tidak ada lagi lembar yang tertinggal tanpa ada yang tahu."
+Isyarat: Kabag memandu dan berbicara; Admin RK dan Kasubbag hanya mengoperasikan. Semua memakai instans demo berdata contoh. Bila aplikasi atau jaringan bermasalah lebih dari 10 detik, langsung putar video demo cadangan di laptop. Admin RK memberi isyarat pada menit 5:40.</a:t>
             </a:r>
             <a:endParaRPr lang="en-US" dirty="0"/>
           </a:p>
@@ -1546,7 +1585,11 @@
           <a:p>
             <a:r>
               <a:rPr lang="en-US" dirty="0"/>
-              <a:t>Baca dari kiri ke kanan: sebelumnya diperkirakan 18–24 jam (tidak pernah dicatat), sekarang median 1,99 jam yang terukur, dan 99,3% tayang kurang dari sehari. Sebutkan tiga angka saja: 1,99 jam, 99,3%, dan 47,5% penelaahan di luar jam kerja (405 dari 852), artinya pekerjaan tidak lagi menunggu jendela 30 menit. Jejak audit: 3.072 peristiwa pada 438 kegiatan; penugasan petugas pada 92,4% kegiatan. Tutup dengan hemat kertas: rencana kegiatan tidak lagi dicetak ulang setiap ada perubahan, 452 berkas undangan terarsip digital, daftar hadir dan persetujuan cukup di layar. (±50 detik)</a:t>
+              <a:t>5:40–6:30 · Manfaat terukur
+Hasilnya terukur dari basis data, per 24 September 2026. Dari pengajuan sampai tayang, yang dulu diperkirakan 18 sampai 24 jam, kini median 1,99 jam, dan 99,3 persen tayang kurang dari sehari.
+589 kegiatan terkelola dan 3.072 keputusan terekam. 92,4 persen kegiatan sudah ada petugasnya. Hampir separuh penelaahan, 47,5 persen, dilakukan di luar jam kerja: pekerjaan tidak lagi menunggu jendela 30 menit.
+Dan hemat kertas: rencana kegiatan tidak lagi dicetak ulang, 452 berkas undangan terarsip digital.
+Isyarat: Beri jeda dua detik sesudah '1,99 jam'. Ini angka utama; biarkan juri mencernanya.</a:t>
             </a:r>
             <a:endParaRPr lang="en-US" dirty="0"/>
           </a:p>
@@ -1634,7 +1677,10 @@
           <a:p>
             <a:r>
               <a:rPr lang="en-US" dirty="0"/>
-              <a:t>Bacakan satu kutipan Wali Kota. Lalu: 62 kegiatan didisposisikan langsung dari aplikasi, 341 konfirmasi ajudan, 67 tindakan Pelaksana Harian tercatat, dan notifikasi aktif di 37 perangkat. (±25 detik)</a:t>
+              <a:t>6:30–7:00 · Dirasakan Pimpinan
+Manfaatnya dirasakan langsung oleh Pimpinan. Wali Kota menyampaikan: "Yang terpenting bagi saya adalah kepastian: ke mana saya harus hadir, kapan, dan siapa yang menyiapkannya."
+62 kegiatan telah beliau disposisikan kepada Wakil langsung dari aplikasi, dan ajudan sudah 341 kali mengonfirmasi kehadiran.
+Isyarat: Bacakan kutipan dengan nada hormat dan pelan, sambil menunjuk kotak kutipan.</a:t>
             </a:r>
             <a:endParaRPr lang="en-US" dirty="0"/>
           </a:p>
@@ -1722,7 +1768,9 @@
           <a:p>
             <a:r>
               <a:rPr lang="en-US" dirty="0"/>
-              <a:t>Sampaikan sebagai fitur tersendiri, bukan bagian dari alur agenda. Peminjaman ruangan: 123 pengajuan dari 66 instansi, 98 disetujui. Audiensi: 55 permohonan dari 53 instansi, 48 selesai diproses, 31 menjadi agenda Pimpinan. Pemohon memantau dengan kode penelusuran. Data per 24 September 2026. (±30 detik)</a:t>
+              <a:t>7:00–7:25 · Fitur lain: kanal publik
+Di luar alur agenda, ada fitur tersendiri untuk masyarakat: kanal publik. Tanpa akun, 66 instansi mengajukan peminjaman ruangan dan 53 instansi mengajukan audiensi, lalu memantau statusnya sendiri dengan kode penelusuran, tanpa datang atau menelepon berulang.
+Isyarat: Tegaskan 'fitur tersendiri', supaya juri tidak mencampurnya dengan alur agenda.</a:t>
             </a:r>
             <a:endParaRPr lang="en-US" dirty="0"/>
           </a:p>
@@ -1926,7 +1974,7 @@
                   <a:schemeClr val="accent5"/>
                 </a:solidFill>
               </a:rPr>
-              <a:t>Prokopim Hibot  ·  Kaltara Innovation Awards 2026  ·  Kategori ASN Pemerintah Kabupaten/Kota</a:t>
+              <a:t>Prokopim Hibot  ·  Kaltara Innovation Awards 2026  ·  Kategori Inovasi Terapan – ASN Pemerintah Kabupaten/Kota</a:t>
             </a:r>
             <a:endParaRPr lang="en-US" sz="1000" dirty="0"/>
           </a:p>
@@ -2165,7 +2213,7 @@
                   <a:schemeClr val="accent6"/>
                 </a:solidFill>
               </a:rPr>
-              <a:t>Prokopim Hibot  ·  Kaltara Innovation Awards 2026  ·  Kategori ASN Pemerintah Kabupaten/Kota</a:t>
+              <a:t>Prokopim Hibot  ·  Kaltara Innovation Awards 2026  ·  Kategori Inovasi Terapan – ASN Pemerintah Kabupaten/Kota</a:t>
             </a:r>
             <a:endParaRPr lang="en-US" sz="1000" dirty="0"/>
           </a:p>
@@ -2753,14 +2801,115 @@
       </p:sp>
       <p:sp>
         <p:nvSpPr>
-          <p:cNvPr id="8" name="Text 4"/>
-          <p:cNvSpPr txBox="1"/>
-          <p:nvPr/>
-        </p:nvSpPr>
-        <p:spPr>
-          <a:xfrm>
-            <a:off x="548640" y="4023360"/>
-            <a:ext cx="7132320" cy="685800"/>
+          <p:cNvPr id="8" name="Shape 4"/>
+          <p:cNvSpPr/>
+          <p:nvPr/>
+        </p:nvSpPr>
+        <p:spPr>
+          <a:xfrm>
+            <a:off x="548640" y="3931920"/>
+            <a:ext cx="7498080" cy="658368"/>
+          </a:xfrm>
+          <a:prstGeom prst="roundRect">
+            <a:avLst>
+              <a:gd name="adj" fmla="val 11111"/>
+            </a:avLst>
+          </a:prstGeom>
+          <a:solidFill>
+            <a:schemeClr val="accent1">
+              <a:alpha val="15000"/>
+            </a:schemeClr>
+          </a:solidFill>
+          <a:ln w="15875">
+            <a:solidFill>
+              <a:schemeClr val="accent1"/>
+            </a:solidFill>
+            <a:prstDash val="solid"/>
+          </a:ln>
+        </p:spPr>
+      </p:sp>
+      <p:sp>
+        <p:nvSpPr>
+          <p:cNvPr id="9" name="Text 5"/>
+          <p:cNvSpPr txBox="1"/>
+          <p:nvPr/>
+        </p:nvSpPr>
+        <p:spPr>
+          <a:xfrm>
+            <a:off x="777240" y="3931920"/>
+            <a:ext cx="1188720" cy="658368"/>
+          </a:xfrm>
+          <a:prstGeom prst="rect">
+            <a:avLst/>
+          </a:prstGeom>
+          <a:noFill/>
+          <a:ln/>
+        </p:spPr>
+        <p:txBody>
+          <a:bodyPr wrap="square" lIns="0" tIns="0" rIns="0" bIns="0" rtlCol="0" anchor="ctr"/>
+          <a:lstStyle/>
+          <a:p>
+            <a:pPr indent="0" marL="0">
+              <a:buNone/>
+            </a:pPr>
+            <a:r>
+              <a:rPr lang="en-US" sz="1200" b="1" spc="100" kern="0" dirty="0">
+                <a:solidFill>
+                  <a:schemeClr val="accent1"/>
+                </a:solidFill>
+              </a:rPr>
+              <a:t>KATEGORI</a:t>
+            </a:r>
+            <a:endParaRPr lang="en-US" sz="1200" dirty="0"/>
+          </a:p>
+        </p:txBody>
+      </p:sp>
+      <p:sp>
+        <p:nvSpPr>
+          <p:cNvPr id="10" name="Text 6"/>
+          <p:cNvSpPr txBox="1"/>
+          <p:nvPr/>
+        </p:nvSpPr>
+        <p:spPr>
+          <a:xfrm>
+            <a:off x="1874520" y="3931920"/>
+            <a:ext cx="6080760" cy="658368"/>
+          </a:xfrm>
+          <a:prstGeom prst="rect">
+            <a:avLst/>
+          </a:prstGeom>
+          <a:noFill/>
+          <a:ln/>
+        </p:spPr>
+        <p:txBody>
+          <a:bodyPr wrap="square" lIns="0" tIns="0" rIns="0" bIns="0" rtlCol="0" anchor="ctr"/>
+          <a:lstStyle/>
+          <a:p>
+            <a:pPr indent="0" marL="0">
+              <a:buNone/>
+            </a:pPr>
+            <a:r>
+              <a:rPr lang="en-US" sz="1900" b="1" dirty="0">
+                <a:solidFill>
+                  <a:schemeClr val="bg1"/>
+                </a:solidFill>
+              </a:rPr>
+              <a:t>Inovasi Terapan – ASN Pemerintah Kabupaten/Kota</a:t>
+            </a:r>
+            <a:endParaRPr lang="en-US" sz="1900" dirty="0"/>
+          </a:p>
+        </p:txBody>
+      </p:sp>
+      <p:sp>
+        <p:nvSpPr>
+          <p:cNvPr id="11" name="Text 7"/>
+          <p:cNvSpPr txBox="1"/>
+          <p:nvPr/>
+        </p:nvSpPr>
+        <p:spPr>
+          <a:xfrm>
+            <a:off x="548640" y="4681728"/>
+            <a:ext cx="7132320" cy="329184"/>
           </a:xfrm>
           <a:prstGeom prst="rect">
             <a:avLst/>
@@ -2773,9 +2922,6 @@
           <a:lstStyle/>
           <a:p>
             <a:pPr indent="0" marL="0">
-              <a:spcAft>
-                <a:spcPts val="200"/>
-              </a:spcAft>
               <a:buNone/>
             </a:pPr>
             <a:r>
@@ -2784,38 +2930,21 @@
                   <a:schemeClr val="accent6"/>
                 </a:solidFill>
               </a:rPr>
-              <a:t>Inovasi Terapan – ASN Pemerintah Kabupaten/Kota</a:t>
+              <a:t>Bagian Protokol dan Komunikasi Pimpinan, Sekretariat Daerah Kota Tarakan</a:t>
             </a:r>
             <a:endParaRPr lang="en-US" sz="1500" dirty="0"/>
           </a:p>
-          <a:p>
-            <a:pPr indent="0" marL="0">
-              <a:spcAft>
-                <a:spcPts val="200"/>
-              </a:spcAft>
-              <a:buNone/>
-            </a:pPr>
-            <a:r>
-              <a:rPr lang="en-US" sz="1500" dirty="0">
-                <a:solidFill>
-                  <a:schemeClr val="accent6"/>
-                </a:solidFill>
-              </a:rPr>
-              <a:t>Bagian Protokol dan Komunikasi Pimpinan, Sekretariat Daerah Kota Tarakan</a:t>
-            </a:r>
-            <a:endParaRPr lang="en-US" sz="1500" dirty="0"/>
-          </a:p>
-        </p:txBody>
-      </p:sp>
-      <p:sp>
-        <p:nvSpPr>
-          <p:cNvPr id="9" name="Text 5"/>
-          <p:cNvSpPr txBox="1"/>
-          <p:nvPr/>
-        </p:nvSpPr>
-        <p:spPr>
-          <a:xfrm>
-            <a:off x="548640" y="5074920"/>
+        </p:txBody>
+      </p:sp>
+      <p:sp>
+        <p:nvSpPr>
+          <p:cNvPr id="12" name="Text 8"/>
+          <p:cNvSpPr txBox="1"/>
+          <p:nvPr/>
+        </p:nvSpPr>
+        <p:spPr>
+          <a:xfrm>
+            <a:off x="548640" y="5212080"/>
             <a:ext cx="7132320" cy="685800"/>
           </a:xfrm>
           <a:prstGeom prst="rect">
@@ -2856,7 +2985,7 @@
       </p:sp>
       <p:pic>
         <p:nvPicPr>
-          <p:cNvPr id="10" name="Image 2" descr="/home/user/joyful-visuals/docs/lomba/build/paparan/aset/hp_walikota.jpg">    </p:cNvPr>
+          <p:cNvPr id="13" name="Image 2" descr="/home/user/joyful-visuals/docs/lomba/build/paparan/aset/hp_walikota.jpg">    </p:cNvPr>
           <p:cNvPicPr>
             <a:picLocks noChangeAspect="1"/>
           </p:cNvPicPr>
@@ -2887,7 +3016,7 @@
       </p:pic>
       <p:sp>
         <p:nvSpPr>
-          <p:cNvPr id="12" name="Text 0"/>
+          <p:cNvPr id="15" name="Text 0"/>
           <p:cNvSpPr/>
           <p:nvPr>
             <p:ph idx="100" type="body" hasCustomPrompt="1"/>
@@ -2917,7 +3046,7 @@
       </p:sp>
       <p:sp>
         <p:nvSpPr>
-          <p:cNvPr id="13" name="Text 0"/>
+          <p:cNvPr id="16" name="Text 0"/>
           <p:cNvSpPr/>
           <p:nvPr>
             <p:ph idx="101" type="title" hasCustomPrompt="1"/>
@@ -6820,11 +6949,11 @@
         <p:spPr>
           <a:xfrm>
             <a:off x="548640" y="1783080"/>
-            <a:ext cx="3545738" cy="1828800"/>
+            <a:ext cx="3545738" cy="1572768"/>
           </a:xfrm>
           <a:prstGeom prst="roundRect">
             <a:avLst>
-              <a:gd name="adj" fmla="val 6000"/>
+              <a:gd name="adj" fmla="val 6977"/>
             </a:avLst>
           </a:prstGeom>
           <a:solidFill>
@@ -6944,7 +7073,7 @@
         <p:spPr>
           <a:xfrm>
             <a:off x="731520" y="2404872"/>
-            <a:ext cx="3179978" cy="1143000"/>
+            <a:ext cx="3179978" cy="886968"/>
           </a:xfrm>
           <a:prstGeom prst="rect">
             <a:avLst/>
@@ -6980,11 +7109,11 @@
         <p:spPr>
           <a:xfrm>
             <a:off x="4322978" y="1783080"/>
-            <a:ext cx="3545738" cy="1828800"/>
+            <a:ext cx="3545738" cy="1572768"/>
           </a:xfrm>
           <a:prstGeom prst="roundRect">
             <a:avLst>
-              <a:gd name="adj" fmla="val 6000"/>
+              <a:gd name="adj" fmla="val 6977"/>
             </a:avLst>
           </a:prstGeom>
           <a:solidFill>
@@ -7104,7 +7233,7 @@
         <p:spPr>
           <a:xfrm>
             <a:off x="4505858" y="2404872"/>
-            <a:ext cx="3179978" cy="1143000"/>
+            <a:ext cx="3179978" cy="886968"/>
           </a:xfrm>
           <a:prstGeom prst="rect">
             <a:avLst/>
@@ -7140,11 +7269,11 @@
         <p:spPr>
           <a:xfrm>
             <a:off x="8097317" y="1783080"/>
-            <a:ext cx="3545738" cy="1828800"/>
+            <a:ext cx="3545738" cy="1572768"/>
           </a:xfrm>
           <a:prstGeom prst="roundRect">
             <a:avLst>
-              <a:gd name="adj" fmla="val 6000"/>
+              <a:gd name="adj" fmla="val 6977"/>
             </a:avLst>
           </a:prstGeom>
           <a:solidFill>
@@ -7264,7 +7393,7 @@
         <p:spPr>
           <a:xfrm>
             <a:off x="8280197" y="2404872"/>
-            <a:ext cx="3179978" cy="1143000"/>
+            <a:ext cx="3179978" cy="886968"/>
           </a:xfrm>
           <a:prstGeom prst="rect">
             <a:avLst/>
@@ -7299,12 +7428,12 @@
         </p:nvSpPr>
         <p:spPr>
           <a:xfrm>
-            <a:off x="548640" y="3794760"/>
-            <a:ext cx="3545738" cy="1828800"/>
+            <a:off x="548640" y="3538728"/>
+            <a:ext cx="3545738" cy="1572768"/>
           </a:xfrm>
           <a:prstGeom prst="roundRect">
             <a:avLst>
-              <a:gd name="adj" fmla="val 6000"/>
+              <a:gd name="adj" fmla="val 6977"/>
             </a:avLst>
           </a:prstGeom>
           <a:solidFill>
@@ -7326,7 +7455,7 @@
         </p:nvSpPr>
         <p:spPr>
           <a:xfrm>
-            <a:off x="731520" y="3959352"/>
+            <a:off x="731520" y="3703320"/>
             <a:ext cx="365760" cy="365760"/>
           </a:xfrm>
           <a:prstGeom prst="ellipse">
@@ -7351,7 +7480,7 @@
         </p:nvSpPr>
         <p:spPr>
           <a:xfrm>
-            <a:off x="731520" y="3959352"/>
+            <a:off x="731520" y="3703320"/>
             <a:ext cx="365760" cy="365760"/>
           </a:xfrm>
           <a:prstGeom prst="rect">
@@ -7387,7 +7516,7 @@
         </p:nvSpPr>
         <p:spPr>
           <a:xfrm>
-            <a:off x="1234440" y="3959352"/>
+            <a:off x="1234440" y="3703320"/>
             <a:ext cx="2677058" cy="365760"/>
           </a:xfrm>
           <a:prstGeom prst="rect">
@@ -7423,8 +7552,8 @@
         </p:nvSpPr>
         <p:spPr>
           <a:xfrm>
-            <a:off x="731520" y="4416552"/>
-            <a:ext cx="3179978" cy="1143000"/>
+            <a:off x="731520" y="4160520"/>
+            <a:ext cx="3179978" cy="886968"/>
           </a:xfrm>
           <a:prstGeom prst="rect">
             <a:avLst/>
@@ -7459,12 +7588,12 @@
         </p:nvSpPr>
         <p:spPr>
           <a:xfrm>
-            <a:off x="4322978" y="3794760"/>
-            <a:ext cx="3545738" cy="1828800"/>
+            <a:off x="4322978" y="3538728"/>
+            <a:ext cx="3545738" cy="1572768"/>
           </a:xfrm>
           <a:prstGeom prst="roundRect">
             <a:avLst>
-              <a:gd name="adj" fmla="val 6000"/>
+              <a:gd name="adj" fmla="val 6977"/>
             </a:avLst>
           </a:prstGeom>
           <a:solidFill>
@@ -7486,7 +7615,7 @@
         </p:nvSpPr>
         <p:spPr>
           <a:xfrm>
-            <a:off x="4505858" y="3959352"/>
+            <a:off x="4505858" y="3703320"/>
             <a:ext cx="365760" cy="365760"/>
           </a:xfrm>
           <a:prstGeom prst="ellipse">
@@ -7511,7 +7640,7 @@
         </p:nvSpPr>
         <p:spPr>
           <a:xfrm>
-            <a:off x="4505858" y="3959352"/>
+            <a:off x="4505858" y="3703320"/>
             <a:ext cx="365760" cy="365760"/>
           </a:xfrm>
           <a:prstGeom prst="rect">
@@ -7547,7 +7676,7 @@
         </p:nvSpPr>
         <p:spPr>
           <a:xfrm>
-            <a:off x="5008778" y="3959352"/>
+            <a:off x="5008778" y="3703320"/>
             <a:ext cx="2677058" cy="365760"/>
           </a:xfrm>
           <a:prstGeom prst="rect">
@@ -7583,8 +7712,8 @@
         </p:nvSpPr>
         <p:spPr>
           <a:xfrm>
-            <a:off x="4505858" y="4416552"/>
-            <a:ext cx="3179978" cy="1143000"/>
+            <a:off x="4505858" y="4160520"/>
+            <a:ext cx="3179978" cy="886968"/>
           </a:xfrm>
           <a:prstGeom prst="rect">
             <a:avLst/>
@@ -7619,12 +7748,12 @@
         </p:nvSpPr>
         <p:spPr>
           <a:xfrm>
-            <a:off x="8097317" y="3794760"/>
-            <a:ext cx="3545738" cy="1828800"/>
+            <a:off x="8097317" y="3538728"/>
+            <a:ext cx="3545738" cy="1572768"/>
           </a:xfrm>
           <a:prstGeom prst="roundRect">
             <a:avLst>
-              <a:gd name="adj" fmla="val 6000"/>
+              <a:gd name="adj" fmla="val 6977"/>
             </a:avLst>
           </a:prstGeom>
           <a:solidFill>
@@ -7646,7 +7775,7 @@
         </p:nvSpPr>
         <p:spPr>
           <a:xfrm>
-            <a:off x="8280197" y="3959352"/>
+            <a:off x="8280197" y="3703320"/>
             <a:ext cx="365760" cy="365760"/>
           </a:xfrm>
           <a:prstGeom prst="ellipse">
@@ -7671,7 +7800,7 @@
         </p:nvSpPr>
         <p:spPr>
           <a:xfrm>
-            <a:off x="8280197" y="3959352"/>
+            <a:off x="8280197" y="3703320"/>
             <a:ext cx="365760" cy="365760"/>
           </a:xfrm>
           <a:prstGeom prst="rect">
@@ -7707,7 +7836,7 @@
         </p:nvSpPr>
         <p:spPr>
           <a:xfrm>
-            <a:off x="8783117" y="3959352"/>
+            <a:off x="8783117" y="3703320"/>
             <a:ext cx="2677058" cy="365760"/>
           </a:xfrm>
           <a:prstGeom prst="rect">
@@ -7743,8 +7872,8 @@
         </p:nvSpPr>
         <p:spPr>
           <a:xfrm>
-            <a:off x="8280197" y="4416552"/>
-            <a:ext cx="3179978" cy="1143000"/>
+            <a:off x="8280197" y="4160520"/>
+            <a:ext cx="3179978" cy="886968"/>
           </a:xfrm>
           <a:prstGeom prst="rect">
             <a:avLst/>
@@ -7773,7 +7902,54 @@
       </p:sp>
       <p:sp>
         <p:nvSpPr>
-          <p:cNvPr id="35" name="nilaitambah"/>
+          <p:cNvPr id="35" name="Text 33"/>
+          <p:cNvSpPr txBox="1"/>
+          <p:nvPr/>
+        </p:nvSpPr>
+        <p:spPr>
+          <a:xfrm>
+            <a:off x="548640" y="5193792"/>
+            <a:ext cx="11094415" cy="384048"/>
+          </a:xfrm>
+          <a:prstGeom prst="rect">
+            <a:avLst/>
+          </a:prstGeom>
+          <a:noFill/>
+          <a:ln/>
+        </p:spPr>
+        <p:txBody>
+          <a:bodyPr wrap="square" lIns="0" tIns="0" rIns="0" bIns="0" rtlCol="0" anchor="ctr"/>
+          <a:lstStyle/>
+          <a:p>
+            <a:pPr indent="0" marL="0">
+              <a:buNone/>
+            </a:pPr>
+            <a:r>
+              <a:rPr lang="en-US" sz="1400" b="1" dirty="0">
+                <a:solidFill>
+                  <a:schemeClr val="accent4"/>
+                </a:solidFill>
+              </a:rPr>
+              <a:t>Koreksi data  </a:t>
+            </a:r>
+            <a:pPr indent="0" marL="0">
+              <a:buNone/>
+            </a:pPr>
+            <a:r>
+              <a:rPr lang="en-US" sz="1400" dirty="0">
+                <a:solidFill>
+                  <a:schemeClr val="tx1"/>
+                </a:solidFill>
+              </a:rPr>
+              <a:t>Proposal menulis tiga lembar (peristiwa Januari 2026); lembar aslinya dua, satu tidak sampai. Peristiwanya sama.</a:t>
+            </a:r>
+            <a:endParaRPr lang="en-US" sz="1400" dirty="0"/>
+          </a:p>
+        </p:txBody>
+      </p:sp>
+      <p:sp>
+        <p:nvSpPr>
+          <p:cNvPr id="36" name="nilaitambah"/>
           <p:cNvSpPr/>
           <p:nvPr/>
         </p:nvSpPr>
@@ -7800,7 +7976,7 @@
       </p:sp>
       <p:sp>
         <p:nvSpPr>
-          <p:cNvPr id="36" name="Text 34"/>
+          <p:cNvPr id="37" name="Text 35"/>
           <p:cNvSpPr txBox="1"/>
           <p:nvPr/>
         </p:nvSpPr>
@@ -7999,7 +8175,7 @@
         </p:nvSpPr>
         <p:spPr>
           <a:xfrm>
-            <a:off x="548640" y="1691640"/>
+            <a:off x="548640" y="2011680"/>
             <a:ext cx="4480560" cy="1005840"/>
           </a:xfrm>
           <a:prstGeom prst="roundRect">
@@ -8026,7 +8202,7 @@
         </p:nvSpPr>
         <p:spPr>
           <a:xfrm>
-            <a:off x="777240" y="1938528"/>
+            <a:off x="777240" y="2258568"/>
             <a:ext cx="512064" cy="512064"/>
           </a:xfrm>
           <a:prstGeom prst="ellipse">
@@ -8051,7 +8227,7 @@
         </p:nvSpPr>
         <p:spPr>
           <a:xfrm>
-            <a:off x="777240" y="1938528"/>
+            <a:off x="777240" y="2258568"/>
             <a:ext cx="512064" cy="512064"/>
           </a:xfrm>
           <a:prstGeom prst="rect">
@@ -8087,7 +8263,7 @@
         </p:nvSpPr>
         <p:spPr>
           <a:xfrm>
-            <a:off x="1508760" y="1874520"/>
+            <a:off x="1508760" y="2194560"/>
             <a:ext cx="3383280" cy="329184"/>
           </a:xfrm>
           <a:prstGeom prst="rect">
@@ -8109,7 +8285,7 @@
                   <a:schemeClr val="tx2"/>
                 </a:solidFill>
               </a:rPr>
-              <a:t>Disposisi 1</a:t>
+              <a:t>Rencana Kegiatan</a:t>
             </a:r>
             <a:endParaRPr lang="en-US" sz="1600" dirty="0"/>
           </a:p>
@@ -8123,7 +8299,7 @@
         </p:nvSpPr>
         <p:spPr>
           <a:xfrm>
-            <a:off x="1508760" y="2221992"/>
+            <a:off x="1508760" y="2542032"/>
             <a:ext cx="3383280" cy="310896"/>
           </a:xfrm>
           <a:prstGeom prst="rect">
@@ -8159,167 +8335,7 @@
         </p:nvSpPr>
         <p:spPr>
           <a:xfrm>
-            <a:off x="548640" y="2898648"/>
-            <a:ext cx="4480560" cy="1005840"/>
-          </a:xfrm>
-          <a:prstGeom prst="roundRect">
-            <a:avLst>
-              <a:gd name="adj" fmla="val 10909"/>
-            </a:avLst>
-          </a:prstGeom>
-          <a:solidFill>
-            <a:schemeClr val="bg2"/>
-          </a:solidFill>
-          <a:ln w="9525">
-            <a:solidFill>
-              <a:schemeClr val="bg2"/>
-            </a:solidFill>
-            <a:prstDash val="solid"/>
-          </a:ln>
-        </p:spPr>
-      </p:sp>
-      <p:sp>
-        <p:nvSpPr>
-          <p:cNvPr id="10" name="Shape 8"/>
-          <p:cNvSpPr/>
-          <p:nvPr/>
-        </p:nvSpPr>
-        <p:spPr>
-          <a:xfrm>
-            <a:off x="777240" y="3145536"/>
-            <a:ext cx="512064" cy="512064"/>
-          </a:xfrm>
-          <a:prstGeom prst="ellipse">
-            <a:avLst/>
-          </a:prstGeom>
-          <a:solidFill>
-            <a:schemeClr val="accent3"/>
-          </a:solidFill>
-          <a:ln w="12700">
-            <a:solidFill>
-              <a:schemeClr val="accent3"/>
-            </a:solidFill>
-            <a:prstDash val="solid"/>
-          </a:ln>
-        </p:spPr>
-      </p:sp>
-      <p:sp>
-        <p:nvSpPr>
-          <p:cNvPr id="11" name="Text 9"/>
-          <p:cNvSpPr txBox="1"/>
-          <p:nvPr/>
-        </p:nvSpPr>
-        <p:spPr>
-          <a:xfrm>
-            <a:off x="777240" y="3145536"/>
-            <a:ext cx="512064" cy="512064"/>
-          </a:xfrm>
-          <a:prstGeom prst="rect">
-            <a:avLst/>
-          </a:prstGeom>
-          <a:noFill/>
-          <a:ln/>
-        </p:spPr>
-        <p:txBody>
-          <a:bodyPr wrap="square" lIns="0" tIns="0" rIns="0" bIns="0" rtlCol="0" anchor="ctr"/>
-          <a:lstStyle/>
-          <a:p>
-            <a:pPr algn="ctr" indent="0" marL="0">
-              <a:buNone/>
-            </a:pPr>
-            <a:r>
-              <a:rPr lang="en-US" sz="1400" b="1" dirty="0">
-                <a:solidFill>
-                  <a:schemeClr val="bg1"/>
-                </a:solidFill>
-              </a:rPr>
-              <a:t>✓</a:t>
-            </a:r>
-            <a:endParaRPr lang="en-US" sz="1400" dirty="0"/>
-          </a:p>
-        </p:txBody>
-      </p:sp>
-      <p:sp>
-        <p:nvSpPr>
-          <p:cNvPr id="12" name="Text 10"/>
-          <p:cNvSpPr txBox="1"/>
-          <p:nvPr/>
-        </p:nvSpPr>
-        <p:spPr>
-          <a:xfrm>
-            <a:off x="1508760" y="3081528"/>
-            <a:ext cx="3383280" cy="329184"/>
-          </a:xfrm>
-          <a:prstGeom prst="rect">
-            <a:avLst/>
-          </a:prstGeom>
-          <a:noFill/>
-          <a:ln/>
-        </p:spPr>
-        <p:txBody>
-          <a:bodyPr wrap="square" lIns="0" tIns="0" rIns="0" bIns="0" rtlCol="0" anchor="t"/>
-          <a:lstStyle/>
-          <a:p>
-            <a:pPr indent="0" marL="0">
-              <a:buNone/>
-            </a:pPr>
-            <a:r>
-              <a:rPr lang="en-US" sz="1600" b="1" dirty="0">
-                <a:solidFill>
-                  <a:schemeClr val="tx2"/>
-                </a:solidFill>
-              </a:rPr>
-              <a:t>Disposisi 2</a:t>
-            </a:r>
-            <a:endParaRPr lang="en-US" sz="1600" dirty="0"/>
-          </a:p>
-        </p:txBody>
-      </p:sp>
-      <p:sp>
-        <p:nvSpPr>
-          <p:cNvPr id="13" name="Text 11"/>
-          <p:cNvSpPr txBox="1"/>
-          <p:nvPr/>
-        </p:nvSpPr>
-        <p:spPr>
-          <a:xfrm>
-            <a:off x="1508760" y="3429000"/>
-            <a:ext cx="3383280" cy="310896"/>
-          </a:xfrm>
-          <a:prstGeom prst="rect">
-            <a:avLst/>
-          </a:prstGeom>
-          <a:noFill/>
-          <a:ln/>
-        </p:spPr>
-        <p:txBody>
-          <a:bodyPr wrap="square" lIns="0" tIns="0" rIns="0" bIns="0" rtlCol="0" anchor="t"/>
-          <a:lstStyle/>
-          <a:p>
-            <a:pPr indent="0" marL="0">
-              <a:buNone/>
-            </a:pPr>
-            <a:r>
-              <a:rPr lang="en-US" sz="1400" dirty="0">
-                <a:solidFill>
-                  <a:schemeClr val="accent5"/>
-                </a:solidFill>
-              </a:rPr>
-              <a:t>Difoto, terkirim ke grup WA</a:t>
-            </a:r>
-            <a:endParaRPr lang="en-US" sz="1400" dirty="0"/>
-          </a:p>
-        </p:txBody>
-      </p:sp>
-      <p:sp>
-        <p:nvSpPr>
-          <p:cNvPr id="14" name="lembar3"/>
-          <p:cNvSpPr/>
-          <p:nvPr/>
-        </p:nvSpPr>
-        <p:spPr>
-          <a:xfrm>
-            <a:off x="548640" y="4105656"/>
+            <a:off x="548640" y="3383280"/>
             <a:ext cx="4480560" cy="1005840"/>
           </a:xfrm>
           <a:prstGeom prst="roundRect">
@@ -8340,13 +8356,13 @@
       </p:sp>
       <p:sp>
         <p:nvSpPr>
-          <p:cNvPr id="15" name="Shape 13"/>
+          <p:cNvPr id="10" name="Shape 8"/>
           <p:cNvSpPr/>
           <p:nvPr/>
         </p:nvSpPr>
         <p:spPr>
           <a:xfrm>
-            <a:off x="777240" y="4352544"/>
+            <a:off x="777240" y="3630168"/>
             <a:ext cx="512064" cy="512064"/>
           </a:xfrm>
           <a:prstGeom prst="ellipse">
@@ -8365,13 +8381,13 @@
       </p:sp>
       <p:sp>
         <p:nvSpPr>
-          <p:cNvPr id="16" name="Text 14"/>
-          <p:cNvSpPr txBox="1"/>
-          <p:nvPr/>
-        </p:nvSpPr>
-        <p:spPr>
-          <a:xfrm>
-            <a:off x="777240" y="4352544"/>
+          <p:cNvPr id="11" name="Text 9"/>
+          <p:cNvSpPr txBox="1"/>
+          <p:nvPr/>
+        </p:nvSpPr>
+        <p:spPr>
+          <a:xfrm>
+            <a:off x="777240" y="3630168"/>
             <a:ext cx="512064" cy="512064"/>
           </a:xfrm>
           <a:prstGeom prst="rect">
@@ -8401,13 +8417,13 @@
       </p:sp>
       <p:sp>
         <p:nvSpPr>
-          <p:cNvPr id="17" name="Text 15"/>
-          <p:cNvSpPr txBox="1"/>
-          <p:nvPr/>
-        </p:nvSpPr>
-        <p:spPr>
-          <a:xfrm>
-            <a:off x="1508760" y="4288536"/>
+          <p:cNvPr id="12" name="Text 10"/>
+          <p:cNvSpPr txBox="1"/>
+          <p:nvPr/>
+        </p:nvSpPr>
+        <p:spPr>
+          <a:xfrm>
+            <a:off x="1508760" y="3566160"/>
             <a:ext cx="3383280" cy="329184"/>
           </a:xfrm>
           <a:prstGeom prst="rect">
@@ -8429,7 +8445,7 @@
                   <a:schemeClr val="tx2"/>
                 </a:solidFill>
               </a:rPr>
-              <a:t>Disposisi 3</a:t>
+              <a:t>Rencana Audiensi</a:t>
             </a:r>
             <a:endParaRPr lang="en-US" sz="1600" dirty="0"/>
           </a:p>
@@ -8437,13 +8453,13 @@
       </p:sp>
       <p:sp>
         <p:nvSpPr>
-          <p:cNvPr id="18" name="Text 16"/>
-          <p:cNvSpPr txBox="1"/>
-          <p:nvPr/>
-        </p:nvSpPr>
-        <p:spPr>
-          <a:xfrm>
-            <a:off x="1508760" y="4636008"/>
+          <p:cNvPr id="13" name="Text 11"/>
+          <p:cNvSpPr txBox="1"/>
+          <p:nvPr/>
+        </p:nvSpPr>
+        <p:spPr>
+          <a:xfrm>
+            <a:off x="1508760" y="3913632"/>
             <a:ext cx="3383280" cy="310896"/>
           </a:xfrm>
           <a:prstGeom prst="rect">
@@ -8473,7 +8489,7 @@
       </p:sp>
       <p:sp>
         <p:nvSpPr>
-          <p:cNvPr id="19" name="Text 17"/>
+          <p:cNvPr id="14" name="Text 12"/>
           <p:cNvSpPr txBox="1"/>
           <p:nvPr/>
         </p:nvSpPr>
@@ -8509,7 +8525,7 @@
       </p:sp>
       <p:sp>
         <p:nvSpPr>
-          <p:cNvPr id="20" name="Text 18"/>
+          <p:cNvPr id="15" name="Text 13"/>
           <p:cNvSpPr txBox="1"/>
           <p:nvPr/>
         </p:nvSpPr>

</xml_diff>

<commit_message>
Paparan: misi RPJMD ditulis utuh; panah slide akar masalah tersambung di semua penampil
Garis berpanah kini berukuran positif dengan flipV/flipH, sehingga panah
yang naik tidak lagi terputus di PowerPoint/Keynote.

Co-Authored-By: Claude Opus 5.5 <noreply@anthropic.com>
Claude-Session: https://claude.ai/code/session_01TchDZWsQsgeuq52sKmozd1
</commit_message>
<xml_diff>
--- a/docs/lomba/kaltara/Paparan-Prokopim-Hibot-Kaltara-2026.pptx
+++ b/docs/lomba/kaltara/Paparan-Prokopim-Hibot-Kaltara-2026.pptx
@@ -120,56 +120,56 @@
   <p:extLst>
     <p:ext uri="{521415D9-36F7-43E2-AB2F-B90AF26B5E84}">
       <p14:sectionLst xmlns:p14="http://schemas.microsoft.com/office/powerpoint/2010/main">
-        <p14:section name="Pembuka" id="{22b31861-89e8-529c-3ddd-68de11282f5a}">
+        <p14:section name="Pembuka" id="{801225eb-d7fd-f6dc-8d3a-c60566f955a9}">
           <p14:sldIdLst>
             <p14:sldId id="256"/>
           </p14:sldIdLst>
         </p14:section>
-        <p14:section name="Latar belakang" id="{c62de004-ec85-8b49-21d5-5eac92a678b4}">
+        <p14:section name="Latar belakang" id="{57c70903-4ca9-6d33-be8a-c5ce072aabcd}">
           <p14:sldIdLst>
             <p14:sldId id="257"/>
             <p14:sldId id="258"/>
           </p14:sldIdLst>
         </p14:section>
-        <p14:section name="Terobosan inovasi" id="{b51b8a1c-4ce1-ad87-c9f8-91a5fb530d90}">
+        <p14:section name="Terobosan inovasi" id="{f454200a-c34f-93b4-b989-f922e281aafe}">
           <p14:sldIdLst>
             <p14:sldId id="259"/>
             <p14:sldId id="260"/>
           </p14:sldIdLst>
         </p14:section>
-        <p14:section name="Manfaat inovasi" id="{766c32ba-9e80-3efd-661d-74e82d4b46a8}">
+        <p14:section name="Manfaat inovasi" id="{fb695692-b2c0-a119-d99b-4d3b8c1d0916}">
           <p14:sldIdLst>
             <p14:sldId id="261"/>
             <p14:sldId id="262"/>
             <p14:sldId id="263"/>
           </p14:sldIdLst>
         </p14:section>
-        <p14:section name="Fitur lain: kanal publik" id="{23628f64-73fd-5023-cc57-7f27981caeb8}">
+        <p14:section name="Fitur lain: kanal publik" id="{b0db6671-a4c0-d8e3-d7cc-4083cd4a708d}">
           <p14:sldIdLst>
             <p14:sldId id="264"/>
           </p14:sldIdLst>
         </p14:section>
-        <p14:section name="Pemanfaatan sumber daya" id="{c1e47e3a-038c-c442-c240-f212efb985b6}">
+        <p14:section name="Pemanfaatan sumber daya" id="{a4db31d4-b928-a121-41cf-f4c902bce455}">
           <p14:sldIdLst>
             <p14:sldId id="265"/>
           </p14:sldIdLst>
         </p14:section>
-        <p14:section name="Diseminasi inovasi" id="{2d2e970c-e0e4-87e2-9e3f-1a70f75e9683}">
+        <p14:section name="Diseminasi inovasi" id="{42ce37d2-43d1-0edb-3f72-ce762a1be417}">
           <p14:sldIdLst>
             <p14:sldId id="266"/>
           </p14:sldIdLst>
         </p14:section>
-        <p14:section name="Kompatibilitas" id="{ba8ac8fb-48fb-1330-b201-54c89ef97fdd}">
+        <p14:section name="Kompatibilitas" id="{53223232-c28a-8ad5-546f-4993f2dba1c9}">
           <p14:sldIdLst>
             <p14:sldId id="267"/>
           </p14:sldIdLst>
         </p14:section>
-        <p14:section name="Penutup" id="{65a6dd3a-cd16-f7c7-d5eb-61f926578fd3}">
+        <p14:section name="Penutup" id="{20828fa8-cb40-075a-704b-ca9feeec73c5}">
           <p14:sldIdLst>
             <p14:sldId id="268"/>
           </p14:sldIdLst>
         </p14:section>
-        <p14:section name="Cadangan penjelasan" id="{a7a31cc3-34aa-1c7c-2df8-d4855af55963}">
+        <p14:section name="Cadangan penjelasan" id="{4a0e0f1e-3f07-95e6-bfab-696241b3f44e}">
           <p14:sldIdLst>
             <p14:sldId id="269"/>
           </p14:sldIdLst>
@@ -6086,7 +6086,7 @@
                   <a:schemeClr val="bg1"/>
                 </a:solidFill>
               </a:rPr>
-              <a:t>RPJMD Kaltara 2025–2029, Misi 3: transformasi tata kelola yang kolaboratif dan inovatif</a:t>
+              <a:t>RPJMD Kalimantan Utara 2025–2029, Misi 3: Mewujudkan Transformasi Tata Kelola yang Kolaboratif dan Inovatif</a:t>
             </a:r>
             <a:endParaRPr lang="en-US" sz="1400" dirty="0"/>
           </a:p>
@@ -6104,7 +6104,7 @@
                   <a:schemeClr val="bg1"/>
                 </a:solidFill>
               </a:rPr>
-              <a:t>RPJMD Kota Tarakan, Misi 4: tata kelola pemerintahan</a:t>
+              <a:t>RPJMD Kota Tarakan 2025–2029, Misi 4: Mewujudkan tata kelola pemerintahan yang adaptif, responsif dan menjaga stabilitas ketertiban dan ketentraman kota</a:t>
             </a:r>
             <a:endParaRPr lang="en-US" sz="1400" dirty="0"/>
           </a:p>
@@ -6122,7 +6122,7 @@
                   <a:schemeClr val="bg1"/>
                 </a:solidFill>
               </a:rPr>
-              <a:t>Semboyan "Tarakan HIBOT" — hibot berarti hebat dalam bahasa Tidung</a:t>
+              <a:t>Semboyan "Tarakan HIBOT": hibot berarti hebat dalam bahasa Tidung</a:t>
             </a:r>
             <a:endParaRPr lang="en-US" sz="1400" dirty="0"/>
           </a:p>
@@ -9381,9 +9381,9 @@
           <p:nvPr/>
         </p:nvSpPr>
         <p:spPr>
-          <a:xfrm>
-            <a:off x="3840480" y="3520440"/>
-            <a:ext cx="1005840" cy="-1591056"/>
+          <a:xfrm flipV="1">
+            <a:off x="3840480" y="1929384"/>
+            <a:ext cx="1005840" cy="1591056"/>
           </a:xfrm>
           <a:prstGeom prst="line">
             <a:avLst/>
@@ -9468,9 +9468,9 @@
           <p:nvPr/>
         </p:nvSpPr>
         <p:spPr>
-          <a:xfrm>
-            <a:off x="3840480" y="3520440"/>
-            <a:ext cx="1005840" cy="-804672"/>
+          <a:xfrm flipV="1">
+            <a:off x="3840480" y="2715768"/>
+            <a:ext cx="1005840" cy="804672"/>
           </a:xfrm>
           <a:prstGeom prst="line">
             <a:avLst/>
@@ -9555,9 +9555,9 @@
           <p:nvPr/>
         </p:nvSpPr>
         <p:spPr>
-          <a:xfrm>
-            <a:off x="3840480" y="3520440"/>
-            <a:ext cx="1005840" cy="-18288"/>
+          <a:xfrm flipV="1">
+            <a:off x="3840480" y="3502152"/>
+            <a:ext cx="1005840" cy="18288"/>
           </a:xfrm>
           <a:prstGeom prst="line">
             <a:avLst/>

</xml_diff>

<commit_message>
Lomba Kaltara: agenda Pimpinan sebagai manfaat utama; daftar hadir tidak ditonjolkan
- Video: adegan 10 hanya penugasan dan jejak audit (Pelaksana Harian),
  adegan 11 dipisah menjadi ruang rapat bagi instansi dan audiensi/tamu bagi
  instansi dan masyarakat; adegan 9 menyebut Wali Kota dan Wakil.
- Paparan: slide 8 'Manfaat utama', slide 9 'Layanan pendukung' dengan
  pembagian penerima manfaat; istilah kanal publik disesuaikan; naskah,
  takarir, dan naskah dubber diperbarui.

Co-Authored-By: Claude Opus 5.5 <noreply@anthropic.com>
Claude-Session: https://claude.ai/code/session_01TchDZWsQsgeuq52sKmozd1
</commit_message>
<xml_diff>
--- a/docs/lomba/kaltara/Paparan-Prokopim-Hibot-Kaltara-2026.pptx
+++ b/docs/lomba/kaltara/Paparan-Prokopim-Hibot-Kaltara-2026.pptx
@@ -120,56 +120,56 @@
   <p:extLst>
     <p:ext uri="{521415D9-36F7-43E2-AB2F-B90AF26B5E84}">
       <p14:sectionLst xmlns:p14="http://schemas.microsoft.com/office/powerpoint/2010/main">
-        <p14:section name="Pembuka" id="{801225eb-d7fd-f6dc-8d3a-c60566f955a9}">
+        <p14:section name="Pembuka" id="{ab327db1-673c-6bb0-7ca8-e8657be1abf0}">
           <p14:sldIdLst>
             <p14:sldId id="256"/>
           </p14:sldIdLst>
         </p14:section>
-        <p14:section name="Latar belakang" id="{57c70903-4ca9-6d33-be8a-c5ce072aabcd}">
+        <p14:section name="Latar belakang" id="{60eb7f04-234e-1806-ee54-37d04f54e9fe}">
           <p14:sldIdLst>
             <p14:sldId id="257"/>
             <p14:sldId id="258"/>
           </p14:sldIdLst>
         </p14:section>
-        <p14:section name="Terobosan inovasi" id="{f454200a-c34f-93b4-b989-f922e281aafe}">
+        <p14:section name="Terobosan inovasi" id="{247eaa67-2040-8b41-6456-140b3a0525da}">
           <p14:sldIdLst>
             <p14:sldId id="259"/>
             <p14:sldId id="260"/>
           </p14:sldIdLst>
         </p14:section>
-        <p14:section name="Manfaat inovasi" id="{fb695692-b2c0-a119-d99b-4d3b8c1d0916}">
+        <p14:section name="Manfaat inovasi" id="{156c5cd8-146d-f6e4-5d6f-e6ee1c5747a1}">
           <p14:sldIdLst>
             <p14:sldId id="261"/>
             <p14:sldId id="262"/>
             <p14:sldId id="263"/>
           </p14:sldIdLst>
         </p14:section>
-        <p14:section name="Fitur lain: kanal publik" id="{b0db6671-a4c0-d8e3-d7cc-4083cd4a708d}">
+        <p14:section name="Manfaat bagi instansi dan masyarakat" id="{c3571eca-23f1-4686-ad74-f8a00565d9d9}">
           <p14:sldIdLst>
             <p14:sldId id="264"/>
           </p14:sldIdLst>
         </p14:section>
-        <p14:section name="Pemanfaatan sumber daya" id="{a4db31d4-b928-a121-41cf-f4c902bce455}">
+        <p14:section name="Pemanfaatan sumber daya" id="{9037cf0d-2c83-2c98-1bc4-210e882733a3}">
           <p14:sldIdLst>
             <p14:sldId id="265"/>
           </p14:sldIdLst>
         </p14:section>
-        <p14:section name="Diseminasi inovasi" id="{42ce37d2-43d1-0edb-3f72-ce762a1be417}">
+        <p14:section name="Diseminasi inovasi" id="{d5262ca3-d7fb-04ac-7873-e6470b0cc7d8}">
           <p14:sldIdLst>
             <p14:sldId id="266"/>
           </p14:sldIdLst>
         </p14:section>
-        <p14:section name="Kompatibilitas" id="{53223232-c28a-8ad5-546f-4993f2dba1c9}">
+        <p14:section name="Kompatibilitas" id="{cd292c7a-905b-9ac7-d9a2-b9208a799457}">
           <p14:sldIdLst>
             <p14:sldId id="267"/>
           </p14:sldIdLst>
         </p14:section>
-        <p14:section name="Penutup" id="{20828fa8-cb40-075a-704b-ca9feeec73c5}">
+        <p14:section name="Penutup" id="{ad5ccda0-19c8-64c3-ff69-a604b80d3d0f}">
           <p14:sldIdLst>
             <p14:sldId id="268"/>
           </p14:sldIdLst>
         </p14:section>
-        <p14:section name="Cadangan penjelasan" id="{4a0e0f1e-3f07-95e6-bfab-696241b3f44e}">
+        <p14:section name="Cadangan penjelasan" id="{9451f318-9270-d5fa-8954-84c231c7f8d8}">
           <p14:sldIdLst>
             <p14:sldId id="269"/>
           </p14:sldIdLst>
@@ -1677,10 +1677,10 @@
           <a:p>
             <a:r>
               <a:rPr lang="en-US" dirty="0"/>
-              <a:t>6:30–7:00 · Dirasakan Pimpinan
-Manfaatnya dirasakan langsung oleh Pimpinan. Wali Kota menyampaikan: "Yang terpenting bagi saya adalah kepastian: ke mana saya harus hadir, kapan, dan siapa yang menyiapkannya."
+              <a:t>6:30–7:00 · Manfaat utama: agenda Wali Kota dan Wakil
+Manfaat utamanya ada pada agenda Wali Kota dan Wakil Wali Kota. Wali Kota menyampaikan: "Yang terpenting bagi saya adalah kepastian: ke mana saya harus hadir, kapan, dan siapa yang menyiapkannya."
 62 kegiatan telah beliau disposisikan kepada Wakil langsung dari aplikasi, dan ajudan sudah 341 kali mengonfirmasi kehadiran.
-Isyarat: Bacakan kutipan dengan nada hormat dan pelan, sambil menunjuk kotak kutipan.</a:t>
+Isyarat: Bacakan kutipan dengan nada hormat dan pelan, sambil menunjuk kotak kutipan. Tegaskan kata 'utama'.</a:t>
             </a:r>
             <a:endParaRPr lang="en-US" dirty="0"/>
           </a:p>
@@ -1768,9 +1768,9 @@
           <a:p>
             <a:r>
               <a:rPr lang="en-US" dirty="0"/>
-              <a:t>7:00–7:25 · Fitur lain: kanal publik
-Di luar alur agenda, ada fitur tersendiri untuk masyarakat: kanal publik. Tanpa akun, 66 instansi mengajukan peminjaman ruangan dan 53 instansi mengajukan audiensi, lalu memantau statusnya sendiri dengan kode penelusuran, tanpa datang atau menelepon berulang.
-Isyarat: Tegaskan 'fitur tersendiri', supaya juri tidak mencampurnya dengan alur agenda.</a:t>
+              <a:t>7:00–7:25 · Layanan pendukung: instansi dan masyarakat
+Selain agenda Pimpinan, ada dua layanan pendukung. Bagi instansi, peminjaman ruang rapat: 123 pengajuan dari 66 instansi. Bagi instansi dan masyarakat, permohonan audiensi dan bertamu kepada Pimpinan: 55 permohonan dari 53 instansi. Statusnya dipantau sendiri dengan kode penelusuran, tanpa datang atau menelepon berulang.
+Isyarat: Sampaikan sebagai pendukung, nada lebih ringan; jangan berlama-lama, inti paparan tetap agenda Pimpinan.</a:t>
             </a:r>
             <a:endParaRPr lang="en-US" dirty="0"/>
           </a:p>
@@ -5058,7 +5058,7 @@
                   <a:schemeClr val="accent5"/>
                 </a:solidFill>
               </a:rPr>
-              <a:t>instansi memakai kanal publik ruangan dan audiensi</a:t>
+              <a:t>instansi mengajukan peminjaman ruangan dan audiensi</a:t>
             </a:r>
             <a:endParaRPr lang="en-US" sz="1400" dirty="0"/>
           </a:p>
@@ -9803,7 +9803,7 @@
                   <a:schemeClr val="tx1"/>
                 </a:solidFill>
               </a:rPr>
-              <a:t>Kanal publik tidak dapat ditelusuri</a:t>
+              <a:t>Permohonan ruangan dan audiensi tidak dapat ditelusuri</a:t>
             </a:r>
             <a:endParaRPr lang="en-US" sz="1500" dirty="0"/>
           </a:p>
@@ -12393,7 +12393,7 @@
                   <a:schemeClr val="tx2"/>
                 </a:solidFill>
               </a:rPr>
-              <a:t>Kanal publik terlacak</a:t>
+              <a:t>Permohonan publik terlacak</a:t>
             </a:r>
             <a:endParaRPr lang="en-US" sz="1500" dirty="0"/>
           </a:p>
@@ -12429,7 +12429,7 @@
                   <a:schemeClr val="accent5"/>
                 </a:solidFill>
               </a:rPr>
-              <a:t>Dipantau sendiri dengan kode</a:t>
+              <a:t>Ruangan dan audiensi dipantau dengan kode</a:t>
             </a:r>
             <a:endParaRPr lang="en-US" sz="1400" dirty="0"/>
           </a:p>
@@ -15390,7 +15390,7 @@
                   <a:schemeClr val="tx2"/>
                 </a:solidFill>
               </a:rPr>
-              <a:t>Dirasakan langsung oleh Pimpinan dan jajarannya</a:t>
+              <a:t>Manfaat utama: agenda yang pasti bagi Wali Kota dan Wakil</a:t>
             </a:r>
             <a:endParaRPr lang="en-US" sz="2800" dirty="0"/>
           </a:p>
@@ -16015,7 +16015,7 @@
                   <a:schemeClr val="accent5"/>
                 </a:solidFill>
               </a:rPr>
-              <a:t>FITUR LAIN  ·  MANFAAT BAGI MASYARAKAT</a:t>
+              <a:t>MANFAAT INOVASI  ·  LAYANAN PENDUKUNG</a:t>
             </a:r>
             <a:endParaRPr lang="en-US" sz="1200" dirty="0"/>
           </a:p>
@@ -16053,7 +16053,7 @@
                   <a:schemeClr val="tx2"/>
                 </a:solidFill>
               </a:rPr>
-              <a:t>Kanal publik: warga dan instansi mengurus sendiri, tanpa akun</a:t>
+              <a:t>Selain agenda Pimpinan: layanan bagi instansi dan masyarakat</a:t>
             </a:r>
             <a:endParaRPr lang="en-US" sz="2800" dirty="0"/>
           </a:p>
@@ -16089,7 +16089,7 @@
                   <a:schemeClr val="accent5"/>
                 </a:solidFill>
               </a:rPr>
-              <a:t>Terpisah dari alur agenda Pimpinan, kanal ini melayani masyarakat dan instansi lewat peramban.</a:t>
+              <a:t>Agenda Wali Kota dan Wakil tetap yang utama. Dua layanan ini diakses lewat peramban, tanpa akun.</a:t>
             </a:r>
             <a:endParaRPr lang="en-US" sz="1400" dirty="0"/>
           </a:p>
@@ -16152,7 +16152,7 @@
                   <a:schemeClr val="tx2"/>
                 </a:solidFill>
               </a:rPr>
-              <a:t>Peminjaman ruang rapat</a:t>
+              <a:t>Instansi · Peminjaman ruang rapat</a:t>
             </a:r>
             <a:endParaRPr lang="en-US" sz="1700" dirty="0"/>
           </a:p>
@@ -16363,7 +16363,7 @@
                   <a:schemeClr val="accent1"/>
                 </a:solidFill>
               </a:rPr>
-              <a:t>Permohonan audiensi</a:t>
+              <a:t>Instansi dan masyarakat · Audiensi dan tamu</a:t>
             </a:r>
             <a:endParaRPr lang="en-US" sz="1700" dirty="0"/>
           </a:p>

</xml_diff>

<commit_message>
Paparan: cantumkan Bidang Fokus 3 (Tata Kelola Kolaboratif dan Pelayanan Publik)
Slide 1 memuat kategori dan bidang fokus; slide 12 diberi pita bidang fokus
beserta empat subfokus yang dijawab, sesuai proposal; naskah pembuka dan
slide 12 disesuaikan.

Co-Authored-By: Claude Opus 5.5 <noreply@anthropic.com>
Claude-Session: https://claude.ai/code/session_01TchDZWsQsgeuq52sKmozd1
</commit_message>
<xml_diff>
--- a/docs/lomba/kaltara/Paparan-Prokopim-Hibot-Kaltara-2026.pptx
+++ b/docs/lomba/kaltara/Paparan-Prokopim-Hibot-Kaltara-2026.pptx
@@ -120,56 +120,56 @@
   <p:extLst>
     <p:ext uri="{521415D9-36F7-43E2-AB2F-B90AF26B5E84}">
       <p14:sectionLst xmlns:p14="http://schemas.microsoft.com/office/powerpoint/2010/main">
-        <p14:section name="Pembuka" id="{ab327db1-673c-6bb0-7ca8-e8657be1abf0}">
+        <p14:section name="Pembuka" id="{34ab9041-b80c-e4e2-8159-d240322e7183}">
           <p14:sldIdLst>
             <p14:sldId id="256"/>
           </p14:sldIdLst>
         </p14:section>
-        <p14:section name="Latar belakang" id="{60eb7f04-234e-1806-ee54-37d04f54e9fe}">
+        <p14:section name="Latar belakang" id="{e03974fb-2d4f-3f5c-9e73-3b873f4bc8ba}">
           <p14:sldIdLst>
             <p14:sldId id="257"/>
             <p14:sldId id="258"/>
           </p14:sldIdLst>
         </p14:section>
-        <p14:section name="Terobosan inovasi" id="{247eaa67-2040-8b41-6456-140b3a0525da}">
+        <p14:section name="Terobosan inovasi" id="{c6d32a50-4e7e-1707-9ff5-8b1409a389f2}">
           <p14:sldIdLst>
             <p14:sldId id="259"/>
             <p14:sldId id="260"/>
           </p14:sldIdLst>
         </p14:section>
-        <p14:section name="Manfaat inovasi" id="{156c5cd8-146d-f6e4-5d6f-e6ee1c5747a1}">
+        <p14:section name="Manfaat inovasi" id="{f42de21e-66a2-eb6b-e5a1-0d1fe2a30798}">
           <p14:sldIdLst>
             <p14:sldId id="261"/>
             <p14:sldId id="262"/>
             <p14:sldId id="263"/>
           </p14:sldIdLst>
         </p14:section>
-        <p14:section name="Manfaat bagi instansi dan masyarakat" id="{c3571eca-23f1-4686-ad74-f8a00565d9d9}">
+        <p14:section name="Manfaat bagi instansi dan masyarakat" id="{6c266e99-32e3-f359-cefc-e10866219530}">
           <p14:sldIdLst>
             <p14:sldId id="264"/>
           </p14:sldIdLst>
         </p14:section>
-        <p14:section name="Pemanfaatan sumber daya" id="{9037cf0d-2c83-2c98-1bc4-210e882733a3}">
+        <p14:section name="Pemanfaatan sumber daya" id="{49ca86c0-255d-e1c6-a1ec-f51d2390ff3d}">
           <p14:sldIdLst>
             <p14:sldId id="265"/>
           </p14:sldIdLst>
         </p14:section>
-        <p14:section name="Diseminasi inovasi" id="{d5262ca3-d7fb-04ac-7873-e6470b0cc7d8}">
+        <p14:section name="Diseminasi inovasi" id="{633e2a6f-08e3-51e2-95b2-a4021b11b2e1}">
           <p14:sldIdLst>
             <p14:sldId id="266"/>
           </p14:sldIdLst>
         </p14:section>
-        <p14:section name="Kompatibilitas" id="{cd292c7a-905b-9ac7-d9a2-b9208a799457}">
+        <p14:section name="Kompatibilitas" id="{41846242-d6f0-b98a-93f5-f2240ef899f1}">
           <p14:sldIdLst>
             <p14:sldId id="267"/>
           </p14:sldIdLst>
         </p14:section>
-        <p14:section name="Penutup" id="{ad5ccda0-19c8-64c3-ff69-a604b80d3d0f}">
+        <p14:section name="Penutup" id="{aa5bec5d-6282-1762-02b0-77f868775bb2}">
           <p14:sldIdLst>
             <p14:sldId id="268"/>
           </p14:sldIdLst>
         </p14:section>
-        <p14:section name="Cadangan penjelasan" id="{9451f318-9270-d5fa-8954-84c231c7f8d8}">
+        <p14:section name="Cadangan penjelasan" id="{45578b0a-e5fc-ce30-658b-a6195201a0bb}">
           <p14:sldIdLst>
             <p14:sldId id="269"/>
           </p14:sldIdLst>
@@ -580,7 +580,7 @@
               <a:rPr lang="en-US" dirty="0"/>
               <a:t>0:00–0:25 · Pembuka
 Assalamualaikum warahmatullahi wabarakatuh. Selamat [pagi/siang], Bapak dan Ibu Dewan Juri yang kami hormati.
-Izin kami sampaikan Prokopim Hibot, satu alur digital terverifikasi untuk agenda Pimpinan Daerah, dari Bagian Protokol dan Komunikasi Pimpinan, Sekretariat Daerah Kota Tarakan. Kami mengikuti kategori Inovasi Terapan, ASN Pemerintah Kabupaten/Kota.
+Izin kami sampaikan Prokopim Hibot, satu alur digital terverifikasi untuk agenda Pimpinan Daerah, dari Bagian Protokol dan Komunikasi Pimpinan, Sekretariat Daerah Kota Tarakan. Kami mengikuti kategori Inovasi Terapan, ASN Pemerintah Kabupaten/Kota, pada Bidang Fokus 3: Tata Kelola Kolaboratif dan Pelayanan Publik.
 Isyarat: Berdiri tegak, tatap juri, senyum. Jangan buru-buru; kalimat pertama menentukan kesan.</a:t>
             </a:r>
             <a:endParaRPr lang="en-US" dirty="0"/>
@@ -851,10 +851,10 @@
           <a:p>
             <a:r>
               <a:rPr lang="en-US" dirty="0"/>
-              <a:t>8:25–8:50 · Kompatibilitas
-Inovasi ini selaras dengan Undang-Undang Pelayanan Publik dan Keprotokolan, Peraturan Pemerintah tentang Inovasi Daerah, dan SPBE, serta mendukung Misi 3 RPJMD Kalimantan Utara dan Misi 4 Kota Tarakan.
-Aplikasi menyesuaikan cara kerja Pimpinan, bukan sebaliknya: naskah sambutan tetap tersedia tercetak.
-Isyarat: Cukup sebut garis besar; nomor peraturan sudah tertulis di slide.</a:t>
+              <a:t>8:25–8:50 · Kompatibilitas dan bidang fokus
+Inovasi ini menjawab Bidang Fokus 3 pada pedoman, Tata Kelola Kolaboratif dan Pelayanan Publik: digitalisasi pelayanan, penyederhanaan proses bisnis, integrasi data, serta transparansi dan akuntabilitas.
+Juga selaras dengan Misi 3 RPJMD Kalimantan Utara dan Misi 4 Kota Tarakan. Aplikasi menyesuaikan cara kerja Pimpinan, bukan sebaliknya: naskah sambutan tetap tersedia tercetak.
+Isyarat: Tunjuk pita Bidang Fokus di atas. Nomor peraturan cukup tertulis di slide, tidak perlu dibacakan.</a:t>
             </a:r>
             <a:endParaRPr lang="en-US" dirty="0"/>
           </a:p>
@@ -2807,12 +2807,12 @@
         </p:nvSpPr>
         <p:spPr>
           <a:xfrm>
-            <a:off x="548640" y="3931920"/>
-            <a:ext cx="7498080" cy="658368"/>
+            <a:off x="548640" y="3840480"/>
+            <a:ext cx="7498080" cy="1024128"/>
           </a:xfrm>
           <a:prstGeom prst="roundRect">
             <a:avLst>
-              <a:gd name="adj" fmla="val 11111"/>
+              <a:gd name="adj" fmla="val 7143"/>
             </a:avLst>
           </a:prstGeom>
           <a:solidFill>
@@ -2836,8 +2836,8 @@
         </p:nvSpPr>
         <p:spPr>
           <a:xfrm>
-            <a:off x="777240" y="3931920"/>
-            <a:ext cx="1188720" cy="658368"/>
+            <a:off x="777240" y="3904488"/>
+            <a:ext cx="1554480" cy="420624"/>
           </a:xfrm>
           <a:prstGeom prst="rect">
             <a:avLst/>
@@ -2872,8 +2872,8 @@
         </p:nvSpPr>
         <p:spPr>
           <a:xfrm>
-            <a:off x="1874520" y="3931920"/>
-            <a:ext cx="6080760" cy="658368"/>
+            <a:off x="2331720" y="3904488"/>
+            <a:ext cx="5623560" cy="420624"/>
           </a:xfrm>
           <a:prstGeom prst="rect">
             <a:avLst/>
@@ -2889,14 +2889,14 @@
               <a:buNone/>
             </a:pPr>
             <a:r>
-              <a:rPr lang="en-US" sz="1900" b="1" dirty="0">
+              <a:rPr lang="en-US" sz="1800" b="1" dirty="0">
                 <a:solidFill>
                   <a:schemeClr val="bg1"/>
                 </a:solidFill>
               </a:rPr>
               <a:t>Inovasi Terapan – ASN Pemerintah Kabupaten/Kota</a:t>
             </a:r>
-            <a:endParaRPr lang="en-US" sz="1900" dirty="0"/>
+            <a:endParaRPr lang="en-US" sz="1800" dirty="0"/>
           </a:p>
         </p:txBody>
       </p:sp>
@@ -2908,7 +2908,79 @@
         </p:nvSpPr>
         <p:spPr>
           <a:xfrm>
-            <a:off x="548640" y="4681728"/>
+            <a:off x="777240" y="4361688"/>
+            <a:ext cx="1554480" cy="420624"/>
+          </a:xfrm>
+          <a:prstGeom prst="rect">
+            <a:avLst/>
+          </a:prstGeom>
+          <a:noFill/>
+          <a:ln/>
+        </p:spPr>
+        <p:txBody>
+          <a:bodyPr wrap="square" lIns="0" tIns="0" rIns="0" bIns="0" rtlCol="0" anchor="ctr"/>
+          <a:lstStyle/>
+          <a:p>
+            <a:pPr indent="0" marL="0">
+              <a:buNone/>
+            </a:pPr>
+            <a:r>
+              <a:rPr lang="en-US" sz="1200" b="1" spc="100" kern="0" dirty="0">
+                <a:solidFill>
+                  <a:schemeClr val="accent1"/>
+                </a:solidFill>
+              </a:rPr>
+              <a:t>BIDANG FOKUS</a:t>
+            </a:r>
+            <a:endParaRPr lang="en-US" sz="1200" dirty="0"/>
+          </a:p>
+        </p:txBody>
+      </p:sp>
+      <p:sp>
+        <p:nvSpPr>
+          <p:cNvPr id="12" name="Text 8"/>
+          <p:cNvSpPr txBox="1"/>
+          <p:nvPr/>
+        </p:nvSpPr>
+        <p:spPr>
+          <a:xfrm>
+            <a:off x="2331720" y="4361688"/>
+            <a:ext cx="5623560" cy="420624"/>
+          </a:xfrm>
+          <a:prstGeom prst="rect">
+            <a:avLst/>
+          </a:prstGeom>
+          <a:noFill/>
+          <a:ln/>
+        </p:spPr>
+        <p:txBody>
+          <a:bodyPr wrap="square" lIns="0" tIns="0" rIns="0" bIns="0" rtlCol="0" anchor="ctr"/>
+          <a:lstStyle/>
+          <a:p>
+            <a:pPr indent="0" marL="0">
+              <a:buNone/>
+            </a:pPr>
+            <a:r>
+              <a:rPr lang="en-US" sz="1800" b="1" dirty="0">
+                <a:solidFill>
+                  <a:schemeClr val="bg1"/>
+                </a:solidFill>
+              </a:rPr>
+              <a:t>3 · Tata Kelola Kolaboratif dan Pelayanan Publik</a:t>
+            </a:r>
+            <a:endParaRPr lang="en-US" sz="1800" dirty="0"/>
+          </a:p>
+        </p:txBody>
+      </p:sp>
+      <p:sp>
+        <p:nvSpPr>
+          <p:cNvPr id="13" name="Text 9"/>
+          <p:cNvSpPr txBox="1"/>
+          <p:nvPr/>
+        </p:nvSpPr>
+        <p:spPr>
+          <a:xfrm>
+            <a:off x="548640" y="4956048"/>
             <a:ext cx="7132320" cy="329184"/>
           </a:xfrm>
           <a:prstGeom prst="rect">
@@ -2938,13 +3010,13 @@
       </p:sp>
       <p:sp>
         <p:nvSpPr>
-          <p:cNvPr id="12" name="Text 8"/>
-          <p:cNvSpPr txBox="1"/>
-          <p:nvPr/>
-        </p:nvSpPr>
-        <p:spPr>
-          <a:xfrm>
-            <a:off x="548640" y="5212080"/>
+          <p:cNvPr id="14" name="Text 10"/>
+          <p:cNvSpPr txBox="1"/>
+          <p:nvPr/>
+        </p:nvSpPr>
+        <p:spPr>
+          <a:xfrm>
+            <a:off x="548640" y="5394960"/>
             <a:ext cx="7132320" cy="685800"/>
           </a:xfrm>
           <a:prstGeom prst="rect">
@@ -2985,7 +3057,7 @@
       </p:sp>
       <p:pic>
         <p:nvPicPr>
-          <p:cNvPr id="13" name="Image 2" descr="/home/user/joyful-visuals/docs/lomba/build/paparan/aset/hp_walikota.jpg">    </p:cNvPr>
+          <p:cNvPr id="15" name="Image 2" descr="/home/user/joyful-visuals/docs/lomba/build/paparan/aset/hp_walikota.jpg">    </p:cNvPr>
           <p:cNvPicPr>
             <a:picLocks noChangeAspect="1"/>
           </p:cNvPicPr>
@@ -3016,7 +3088,7 @@
       </p:pic>
       <p:sp>
         <p:nvSpPr>
-          <p:cNvPr id="15" name="Text 0"/>
+          <p:cNvPr id="17" name="Text 0"/>
           <p:cNvSpPr/>
           <p:nvPr>
             <p:ph idx="100" type="body" hasCustomPrompt="1"/>
@@ -3046,7 +3118,7 @@
       </p:sp>
       <p:sp>
         <p:nvSpPr>
-          <p:cNvPr id="16" name="Text 0"/>
+          <p:cNvPr id="18" name="Text 0"/>
           <p:cNvSpPr/>
           <p:nvPr>
             <p:ph idx="101" type="title" hasCustomPrompt="1"/>
@@ -5808,7 +5880,7 @@
                   <a:schemeClr val="tx2"/>
                 </a:solidFill>
               </a:rPr>
-              <a:t>Selaras regulasi, visi daerah, dan cara kerja Pimpinan</a:t>
+              <a:t>Selaras bidang fokus, regulasi, dan visi daerah</a:t>
             </a:r>
             <a:endParaRPr lang="en-US" sz="2800" dirty="0"/>
           </a:p>
@@ -5816,14 +5888,91 @@
       </p:sp>
       <p:sp>
         <p:nvSpPr>
-          <p:cNvPr id="4" name="kompat1"/>
+          <p:cNvPr id="4" name="bidangfokus"/>
           <p:cNvSpPr/>
           <p:nvPr/>
         </p:nvSpPr>
         <p:spPr>
           <a:xfrm>
-            <a:off x="548640" y="1645920"/>
-            <a:ext cx="3515258" cy="4023360"/>
+            <a:off x="548640" y="1371600"/>
+            <a:ext cx="11094415" cy="777240"/>
+          </a:xfrm>
+          <a:prstGeom prst="roundRect">
+            <a:avLst>
+              <a:gd name="adj" fmla="val 14118"/>
+            </a:avLst>
+          </a:prstGeom>
+          <a:solidFill>
+            <a:srgbClr val="FBF6E7"/>
+          </a:solidFill>
+          <a:ln w="15875">
+            <a:solidFill>
+              <a:schemeClr val="accent1"/>
+            </a:solidFill>
+            <a:prstDash val="solid"/>
+          </a:ln>
+        </p:spPr>
+      </p:sp>
+      <p:sp>
+        <p:nvSpPr>
+          <p:cNvPr id="5" name="Text 3"/>
+          <p:cNvSpPr txBox="1"/>
+          <p:nvPr/>
+        </p:nvSpPr>
+        <p:spPr>
+          <a:xfrm>
+            <a:off x="822960" y="1371600"/>
+            <a:ext cx="10545775" cy="777240"/>
+          </a:xfrm>
+          <a:prstGeom prst="rect">
+            <a:avLst/>
+          </a:prstGeom>
+          <a:noFill/>
+          <a:ln/>
+        </p:spPr>
+        <p:txBody>
+          <a:bodyPr wrap="square" lIns="0" tIns="0" rIns="0" bIns="0" rtlCol="0" anchor="ctr"/>
+          <a:lstStyle/>
+          <a:p>
+            <a:pPr indent="0" marL="0">
+              <a:buNone/>
+            </a:pPr>
+            <a:r>
+              <a:rPr lang="en-US" sz="1400" b="1" dirty="0">
+                <a:solidFill>
+                  <a:schemeClr val="tx2"/>
+                </a:solidFill>
+              </a:rPr>
+              <a:t>Bidang Fokus 3 (Pedoman): Tata Kelola Kolaboratif dan Pelayanan Publik — subfokus yang dijawab:</a:t>
+            </a:r>
+            <a:endParaRPr lang="en-US" sz="1400" dirty="0"/>
+          </a:p>
+          <a:p>
+            <a:pPr indent="0" marL="0">
+              <a:buNone/>
+            </a:pPr>
+            <a:r>
+              <a:rPr lang="en-US" sz="1400" dirty="0">
+                <a:solidFill>
+                  <a:schemeClr val="tx1"/>
+                </a:solidFill>
+              </a:rPr>
+              <a:t>Digitalisasi pelayanan dan SPBE · penyederhanaan proses bisnis · integrasi data · transparansi dan akuntabilitas</a:t>
+            </a:r>
+            <a:endParaRPr lang="en-US" sz="1400" dirty="0"/>
+          </a:p>
+        </p:txBody>
+      </p:sp>
+      <p:sp>
+        <p:nvSpPr>
+          <p:cNvPr id="6" name="kompat1"/>
+          <p:cNvSpPr/>
+          <p:nvPr/>
+        </p:nvSpPr>
+        <p:spPr>
+          <a:xfrm>
+            <a:off x="548640" y="2331720"/>
+            <a:ext cx="3515258" cy="3749040"/>
           </a:xfrm>
           <a:prstGeom prst="roundRect">
             <a:avLst>
@@ -5843,13 +5992,13 @@
       </p:sp>
       <p:sp>
         <p:nvSpPr>
-          <p:cNvPr id="5" name="Text 3"/>
-          <p:cNvSpPr txBox="1"/>
-          <p:nvPr/>
-        </p:nvSpPr>
-        <p:spPr>
-          <a:xfrm>
-            <a:off x="822960" y="1828800"/>
+          <p:cNvPr id="7" name="Text 5"/>
+          <p:cNvSpPr txBox="1"/>
+          <p:nvPr/>
+        </p:nvSpPr>
+        <p:spPr>
+          <a:xfrm>
+            <a:off x="822960" y="2423160"/>
             <a:ext cx="2966618" cy="411480"/>
           </a:xfrm>
           <a:prstGeom prst="rect">
@@ -5879,14 +6028,14 @@
       </p:sp>
       <p:sp>
         <p:nvSpPr>
-          <p:cNvPr id="6" name="Text 4"/>
-          <p:cNvSpPr txBox="1"/>
-          <p:nvPr/>
-        </p:nvSpPr>
-        <p:spPr>
-          <a:xfrm>
-            <a:off x="822960" y="2377440"/>
-            <a:ext cx="3012338" cy="3657600"/>
+          <p:cNvPr id="8" name="Text 6"/>
+          <p:cNvSpPr txBox="1"/>
+          <p:nvPr/>
+        </p:nvSpPr>
+        <p:spPr>
+          <a:xfrm>
+            <a:off x="822960" y="2880360"/>
+            <a:ext cx="3012338" cy="3154680"/>
           </a:xfrm>
           <a:prstGeom prst="rect">
             <a:avLst/>
@@ -5991,14 +6140,14 @@
       </p:sp>
       <p:sp>
         <p:nvSpPr>
-          <p:cNvPr id="7" name="kompat2"/>
+          <p:cNvPr id="9" name="kompat2"/>
           <p:cNvSpPr/>
           <p:nvPr/>
         </p:nvSpPr>
         <p:spPr>
           <a:xfrm>
-            <a:off x="4338218" y="1645920"/>
-            <a:ext cx="3515258" cy="4023360"/>
+            <a:off x="4338218" y="2331720"/>
+            <a:ext cx="3515258" cy="3749040"/>
           </a:xfrm>
           <a:prstGeom prst="roundRect">
             <a:avLst>
@@ -6018,13 +6167,13 @@
       </p:sp>
       <p:sp>
         <p:nvSpPr>
-          <p:cNvPr id="8" name="Text 6"/>
-          <p:cNvSpPr txBox="1"/>
-          <p:nvPr/>
-        </p:nvSpPr>
-        <p:spPr>
-          <a:xfrm>
-            <a:off x="4612538" y="1828800"/>
+          <p:cNvPr id="10" name="Text 8"/>
+          <p:cNvSpPr txBox="1"/>
+          <p:nvPr/>
+        </p:nvSpPr>
+        <p:spPr>
+          <a:xfrm>
+            <a:off x="4612538" y="2423160"/>
             <a:ext cx="2966618" cy="411480"/>
           </a:xfrm>
           <a:prstGeom prst="rect">
@@ -6054,14 +6203,14 @@
       </p:sp>
       <p:sp>
         <p:nvSpPr>
-          <p:cNvPr id="9" name="Text 7"/>
-          <p:cNvSpPr txBox="1"/>
-          <p:nvPr/>
-        </p:nvSpPr>
-        <p:spPr>
-          <a:xfrm>
-            <a:off x="4612538" y="2377440"/>
-            <a:ext cx="3012338" cy="3657600"/>
+          <p:cNvPr id="11" name="Text 9"/>
+          <p:cNvSpPr txBox="1"/>
+          <p:nvPr/>
+        </p:nvSpPr>
+        <p:spPr>
+          <a:xfrm>
+            <a:off x="4612538" y="2880360"/>
+            <a:ext cx="3012338" cy="3154680"/>
           </a:xfrm>
           <a:prstGeom prst="rect">
             <a:avLst/>
@@ -6122,7 +6271,7 @@
                   <a:schemeClr val="bg1"/>
                 </a:solidFill>
               </a:rPr>
-              <a:t>Semboyan "Tarakan HIBOT": hibot berarti hebat dalam bahasa Tidung</a:t>
+              <a:t>Semboyan "Tarakan HIBOT" (hibot: hebat, bahasa Tidung)</a:t>
             </a:r>
             <a:endParaRPr lang="en-US" sz="1400" dirty="0"/>
           </a:p>
@@ -6130,14 +6279,14 @@
       </p:sp>
       <p:sp>
         <p:nvSpPr>
-          <p:cNvPr id="10" name="kompat3"/>
+          <p:cNvPr id="12" name="kompat3"/>
           <p:cNvSpPr/>
           <p:nvPr/>
         </p:nvSpPr>
         <p:spPr>
           <a:xfrm>
-            <a:off x="8127797" y="1645920"/>
-            <a:ext cx="3515258" cy="4023360"/>
+            <a:off x="8127797" y="2331720"/>
+            <a:ext cx="3515258" cy="3749040"/>
           </a:xfrm>
           <a:prstGeom prst="roundRect">
             <a:avLst>
@@ -6157,13 +6306,13 @@
       </p:sp>
       <p:sp>
         <p:nvSpPr>
-          <p:cNvPr id="11" name="Text 9"/>
-          <p:cNvSpPr txBox="1"/>
-          <p:nvPr/>
-        </p:nvSpPr>
-        <p:spPr>
-          <a:xfrm>
-            <a:off x="8402117" y="1828800"/>
+          <p:cNvPr id="13" name="Text 11"/>
+          <p:cNvSpPr txBox="1"/>
+          <p:nvPr/>
+        </p:nvSpPr>
+        <p:spPr>
+          <a:xfrm>
+            <a:off x="8402117" y="2423160"/>
             <a:ext cx="2966618" cy="411480"/>
           </a:xfrm>
           <a:prstGeom prst="rect">
@@ -6193,14 +6342,14 @@
       </p:sp>
       <p:sp>
         <p:nvSpPr>
-          <p:cNvPr id="12" name="Text 10"/>
-          <p:cNvSpPr txBox="1"/>
-          <p:nvPr/>
-        </p:nvSpPr>
-        <p:spPr>
-          <a:xfrm>
-            <a:off x="8402117" y="2377440"/>
-            <a:ext cx="3012338" cy="3657600"/>
+          <p:cNvPr id="14" name="Text 12"/>
+          <p:cNvSpPr txBox="1"/>
+          <p:nvPr/>
+        </p:nvSpPr>
+        <p:spPr>
+          <a:xfrm>
+            <a:off x="8402117" y="2880360"/>
+            <a:ext cx="3012338" cy="3154680"/>
           </a:xfrm>
           <a:prstGeom prst="rect">
             <a:avLst/>

</xml_diff>